<commit_message>
USA statistics QT2-QT4 rewritten in the validated style; rules updated; photo credits regenerated
Co-Authored-By: Claude Opus 5.5 <noreply@anthropic.com>
Claude-Session: https://claude.ai/code/session_0115LFSb2ktGLWPeVksFkSer
</commit_message>
<xml_diff>
--- a/lecons/USA/Practical Geography/11_USA_PRA_QT02_Data_Collection_Sources_and_Techniques.pptx
+++ b/lecons/USA/Practical Geography/11_USA_PRA_QT02_Data_Collection_Sources_and_Techniques.pptx
@@ -67,9 +67,12 @@
     <p:sldId id="315" r:id="rId61"/>
     <p:sldId id="316" r:id="rId62"/>
     <p:sldId id="317" r:id="rId63"/>
+    <p:sldId id="318" r:id="rId64"/>
+    <p:sldId id="319" r:id="rId65"/>
+    <p:sldId id="320" r:id="rId66"/>
   </p:sldIdLst>
   <p:notesMasterIdLst>
-    <p:notesMasterId r:id="rId64"/>
+    <p:notesMasterId r:id="rId67"/>
   </p:notesMasterIdLst>
   <p:sldSz cx="12192000" cy="6858000"/>
   <p:notesSz cx="6858000" cy="12192000"/>
@@ -3379,7 +3382,7 @@
           <a:p>
             <a:r>
               <a:rPr lang="en-US" dirty="0"/>
-              <a:t>Let us copy Sources of Geographical Data. Geographical data come from the following sources. Copy the point on Primary data on the left, then draw the diagram on the right: primary and secondary data. Give it a title and label it clearly.</a:t>
+              <a:t>Let us copy Sources of Geographical Data. Geographical data come from the following sources. Copy the point on Primary data on the left, then draw the diagram on the right: sources of data. Give it a title and label it clearly.</a:t>
             </a:r>
             <a:endParaRPr lang="en-US" dirty="0"/>
           </a:p>
@@ -3555,7 +3558,7 @@
           <a:p>
             <a:r>
               <a:rPr lang="en-US" dirty="0"/>
-              <a:t>We continue with Sources of Geographical Data. On this slide we have Example of primary data and Secondary data. Write each point on a new line, with the key term first, and explain it in your own words when we revise. When you finish, we go to the next slide.</a:t>
+              <a:t>We continue with Sources of Geographical Data. Copy the point on Value of primary data: write the key term first, then its explanation.</a:t>
             </a:r>
             <a:endParaRPr lang="en-US" dirty="0"/>
           </a:p>
@@ -3643,7 +3646,7 @@
           <a:p>
             <a:r>
               <a:rPr lang="en-US" dirty="0"/>
-              <a:t>We continue with Sources of Geographical Data. On this slide we have Sources of secondary data. Write each point on a new line, with the key term first, and explain it in your own words when we revise.</a:t>
+              <a:t>We continue with Sources of Geographical Data. Copy the point on Secondary data: write the key term first, then its explanation.</a:t>
             </a:r>
             <a:endParaRPr lang="en-US" dirty="0"/>
           </a:p>
@@ -3731,7 +3734,7 @@
           <a:p>
             <a:r>
               <a:rPr lang="en-US" dirty="0"/>
-              <a:t>Let us copy Basic Sampling Procedures. The basic sampling procedures are the following. Copy the point on Why sample on the left, then draw the diagram on the right: three sampling methods. Give it a title and label it clearly.</a:t>
+              <a:t>We continue with Sources of Geographical Data. Copy the point on Value of secondary data: write the key term first, then its explanation.</a:t>
             </a:r>
             <a:endParaRPr lang="en-US" dirty="0"/>
           </a:p>
@@ -3819,7 +3822,7 @@
           <a:p>
             <a:r>
               <a:rPr lang="en-US" dirty="0"/>
-              <a:t>We continue with Basic Sampling Procedures. On this slide we have Random sampling. Write each point on a new line, with the key term first, and explain it in your own words when we revise.</a:t>
+              <a:t>Let us copy Basic Sampling Procedures. Samples are chosen by the following procedures. Copy the point on Why sample on the left, then draw the diagram on the right: sampling methods. Give it a title and label it clearly.</a:t>
             </a:r>
             <a:endParaRPr lang="en-US" dirty="0"/>
           </a:p>
@@ -3907,7 +3910,7 @@
           <a:p>
             <a:r>
               <a:rPr lang="en-US" dirty="0"/>
-              <a:t>Copy the point on Systematic sampling on the left, then draw the diagram on the right: systematic sampling. Give it a title and label it clearly.</a:t>
+              <a:t>We continue with Basic Sampling Procedures. Copy the point on Random sampling: write the key term first, then its explanation.</a:t>
             </a:r>
             <a:endParaRPr lang="en-US" dirty="0"/>
           </a:p>
@@ -3995,7 +3998,7 @@
           <a:p>
             <a:r>
               <a:rPr lang="en-US" dirty="0"/>
-              <a:t>We continue with Basic Sampling Procedures. On this slide we have Stratified sampling. Write each point on a new line, with the key term first, and explain it in your own words when we revise.</a:t>
+              <a:t>Copy the point on Systematic sampling on the left, then draw the diagram on the right: systematic sampling. Give it a title and label it clearly.</a:t>
             </a:r>
             <a:endParaRPr lang="en-US" dirty="0"/>
           </a:p>
@@ -4083,7 +4086,7 @@
           <a:p>
             <a:r>
               <a:rPr lang="en-US" dirty="0"/>
-              <a:t>Let us copy Primary Data Collection Techniques. The main techniques of primary data collection are the following. Copy the point on Observation, counting and recording on the left, then draw the diagram on the right: collection techniques. Give it a title and label it clearly.</a:t>
+              <a:t>We continue with Basic Sampling Procedures. Copy the point on Stratified sampling: write the key term first, then its explanation.</a:t>
             </a:r>
             <a:endParaRPr lang="en-US" dirty="0"/>
           </a:p>
@@ -4171,7 +4174,7 @@
           <a:p>
             <a:r>
               <a:rPr lang="en-US" dirty="0"/>
-              <a:t>We continue with Primary Data Collection Techniques. On this slide we have Measurement. Write each point on a new line, with the key term first, and explain it in your own words when we revise.</a:t>
+              <a:t>Let us copy Observation, Recording and Measurement. Data are collected in the field with the following techniques. Copy the point on Observation, counting and recording of frequencies on the left, then draw the diagram on the right: data collection techniques. Give it a title and label it clearly.</a:t>
             </a:r>
             <a:endParaRPr lang="en-US" dirty="0"/>
           </a:p>
@@ -4259,7 +4262,7 @@
           <a:p>
             <a:r>
               <a:rPr lang="en-US" dirty="0"/>
-              <a:t>Copy the point on Questionnaires on the left, then draw the diagram on the right: good and bad questions. Give it a title and label it clearly.</a:t>
+              <a:t>We continue with Observation, Recording and Measurement. Copy the point on Pictures, filming and video recording: write the key term first, then its explanation.</a:t>
             </a:r>
             <a:endParaRPr lang="en-US" dirty="0"/>
           </a:p>
@@ -4347,7 +4350,7 @@
           <a:p>
             <a:r>
               <a:rPr lang="en-US" dirty="0"/>
-              <a:t>We continue with Primary Data Collection Techniques. On this slide we have Interviews and Focus group discussions. Write each point on a new line, with the key term first, and explain it in your own words when we revise.</a:t>
+              <a:t>We continue with Observation, Recording and Measurement. Copy the point on Measurement: write the key term first, then its explanation.</a:t>
             </a:r>
             <a:endParaRPr lang="en-US" dirty="0"/>
           </a:p>
@@ -4523,7 +4526,7 @@
           <a:p>
             <a:r>
               <a:rPr lang="en-US" dirty="0"/>
-              <a:t>Now let us check what you have understood. Question 1: Distinguish primary data from secondary data, with one example from Garoua for each. Answer in your exercise book.</a:t>
+              <a:t>Let us copy Questionnaires, Interviews and Focus Groups. Data are collected from people with the following techniques. Copy the point on Questionnaires on the left, then draw the diagram on the right: a questionnaire. Give it a title and label it clearly.</a:t>
             </a:r>
             <a:endParaRPr lang="en-US" dirty="0"/>
           </a:p>
@@ -4611,7 +4614,7 @@
           <a:p>
             <a:r>
               <a:rPr lang="en-US" dirty="0"/>
-              <a:t>The expected answer is: primary: collected by the researcher (counting motos at a crossroads); secondary: already published (BUCREP census figures). If you got it right, well done.</a:t>
+              <a:t>We continue with Questionnaires, Interviews and Focus Groups. Copy the point on Interviews: write the key term first, then its explanation.</a:t>
             </a:r>
             <a:endParaRPr lang="en-US" dirty="0"/>
           </a:p>
@@ -4699,7 +4702,7 @@
           <a:p>
             <a:r>
               <a:rPr lang="en-US" dirty="0"/>
-              <a:t>Now let us check what you have understood. Question 2: Explain how to select 30 people from a list of 600 by systematic sampling. Answer in your exercise book.</a:t>
+              <a:t>We continue with Questionnaires, Interviews and Focus Groups. Copy the point on Focus group discussions: write the key term first, then its explanation.</a:t>
             </a:r>
             <a:endParaRPr lang="en-US" dirty="0"/>
           </a:p>
@@ -4787,7 +4790,7 @@
           <a:p>
             <a:r>
               <a:rPr lang="en-US" dirty="0"/>
-              <a:t>The expected answer is: k = 600 ÷ 30 = 20; choose a random start between 1 and 20, then every 20th person. If you got it right, well done.</a:t>
+              <a:t>Now let us check what you have understood. Question 1: Distinguish primary data from secondary data, with one example from Garoua for each. Answer in your exercise book.</a:t>
             </a:r>
             <a:endParaRPr lang="en-US" dirty="0"/>
           </a:p>
@@ -4875,7 +4878,7 @@
           <a:p>
             <a:r>
               <a:rPr lang="en-US" dirty="0"/>
-              <a:t>Take your time to copy this part; we will continue together.</a:t>
+              <a:t>The expected answer is: primary: collected by the researcher (counting motos at a crossroads); secondary: already published (BUCREP census figures). If you got it right, well done.</a:t>
             </a:r>
             <a:endParaRPr lang="en-US" dirty="0"/>
           </a:p>
@@ -4963,7 +4966,7 @@
           <a:p>
             <a:r>
               <a:rPr lang="en-US" dirty="0"/>
-              <a:t>For those who need more practice, fill in the blanks in your exercise book. The answers are: number 1, primary; number 2, systematic; number 3, stratified.</a:t>
+              <a:t>Now let us check what you have understood. Question 2: Explain how to select 30 people from a list of 600 by systematic sampling. Answer in your exercise book.</a:t>
             </a:r>
             <a:endParaRPr lang="en-US" dirty="0"/>
           </a:p>
@@ -5051,7 +5054,7 @@
           <a:p>
             <a:r>
               <a:rPr lang="en-US" dirty="0"/>
-              <a:t>For your homework: Define the arithmetic mean. We shall correct it at the beginning of our next lesson.</a:t>
+              <a:t>The expected answer is: k = 600 ÷ 30 = 20; choose a random start between 1 and 20, then every 20th person. If you got it right, well done.</a:t>
             </a:r>
             <a:endParaRPr lang="en-US" dirty="0"/>
           </a:p>
@@ -5139,7 +5142,7 @@
           <a:p>
             <a:r>
               <a:rPr lang="en-US" dirty="0"/>
-              <a:t>Our next lesson will be on Quantitative Techniques 3 (Part 1): Measures of Central Tendency, Range and Quartiles. Thank you for your attention, and see you next time.</a:t>
+              <a:t>Take your time to copy this part; we will continue together.</a:t>
             </a:r>
             <a:endParaRPr lang="en-US" dirty="0"/>
           </a:p>
@@ -5227,7 +5230,7 @@
           <a:p>
             <a:r>
               <a:rPr lang="en-US" dirty="0"/>
-              <a:t>Let us play the bilingual game. I say a word in English, and you give me the French word. Then we do the reverse.</a:t>
+              <a:t>For those who need more practice, fill in the blanks in your exercise book. The answers are: number 1, primary; number 2, systematic; number 3, stratified.</a:t>
             </a:r>
             <a:endParaRPr lang="en-US" dirty="0"/>
           </a:p>
@@ -5315,7 +5318,7 @@
           <a:p>
             <a:r>
               <a:rPr lang="en-US" dirty="0"/>
-              <a:t>I record this information in the official logbook of the class after the lesson.</a:t>
+              <a:t>For your homework: Define the arithmetic mean. We shall correct it at the beginning of our next lesson.</a:t>
             </a:r>
             <a:endParaRPr lang="en-US" dirty="0"/>
           </a:p>
@@ -5491,7 +5494,7 @@
           <a:p>
             <a:r>
               <a:rPr lang="en-US" dirty="0"/>
-              <a:t>I complete the second page of the logbook: the matter taught, the evaluation, the homework and the attendance.</a:t>
+              <a:t>Our next lesson will be on Quantitative Techniques 3 (Part 1): Measures of Central Tendency, Range and Quartiles. Thank you for your attention, and see you next time.</a:t>
             </a:r>
             <a:endParaRPr lang="en-US" dirty="0"/>
           </a:p>
@@ -5579,7 +5582,7 @@
           <a:p>
             <a:r>
               <a:rPr lang="en-US" dirty="0"/>
-              <a:t>This slide is for me, the teacher: it gives the timing of the lesson and what to do if the projector is not available.</a:t>
+              <a:t>Let us play the bilingual game. I say a word in English, and you give me the French word. Then we do the reverse.</a:t>
             </a:r>
             <a:endParaRPr lang="en-US" dirty="0"/>
           </a:p>
@@ -5667,7 +5670,7 @@
           <a:p>
             <a:r>
               <a:rPr lang="en-US" dirty="0"/>
-              <a:t>These are the references and picture credits used to prepare this lesson.</a:t>
+              <a:t>I record this information in the official logbook of the class after the lesson.</a:t>
             </a:r>
             <a:endParaRPr lang="en-US" dirty="0"/>
           </a:p>
@@ -5691,6 +5694,270 @@
             <a:fld id="{F7021451-1387-4CA6-816F-3879F97B5CBC}" type="slidenum">
               <a:rPr lang="en-US"/>
               <a:t>62</a:t>
+            </a:fld>
+            <a:endParaRPr lang="en-US"/>
+          </a:p>
+        </p:txBody>
+      </p:sp>
+    </p:spTree>
+    <p:extLst>
+      <p:ext uri="{BB962C8B-B14F-4D97-AF65-F5344CB8AC3E}">
+        <p14:creationId xmlns:p14="http://schemas.microsoft.com/office/powerpoint/2010/main" val="1024086991"/>
+      </p:ext>
+    </p:extLst>
+  </p:cSld>
+  <p:clrMapOvr>
+    <a:masterClrMapping/>
+  </p:clrMapOvr>
+</p:notes>
+</file>
+
+<file path=ppt/notesSlides/notesSlide63.xml><?xml version="1.0" encoding="utf-8"?>
+<p:notes xmlns:a="http://schemas.openxmlformats.org/drawingml/2006/main" xmlns:r="http://schemas.openxmlformats.org/officeDocument/2006/relationships" xmlns:p="http://schemas.openxmlformats.org/presentationml/2006/main">
+  <p:cSld>
+    <p:spTree>
+      <p:nvGrpSpPr>
+        <p:cNvPr id="1" name=""/>
+        <p:cNvGrpSpPr/>
+        <p:nvPr/>
+      </p:nvGrpSpPr>
+      <p:grpSpPr>
+        <a:xfrm>
+          <a:off x="0" y="0"/>
+          <a:ext cx="0" cy="0"/>
+          <a:chOff x="0" y="0"/>
+          <a:chExt cx="0" cy="0"/>
+        </a:xfrm>
+      </p:grpSpPr>
+      <p:sp>
+        <p:nvSpPr>
+          <p:cNvPr id="2" name="Slide Image Placeholder 1"/>
+          <p:cNvSpPr>
+            <a:spLocks noGrp="1" noRot="1" noChangeAspect="1"/>
+          </p:cNvSpPr>
+          <p:nvPr>
+            <p:ph type="sldImg"/>
+          </p:nvPr>
+        </p:nvSpPr>
+        <p:spPr/>
+      </p:sp>
+      <p:sp>
+        <p:nvSpPr>
+          <p:cNvPr id="3" name="Notes Placeholder 2"/>
+          <p:cNvSpPr>
+            <a:spLocks noGrp="1"/>
+          </p:cNvSpPr>
+          <p:nvPr>
+            <p:ph type="body" idx="1"/>
+          </p:nvPr>
+        </p:nvSpPr>
+        <p:spPr/>
+        <p:txBody>
+          <a:bodyPr/>
+          <a:lstStyle/>
+          <a:p>
+            <a:r>
+              <a:rPr lang="en-US" dirty="0"/>
+              <a:t>I complete the second page of the logbook: the matter taught, the evaluation, the homework and the attendance.</a:t>
+            </a:r>
+            <a:endParaRPr lang="en-US" dirty="0"/>
+          </a:p>
+        </p:txBody>
+      </p:sp>
+      <p:sp>
+        <p:nvSpPr>
+          <p:cNvPr id="4" name="Slide Number Placeholder 3"/>
+          <p:cNvSpPr>
+            <a:spLocks noGrp="1"/>
+          </p:cNvSpPr>
+          <p:nvPr>
+            <p:ph type="sldNum" sz="quarter" idx="10"/>
+          </p:nvPr>
+        </p:nvSpPr>
+        <p:spPr/>
+        <p:txBody>
+          <a:bodyPr/>
+          <a:lstStyle/>
+          <a:p>
+            <a:fld id="{F7021451-1387-4CA6-816F-3879F97B5CBC}" type="slidenum">
+              <a:rPr lang="en-US"/>
+              <a:t>63</a:t>
+            </a:fld>
+            <a:endParaRPr lang="en-US"/>
+          </a:p>
+        </p:txBody>
+      </p:sp>
+    </p:spTree>
+    <p:extLst>
+      <p:ext uri="{BB962C8B-B14F-4D97-AF65-F5344CB8AC3E}">
+        <p14:creationId xmlns:p14="http://schemas.microsoft.com/office/powerpoint/2010/main" val="1024086991"/>
+      </p:ext>
+    </p:extLst>
+  </p:cSld>
+  <p:clrMapOvr>
+    <a:masterClrMapping/>
+  </p:clrMapOvr>
+</p:notes>
+</file>
+
+<file path=ppt/notesSlides/notesSlide64.xml><?xml version="1.0" encoding="utf-8"?>
+<p:notes xmlns:a="http://schemas.openxmlformats.org/drawingml/2006/main" xmlns:r="http://schemas.openxmlformats.org/officeDocument/2006/relationships" xmlns:p="http://schemas.openxmlformats.org/presentationml/2006/main">
+  <p:cSld>
+    <p:spTree>
+      <p:nvGrpSpPr>
+        <p:cNvPr id="1" name=""/>
+        <p:cNvGrpSpPr/>
+        <p:nvPr/>
+      </p:nvGrpSpPr>
+      <p:grpSpPr>
+        <a:xfrm>
+          <a:off x="0" y="0"/>
+          <a:ext cx="0" cy="0"/>
+          <a:chOff x="0" y="0"/>
+          <a:chExt cx="0" cy="0"/>
+        </a:xfrm>
+      </p:grpSpPr>
+      <p:sp>
+        <p:nvSpPr>
+          <p:cNvPr id="2" name="Slide Image Placeholder 1"/>
+          <p:cNvSpPr>
+            <a:spLocks noGrp="1" noRot="1" noChangeAspect="1"/>
+          </p:cNvSpPr>
+          <p:nvPr>
+            <p:ph type="sldImg"/>
+          </p:nvPr>
+        </p:nvSpPr>
+        <p:spPr/>
+      </p:sp>
+      <p:sp>
+        <p:nvSpPr>
+          <p:cNvPr id="3" name="Notes Placeholder 2"/>
+          <p:cNvSpPr>
+            <a:spLocks noGrp="1"/>
+          </p:cNvSpPr>
+          <p:nvPr>
+            <p:ph type="body" idx="1"/>
+          </p:nvPr>
+        </p:nvSpPr>
+        <p:spPr/>
+        <p:txBody>
+          <a:bodyPr/>
+          <a:lstStyle/>
+          <a:p>
+            <a:r>
+              <a:rPr lang="en-US" dirty="0"/>
+              <a:t>This slide is for me, the teacher: it gives the timing of the lesson and what to do if the projector is not available.</a:t>
+            </a:r>
+            <a:endParaRPr lang="en-US" dirty="0"/>
+          </a:p>
+        </p:txBody>
+      </p:sp>
+      <p:sp>
+        <p:nvSpPr>
+          <p:cNvPr id="4" name="Slide Number Placeholder 3"/>
+          <p:cNvSpPr>
+            <a:spLocks noGrp="1"/>
+          </p:cNvSpPr>
+          <p:nvPr>
+            <p:ph type="sldNum" sz="quarter" idx="10"/>
+          </p:nvPr>
+        </p:nvSpPr>
+        <p:spPr/>
+        <p:txBody>
+          <a:bodyPr/>
+          <a:lstStyle/>
+          <a:p>
+            <a:fld id="{F7021451-1387-4CA6-816F-3879F97B5CBC}" type="slidenum">
+              <a:rPr lang="en-US"/>
+              <a:t>64</a:t>
+            </a:fld>
+            <a:endParaRPr lang="en-US"/>
+          </a:p>
+        </p:txBody>
+      </p:sp>
+    </p:spTree>
+    <p:extLst>
+      <p:ext uri="{BB962C8B-B14F-4D97-AF65-F5344CB8AC3E}">
+        <p14:creationId xmlns:p14="http://schemas.microsoft.com/office/powerpoint/2010/main" val="1024086991"/>
+      </p:ext>
+    </p:extLst>
+  </p:cSld>
+  <p:clrMapOvr>
+    <a:masterClrMapping/>
+  </p:clrMapOvr>
+</p:notes>
+</file>
+
+<file path=ppt/notesSlides/notesSlide65.xml><?xml version="1.0" encoding="utf-8"?>
+<p:notes xmlns:a="http://schemas.openxmlformats.org/drawingml/2006/main" xmlns:r="http://schemas.openxmlformats.org/officeDocument/2006/relationships" xmlns:p="http://schemas.openxmlformats.org/presentationml/2006/main">
+  <p:cSld>
+    <p:spTree>
+      <p:nvGrpSpPr>
+        <p:cNvPr id="1" name=""/>
+        <p:cNvGrpSpPr/>
+        <p:nvPr/>
+      </p:nvGrpSpPr>
+      <p:grpSpPr>
+        <a:xfrm>
+          <a:off x="0" y="0"/>
+          <a:ext cx="0" cy="0"/>
+          <a:chOff x="0" y="0"/>
+          <a:chExt cx="0" cy="0"/>
+        </a:xfrm>
+      </p:grpSpPr>
+      <p:sp>
+        <p:nvSpPr>
+          <p:cNvPr id="2" name="Slide Image Placeholder 1"/>
+          <p:cNvSpPr>
+            <a:spLocks noGrp="1" noRot="1" noChangeAspect="1"/>
+          </p:cNvSpPr>
+          <p:nvPr>
+            <p:ph type="sldImg"/>
+          </p:nvPr>
+        </p:nvSpPr>
+        <p:spPr/>
+      </p:sp>
+      <p:sp>
+        <p:nvSpPr>
+          <p:cNvPr id="3" name="Notes Placeholder 2"/>
+          <p:cNvSpPr>
+            <a:spLocks noGrp="1"/>
+          </p:cNvSpPr>
+          <p:nvPr>
+            <p:ph type="body" idx="1"/>
+          </p:nvPr>
+        </p:nvSpPr>
+        <p:spPr/>
+        <p:txBody>
+          <a:bodyPr/>
+          <a:lstStyle/>
+          <a:p>
+            <a:r>
+              <a:rPr lang="en-US" dirty="0"/>
+              <a:t>These are the references and picture credits used to prepare this lesson.</a:t>
+            </a:r>
+            <a:endParaRPr lang="en-US" dirty="0"/>
+          </a:p>
+        </p:txBody>
+      </p:sp>
+      <p:sp>
+        <p:nvSpPr>
+          <p:cNvPr id="4" name="Slide Number Placeholder 3"/>
+          <p:cNvSpPr>
+            <a:spLocks noGrp="1"/>
+          </p:cNvSpPr>
+          <p:nvPr>
+            <p:ph type="sldNum" sz="quarter" idx="10"/>
+          </p:nvPr>
+        </p:nvSpPr>
+        <p:spPr/>
+        <p:txBody>
+          <a:bodyPr/>
+          <a:lstStyle/>
+          <a:p>
+            <a:fld id="{F7021451-1387-4CA6-816F-3879F97B5CBC}" type="slidenum">
+              <a:rPr lang="en-US"/>
+              <a:t>65</a:t>
             </a:fld>
             <a:endParaRPr lang="en-US"/>
           </a:p>
@@ -15499,7 +15766,7 @@
         <p:spPr>
           <a:xfrm>
             <a:off x="365760" y="1783080"/>
-            <a:ext cx="4846320" cy="4617720"/>
+            <a:ext cx="6035040" cy="4617720"/>
           </a:xfrm>
           <a:prstGeom prst="rect">
             <a:avLst/>
@@ -15518,7 +15785,7 @@
               <a:buNone/>
             </a:pPr>
             <a:r>
-              <a:rPr lang="en-US" sz="3200" i="1" dirty="0">
+              <a:rPr lang="en-US" sz="3000" i="1" dirty="0">
                 <a:solidFill>
                   <a:srgbClr val="111111"/>
                 </a:solidFill>
@@ -15528,7 +15795,7 @@
               </a:rPr>
               <a:t>Geographical data come from the following sources:</a:t>
             </a:r>
-            <a:endParaRPr lang="en-US" sz="3200" dirty="0"/>
+            <a:endParaRPr lang="en-US" sz="3000" dirty="0"/>
           </a:p>
           <a:p>
             <a:pPr algn="l" indent="0" marL="0">
@@ -15538,7 +15805,7 @@
               <a:buNone/>
             </a:pPr>
             <a:r>
-              <a:rPr lang="en-US" sz="3200" b="1" dirty="0">
+              <a:rPr lang="en-US" sz="3000" b="1" dirty="0">
                 <a:solidFill>
                   <a:srgbClr val="111111"/>
                 </a:solidFill>
@@ -15555,7 +15822,7 @@
               <a:buNone/>
             </a:pPr>
             <a:r>
-              <a:rPr lang="en-US" sz="3200" dirty="0">
+              <a:rPr lang="en-US" sz="3000" dirty="0">
                 <a:solidFill>
                   <a:srgbClr val="111111"/>
                 </a:solidFill>
@@ -15563,9 +15830,9 @@
                 <a:ea typeface="Times New Roman" pitchFamily="34" charset="-122"/>
                 <a:cs typeface="Times New Roman" pitchFamily="34" charset="-120"/>
               </a:rPr>
-              <a:t>They are original, up to date and specific, collected by fieldwork, observation, measurement, interviews and questionnaires.</a:t>
-            </a:r>
-            <a:endParaRPr lang="en-US" sz="3200" dirty="0"/>
+              <a:t>Primary data are collected by the researcher himself through fieldwork, observation, measurement, interviews and questionnaires. For example, a student measures the temperature of the Benue with a thermometer.</a:t>
+            </a:r>
+            <a:endParaRPr lang="en-US" sz="3000" dirty="0"/>
           </a:p>
         </p:txBody>
       </p:sp>
@@ -15585,8 +15852,8 @@
         </p:blipFill>
         <p:spPr>
           <a:xfrm>
-            <a:off x="5349240" y="2617506"/>
-            <a:ext cx="6659575" cy="2601397"/>
+            <a:off x="6537960" y="2849678"/>
+            <a:ext cx="5470855" cy="2137053"/>
           </a:xfrm>
           <a:prstGeom prst="rect">
             <a:avLst/>
@@ -15601,8 +15868,8 @@
         </p:nvSpPr>
         <p:spPr>
           <a:xfrm>
-            <a:off x="5349240" y="6089904"/>
-            <a:ext cx="6659575" cy="347472"/>
+            <a:off x="6537960" y="6089904"/>
+            <a:ext cx="5470855" cy="347472"/>
           </a:xfrm>
           <a:prstGeom prst="rect">
             <a:avLst/>
@@ -15626,7 +15893,7 @@
                 <a:ea typeface="Times New Roman" pitchFamily="34" charset="-122"/>
                 <a:cs typeface="Times New Roman" pitchFamily="34" charset="-120"/>
               </a:rPr>
-              <a:t>Illustration: primary and secondary data</a:t>
+              <a:t>Illustration: sources of data</a:t>
             </a:r>
             <a:endParaRPr lang="en-US" sz="1600" dirty="0"/>
           </a:p>
@@ -16000,7 +16267,7 @@
         <p:spPr>
           <a:xfrm>
             <a:off x="0" y="658368"/>
-            <a:ext cx="3840480" cy="5833872"/>
+            <a:ext cx="5120640" cy="5833872"/>
           </a:xfrm>
           <a:prstGeom prst="rect">
             <a:avLst/>
@@ -16015,8 +16282,8 @@
         </p:nvSpPr>
         <p:spPr>
           <a:xfrm>
-            <a:off x="4069080" y="1005840"/>
-            <a:ext cx="7802575" cy="731520"/>
+            <a:off x="5349240" y="1005840"/>
+            <a:ext cx="6522415" cy="731520"/>
           </a:xfrm>
           <a:prstGeom prst="rect">
             <a:avLst/>
@@ -16056,8 +16323,8 @@
         </p:nvSpPr>
         <p:spPr>
           <a:xfrm>
-            <a:off x="4069080" y="1783080"/>
-            <a:ext cx="7802575" cy="4663440"/>
+            <a:off x="5349240" y="1783080"/>
+            <a:ext cx="6522415" cy="4663440"/>
           </a:xfrm>
           <a:prstGeom prst="rect">
             <a:avLst/>
@@ -16084,7 +16351,7 @@
                 <a:ea typeface="Times New Roman" pitchFamily="34" charset="-122"/>
                 <a:cs typeface="Times New Roman" pitchFamily="34" charset="-120"/>
               </a:rPr>
-              <a:t>Example of primary data: </a:t>
+              <a:t>Value of primary data: </a:t>
             </a:r>
             <a:pPr algn="l" indent="0" marL="0">
               <a:spcAft>
@@ -16101,44 +16368,7 @@
                 <a:ea typeface="Times New Roman" pitchFamily="34" charset="-122"/>
                 <a:cs typeface="Times New Roman" pitchFamily="34" charset="-120"/>
               </a:rPr>
-              <a:t>Measuring the temperature of the Benue with a thermometer.</a:t>
-            </a:r>
-            <a:endParaRPr lang="en-US" sz="4000" dirty="0"/>
-          </a:p>
-          <a:p>
-            <a:pPr algn="l" indent="0" marL="0">
-              <a:spcAft>
-                <a:spcPts val="800"/>
-              </a:spcAft>
-              <a:buNone/>
-            </a:pPr>
-            <a:r>
-              <a:rPr lang="en-US" sz="4000" b="1" dirty="0">
-                <a:solidFill>
-                  <a:srgbClr val="111111"/>
-                </a:solidFill>
-                <a:latin typeface="Times New Roman" pitchFamily="34" charset="0"/>
-                <a:ea typeface="Times New Roman" pitchFamily="34" charset="-122"/>
-                <a:cs typeface="Times New Roman" pitchFamily="34" charset="-120"/>
-              </a:rPr>
-              <a:t>Secondary data: </a:t>
-            </a:r>
-            <a:pPr algn="l" indent="0" marL="0">
-              <a:spcAft>
-                <a:spcPts val="800"/>
-              </a:spcAft>
-              <a:buNone/>
-            </a:pPr>
-            <a:r>
-              <a:rPr lang="en-US" sz="4000" dirty="0">
-                <a:solidFill>
-                  <a:srgbClr val="111111"/>
-                </a:solidFill>
-                <a:latin typeface="Times New Roman" pitchFamily="34" charset="0"/>
-                <a:ea typeface="Times New Roman" pitchFamily="34" charset="-122"/>
-                <a:cs typeface="Times New Roman" pitchFamily="34" charset="-120"/>
-              </a:rPr>
-              <a:t>They already exist and are cheap and quick to obtain, but may be outdated or not fit the study.</a:t>
+              <a:t>They are original, up to date and fit the purpose of the study exactly. However, they take time and money to collect.</a:t>
             </a:r>
             <a:endParaRPr lang="en-US" sz="4000" dirty="0"/>
           </a:p>
@@ -16273,7 +16503,7 @@
         <p:spPr>
           <a:xfrm>
             <a:off x="0" y="658368"/>
-            <a:ext cx="5120640" cy="5833872"/>
+            <a:ext cx="2468880" cy="5833872"/>
           </a:xfrm>
           <a:prstGeom prst="rect">
             <a:avLst/>
@@ -16288,8 +16518,8 @@
         </p:nvSpPr>
         <p:spPr>
           <a:xfrm>
-            <a:off x="5349240" y="1005840"/>
-            <a:ext cx="6522415" cy="731520"/>
+            <a:off x="2697480" y="1005840"/>
+            <a:ext cx="9174175" cy="731520"/>
           </a:xfrm>
           <a:prstGeom prst="rect">
             <a:avLst/>
@@ -16315,7 +16545,7 @@
                 <a:ea typeface="Times New Roman" pitchFamily="34" charset="-122"/>
                 <a:cs typeface="Times New Roman" pitchFamily="34" charset="-120"/>
               </a:rPr>
-              <a:t>1. Sources of Geographical Data (continued)</a:t>
+              <a:t>1. Sources of Geographical Data</a:t>
             </a:r>
             <a:endParaRPr lang="en-US" sz="3600" dirty="0"/>
           </a:p>
@@ -16329,8 +16559,8 @@
         </p:nvSpPr>
         <p:spPr>
           <a:xfrm>
-            <a:off x="5349240" y="1783080"/>
-            <a:ext cx="6522415" cy="4663440"/>
+            <a:off x="2697480" y="1783080"/>
+            <a:ext cx="9174175" cy="4663440"/>
           </a:xfrm>
           <a:prstGeom prst="rect">
             <a:avLst/>
@@ -16357,7 +16587,7 @@
                 <a:ea typeface="Times New Roman" pitchFamily="34" charset="-122"/>
                 <a:cs typeface="Times New Roman" pitchFamily="34" charset="-120"/>
               </a:rPr>
-              <a:t>Sources of secondary data: </a:t>
+              <a:t>Secondary data: </a:t>
             </a:r>
             <a:pPr algn="l" indent="0" marL="0">
               <a:spcAft>
@@ -16374,7 +16604,7 @@
                 <a:ea typeface="Times New Roman" pitchFamily="34" charset="-122"/>
                 <a:cs typeface="Times New Roman" pitchFamily="34" charset="-120"/>
               </a:rPr>
-              <a:t>Books, BUCREP census reports, INS statistics, Cameroon Tribune, maps, websites and reports of the Ministry of Agriculture on cotton production.</a:t>
+              <a:t>Secondary data already exist in books, BUCREP census reports, INS statistics, newspapers such as Cameroon Tribune, maps and websites. Reports of the Ministry of Agriculture on cotton production are an example.</a:t>
             </a:r>
             <a:endParaRPr lang="en-US" sz="4000" dirty="0"/>
           </a:p>
@@ -16492,129 +16722,9 @@
           </a:p>
         </p:txBody>
       </p:sp>
-      <p:sp>
-        <p:nvSpPr>
-          <p:cNvPr id="3" name="Text 1"/>
-          <p:cNvSpPr/>
-          <p:nvPr/>
-        </p:nvSpPr>
-        <p:spPr>
-          <a:xfrm>
-            <a:off x="365760" y="1005840"/>
-            <a:ext cx="11460175" cy="731520"/>
-          </a:xfrm>
-          <a:prstGeom prst="rect">
-            <a:avLst/>
-          </a:prstGeom>
-          <a:noFill/>
-          <a:ln/>
-        </p:spPr>
-        <p:txBody>
-          <a:bodyPr wrap="square" lIns="0" tIns="0" rIns="0" bIns="0" rtlCol="0" anchor="ctr">
-            <a:normAutofit/>
-          </a:bodyPr>
-          <a:lstStyle/>
-          <a:p>
-            <a:pPr algn="ctr" indent="0" marL="0">
-              <a:buNone/>
-            </a:pPr>
-            <a:r>
-              <a:rPr lang="en-US" sz="3600" b="1" dirty="0">
-                <a:solidFill>
-                  <a:srgbClr val="990011"/>
-                </a:solidFill>
-                <a:latin typeface="Times New Roman" pitchFamily="34" charset="0"/>
-                <a:ea typeface="Times New Roman" pitchFamily="34" charset="-122"/>
-                <a:cs typeface="Times New Roman" pitchFamily="34" charset="-120"/>
-              </a:rPr>
-              <a:t>2. Basic Sampling Procedures</a:t>
-            </a:r>
-            <a:endParaRPr lang="en-US" sz="3600" dirty="0"/>
-          </a:p>
-        </p:txBody>
-      </p:sp>
-      <p:sp>
-        <p:nvSpPr>
-          <p:cNvPr id="4" name="Text 2"/>
-          <p:cNvSpPr/>
-          <p:nvPr/>
-        </p:nvSpPr>
-        <p:spPr>
-          <a:xfrm>
-            <a:off x="365760" y="1783080"/>
-            <a:ext cx="4846320" cy="4617720"/>
-          </a:xfrm>
-          <a:prstGeom prst="rect">
-            <a:avLst/>
-          </a:prstGeom>
-          <a:noFill/>
-          <a:ln/>
-        </p:spPr>
-        <p:txBody>
-          <a:bodyPr wrap="square" lIns="0" tIns="0" rIns="0" bIns="0" rtlCol="0" anchor="t"/>
-          <a:lstStyle/>
-          <a:p>
-            <a:pPr algn="l" indent="0" marL="0">
-              <a:spcAft>
-                <a:spcPts val="800"/>
-              </a:spcAft>
-              <a:buNone/>
-            </a:pPr>
-            <a:r>
-              <a:rPr lang="en-US" sz="3600" i="1" dirty="0">
-                <a:solidFill>
-                  <a:srgbClr val="111111"/>
-                </a:solidFill>
-                <a:latin typeface="Times New Roman" pitchFamily="34" charset="0"/>
-                <a:ea typeface="Times New Roman" pitchFamily="34" charset="-122"/>
-                <a:cs typeface="Times New Roman" pitchFamily="34" charset="-120"/>
-              </a:rPr>
-              <a:t>The basic sampling procedures are the following:</a:t>
-            </a:r>
-            <a:endParaRPr lang="en-US" sz="3600" dirty="0"/>
-          </a:p>
-          <a:p>
-            <a:pPr algn="l" indent="0" marL="0">
-              <a:spcAft>
-                <a:spcPts val="800"/>
-              </a:spcAft>
-              <a:buNone/>
-            </a:pPr>
-            <a:r>
-              <a:rPr lang="en-US" sz="3600" b="1" dirty="0">
-                <a:solidFill>
-                  <a:srgbClr val="111111"/>
-                </a:solidFill>
-                <a:latin typeface="Times New Roman" pitchFamily="34" charset="0"/>
-                <a:ea typeface="Times New Roman" pitchFamily="34" charset="-122"/>
-                <a:cs typeface="Times New Roman" pitchFamily="34" charset="-120"/>
-              </a:rPr>
-              <a:t>Why sample: </a:t>
-            </a:r>
-            <a:pPr algn="l" indent="0" marL="0">
-              <a:spcAft>
-                <a:spcPts val="800"/>
-              </a:spcAft>
-              <a:buNone/>
-            </a:pPr>
-            <a:r>
-              <a:rPr lang="en-US" sz="3600" dirty="0">
-                <a:solidFill>
-                  <a:srgbClr val="111111"/>
-                </a:solidFill>
-                <a:latin typeface="Times New Roman" pitchFamily="34" charset="0"/>
-                <a:ea typeface="Times New Roman" pitchFamily="34" charset="-122"/>
-                <a:cs typeface="Times New Roman" pitchFamily="34" charset="-120"/>
-              </a:rPr>
-              <a:t>It is often impossible, too slow or too costly to study the whole population.</a:t>
-            </a:r>
-            <a:endParaRPr lang="en-US" sz="3600" dirty="0"/>
-          </a:p>
-        </p:txBody>
-      </p:sp>
       <p:pic>
         <p:nvPicPr>
-          <p:cNvPr id="5" name="Image 0" descr="/home/claude/f4/img/v2/sampling_big.png">    </p:cNvPr>
+          <p:cNvPr id="3" name="Image 0" descr="/home/claude/f4/img/minesec_sheet.png">    </p:cNvPr>
           <p:cNvPicPr>
             <a:picLocks noChangeAspect="1"/>
           </p:cNvPicPr>
@@ -16628,8 +16738,8 @@
         </p:blipFill>
         <p:spPr>
           <a:xfrm>
-            <a:off x="5349240" y="2617506"/>
-            <a:ext cx="6659575" cy="2601397"/>
+            <a:off x="0" y="658368"/>
+            <a:ext cx="5120640" cy="5833872"/>
           </a:xfrm>
           <a:prstGeom prst="rect">
             <a:avLst/>
@@ -16638,14 +16748,14 @@
       </p:pic>
       <p:sp>
         <p:nvSpPr>
-          <p:cNvPr id="6" name="Text 3"/>
+          <p:cNvPr id="4" name="Text 1"/>
           <p:cNvSpPr/>
           <p:nvPr/>
         </p:nvSpPr>
         <p:spPr>
           <a:xfrm>
-            <a:off x="5349240" y="6089904"/>
-            <a:ext cx="6659575" cy="347472"/>
+            <a:off x="5349240" y="1005840"/>
+            <a:ext cx="6522415" cy="731520"/>
           </a:xfrm>
           <a:prstGeom prst="rect">
             <a:avLst/>
@@ -16654,24 +16764,85 @@
           <a:ln/>
         </p:spPr>
         <p:txBody>
-          <a:bodyPr wrap="square" lIns="0" tIns="0" rIns="0" bIns="0" rtlCol="0" anchor="ctr"/>
+          <a:bodyPr wrap="square" lIns="0" tIns="0" rIns="0" bIns="0" rtlCol="0" anchor="ctr">
+            <a:normAutofit/>
+          </a:bodyPr>
           <a:lstStyle/>
           <a:p>
             <a:pPr algn="ctr" indent="0" marL="0">
               <a:buNone/>
             </a:pPr>
             <a:r>
-              <a:rPr lang="en-US" sz="1600" i="1" dirty="0">
-                <a:solidFill>
-                  <a:srgbClr val="555555"/>
+              <a:rPr lang="en-US" sz="3600" b="1" dirty="0">
+                <a:solidFill>
+                  <a:srgbClr val="990011"/>
                 </a:solidFill>
                 <a:latin typeface="Times New Roman" pitchFamily="34" charset="0"/>
                 <a:ea typeface="Times New Roman" pitchFamily="34" charset="-122"/>
                 <a:cs typeface="Times New Roman" pitchFamily="34" charset="-120"/>
               </a:rPr>
-              <a:t>Illustration: three sampling methods</a:t>
-            </a:r>
-            <a:endParaRPr lang="en-US" sz="1600" dirty="0"/>
+              <a:t>1. Sources of Geographical Data</a:t>
+            </a:r>
+            <a:endParaRPr lang="en-US" sz="3600" dirty="0"/>
+          </a:p>
+        </p:txBody>
+      </p:sp>
+      <p:sp>
+        <p:nvSpPr>
+          <p:cNvPr id="5" name="Text 2"/>
+          <p:cNvSpPr/>
+          <p:nvPr/>
+        </p:nvSpPr>
+        <p:spPr>
+          <a:xfrm>
+            <a:off x="5349240" y="1783080"/>
+            <a:ext cx="6522415" cy="4663440"/>
+          </a:xfrm>
+          <a:prstGeom prst="rect">
+            <a:avLst/>
+          </a:prstGeom>
+          <a:noFill/>
+          <a:ln/>
+        </p:spPr>
+        <p:txBody>
+          <a:bodyPr wrap="square" lIns="0" tIns="0" rIns="0" bIns="0" rtlCol="0" anchor="t"/>
+          <a:lstStyle/>
+          <a:p>
+            <a:pPr algn="l" indent="0" marL="0">
+              <a:spcAft>
+                <a:spcPts val="800"/>
+              </a:spcAft>
+              <a:buNone/>
+            </a:pPr>
+            <a:r>
+              <a:rPr lang="en-US" sz="4000" b="1" dirty="0">
+                <a:solidFill>
+                  <a:srgbClr val="111111"/>
+                </a:solidFill>
+                <a:latin typeface="Times New Roman" pitchFamily="34" charset="0"/>
+                <a:ea typeface="Times New Roman" pitchFamily="34" charset="-122"/>
+                <a:cs typeface="Times New Roman" pitchFamily="34" charset="-120"/>
+              </a:rPr>
+              <a:t>Value of secondary data: </a:t>
+            </a:r>
+            <a:pPr algn="l" indent="0" marL="0">
+              <a:spcAft>
+                <a:spcPts val="800"/>
+              </a:spcAft>
+              <a:buNone/>
+            </a:pPr>
+            <a:r>
+              <a:rPr lang="en-US" sz="4000" dirty="0">
+                <a:solidFill>
+                  <a:srgbClr val="111111"/>
+                </a:solidFill>
+                <a:latin typeface="Times New Roman" pitchFamily="34" charset="0"/>
+                <a:ea typeface="Times New Roman" pitchFamily="34" charset="-122"/>
+                <a:cs typeface="Times New Roman" pitchFamily="34" charset="-120"/>
+              </a:rPr>
+              <a:t>They are cheap and quick to obtain and often cover large areas and long periods. However, they may be outdated or collected for another purpose.</a:t>
+            </a:r>
+            <a:endParaRPr lang="en-US" sz="4000" dirty="0"/>
           </a:p>
         </p:txBody>
       </p:sp>
@@ -16787,9 +16958,129 @@
           </a:p>
         </p:txBody>
       </p:sp>
+      <p:sp>
+        <p:nvSpPr>
+          <p:cNvPr id="3" name="Text 1"/>
+          <p:cNvSpPr/>
+          <p:nvPr/>
+        </p:nvSpPr>
+        <p:spPr>
+          <a:xfrm>
+            <a:off x="365760" y="1005840"/>
+            <a:ext cx="11460175" cy="731520"/>
+          </a:xfrm>
+          <a:prstGeom prst="rect">
+            <a:avLst/>
+          </a:prstGeom>
+          <a:noFill/>
+          <a:ln/>
+        </p:spPr>
+        <p:txBody>
+          <a:bodyPr wrap="square" lIns="0" tIns="0" rIns="0" bIns="0" rtlCol="0" anchor="ctr">
+            <a:normAutofit/>
+          </a:bodyPr>
+          <a:lstStyle/>
+          <a:p>
+            <a:pPr algn="ctr" indent="0" marL="0">
+              <a:buNone/>
+            </a:pPr>
+            <a:r>
+              <a:rPr lang="en-US" sz="3600" b="1" dirty="0">
+                <a:solidFill>
+                  <a:srgbClr val="990011"/>
+                </a:solidFill>
+                <a:latin typeface="Times New Roman" pitchFamily="34" charset="0"/>
+                <a:ea typeface="Times New Roman" pitchFamily="34" charset="-122"/>
+                <a:cs typeface="Times New Roman" pitchFamily="34" charset="-120"/>
+              </a:rPr>
+              <a:t>2. Basic Sampling Procedures</a:t>
+            </a:r>
+            <a:endParaRPr lang="en-US" sz="3600" dirty="0"/>
+          </a:p>
+        </p:txBody>
+      </p:sp>
+      <p:sp>
+        <p:nvSpPr>
+          <p:cNvPr id="4" name="Text 2"/>
+          <p:cNvSpPr/>
+          <p:nvPr/>
+        </p:nvSpPr>
+        <p:spPr>
+          <a:xfrm>
+            <a:off x="365760" y="1783080"/>
+            <a:ext cx="6035040" cy="4617720"/>
+          </a:xfrm>
+          <a:prstGeom prst="rect">
+            <a:avLst/>
+          </a:prstGeom>
+          <a:noFill/>
+          <a:ln/>
+        </p:spPr>
+        <p:txBody>
+          <a:bodyPr wrap="square" lIns="0" tIns="0" rIns="0" bIns="0" rtlCol="0" anchor="t"/>
+          <a:lstStyle/>
+          <a:p>
+            <a:pPr algn="l" indent="0" marL="0">
+              <a:spcAft>
+                <a:spcPts val="800"/>
+              </a:spcAft>
+              <a:buNone/>
+            </a:pPr>
+            <a:r>
+              <a:rPr lang="en-US" sz="3400" i="1" dirty="0">
+                <a:solidFill>
+                  <a:srgbClr val="111111"/>
+                </a:solidFill>
+                <a:latin typeface="Times New Roman" pitchFamily="34" charset="0"/>
+                <a:ea typeface="Times New Roman" pitchFamily="34" charset="-122"/>
+                <a:cs typeface="Times New Roman" pitchFamily="34" charset="-120"/>
+              </a:rPr>
+              <a:t>Samples are chosen by the following procedures:</a:t>
+            </a:r>
+            <a:endParaRPr lang="en-US" sz="3400" dirty="0"/>
+          </a:p>
+          <a:p>
+            <a:pPr algn="l" indent="0" marL="0">
+              <a:spcAft>
+                <a:spcPts val="800"/>
+              </a:spcAft>
+              <a:buNone/>
+            </a:pPr>
+            <a:r>
+              <a:rPr lang="en-US" sz="3400" b="1" dirty="0">
+                <a:solidFill>
+                  <a:srgbClr val="111111"/>
+                </a:solidFill>
+                <a:latin typeface="Times New Roman" pitchFamily="34" charset="0"/>
+                <a:ea typeface="Times New Roman" pitchFamily="34" charset="-122"/>
+                <a:cs typeface="Times New Roman" pitchFamily="34" charset="-120"/>
+              </a:rPr>
+              <a:t>Why sample: </a:t>
+            </a:r>
+            <a:pPr algn="l" indent="0" marL="0">
+              <a:spcAft>
+                <a:spcPts val="800"/>
+              </a:spcAft>
+              <a:buNone/>
+            </a:pPr>
+            <a:r>
+              <a:rPr lang="en-US" sz="3400" dirty="0">
+                <a:solidFill>
+                  <a:srgbClr val="111111"/>
+                </a:solidFill>
+                <a:latin typeface="Times New Roman" pitchFamily="34" charset="0"/>
+                <a:ea typeface="Times New Roman" pitchFamily="34" charset="-122"/>
+                <a:cs typeface="Times New Roman" pitchFamily="34" charset="-120"/>
+              </a:rPr>
+              <a:t>It is often impossible, too slow or too costly to study every member of a population. A well-chosen sample gives reliable results for the whole group.</a:t>
+            </a:r>
+            <a:endParaRPr lang="en-US" sz="3400" dirty="0"/>
+          </a:p>
+        </p:txBody>
+      </p:sp>
       <p:pic>
         <p:nvPicPr>
-          <p:cNvPr id="3" name="Image 0" descr="/home/claude/f4/img/minesec_sheet.png">    </p:cNvPr>
+          <p:cNvPr id="5" name="Image 0" descr="/home/claude/f4/img/v2/sampling_big.png">    </p:cNvPr>
           <p:cNvPicPr>
             <a:picLocks noChangeAspect="1"/>
           </p:cNvPicPr>
@@ -16803,8 +17094,8 @@
         </p:blipFill>
         <p:spPr>
           <a:xfrm>
-            <a:off x="0" y="658368"/>
-            <a:ext cx="5120640" cy="5833872"/>
+            <a:off x="6537960" y="2849678"/>
+            <a:ext cx="5470855" cy="2137053"/>
           </a:xfrm>
           <a:prstGeom prst="rect">
             <a:avLst/>
@@ -16813,14 +17104,14 @@
       </p:pic>
       <p:sp>
         <p:nvSpPr>
-          <p:cNvPr id="4" name="Text 1"/>
+          <p:cNvPr id="6" name="Text 3"/>
           <p:cNvSpPr/>
           <p:nvPr/>
         </p:nvSpPr>
         <p:spPr>
           <a:xfrm>
-            <a:off x="5349240" y="1005840"/>
-            <a:ext cx="6522415" cy="731520"/>
+            <a:off x="6537960" y="6089904"/>
+            <a:ext cx="5470855" cy="347472"/>
           </a:xfrm>
           <a:prstGeom prst="rect">
             <a:avLst/>
@@ -16829,85 +17120,24 @@
           <a:ln/>
         </p:spPr>
         <p:txBody>
-          <a:bodyPr wrap="square" lIns="0" tIns="0" rIns="0" bIns="0" rtlCol="0" anchor="ctr">
-            <a:normAutofit/>
-          </a:bodyPr>
+          <a:bodyPr wrap="square" lIns="0" tIns="0" rIns="0" bIns="0" rtlCol="0" anchor="ctr"/>
           <a:lstStyle/>
           <a:p>
             <a:pPr algn="ctr" indent="0" marL="0">
               <a:buNone/>
             </a:pPr>
             <a:r>
-              <a:rPr lang="en-US" sz="3600" b="1" dirty="0">
-                <a:solidFill>
-                  <a:srgbClr val="990011"/>
+              <a:rPr lang="en-US" sz="1600" i="1" dirty="0">
+                <a:solidFill>
+                  <a:srgbClr val="555555"/>
                 </a:solidFill>
                 <a:latin typeface="Times New Roman" pitchFamily="34" charset="0"/>
                 <a:ea typeface="Times New Roman" pitchFamily="34" charset="-122"/>
                 <a:cs typeface="Times New Roman" pitchFamily="34" charset="-120"/>
               </a:rPr>
-              <a:t>2. Basic Sampling Procedures</a:t>
-            </a:r>
-            <a:endParaRPr lang="en-US" sz="3600" dirty="0"/>
-          </a:p>
-        </p:txBody>
-      </p:sp>
-      <p:sp>
-        <p:nvSpPr>
-          <p:cNvPr id="5" name="Text 2"/>
-          <p:cNvSpPr/>
-          <p:nvPr/>
-        </p:nvSpPr>
-        <p:spPr>
-          <a:xfrm>
-            <a:off x="5349240" y="1783080"/>
-            <a:ext cx="6522415" cy="4663440"/>
-          </a:xfrm>
-          <a:prstGeom prst="rect">
-            <a:avLst/>
-          </a:prstGeom>
-          <a:noFill/>
-          <a:ln/>
-        </p:spPr>
-        <p:txBody>
-          <a:bodyPr wrap="square" lIns="0" tIns="0" rIns="0" bIns="0" rtlCol="0" anchor="t"/>
-          <a:lstStyle/>
-          <a:p>
-            <a:pPr algn="l" indent="0" marL="0">
-              <a:spcAft>
-                <a:spcPts val="800"/>
-              </a:spcAft>
-              <a:buNone/>
-            </a:pPr>
-            <a:r>
-              <a:rPr lang="en-US" sz="4000" b="1" dirty="0">
-                <a:solidFill>
-                  <a:srgbClr val="111111"/>
-                </a:solidFill>
-                <a:latin typeface="Times New Roman" pitchFamily="34" charset="0"/>
-                <a:ea typeface="Times New Roman" pitchFamily="34" charset="-122"/>
-                <a:cs typeface="Times New Roman" pitchFamily="34" charset="-120"/>
-              </a:rPr>
-              <a:t>Random sampling: </a:t>
-            </a:r>
-            <a:pPr algn="l" indent="0" marL="0">
-              <a:spcAft>
-                <a:spcPts val="800"/>
-              </a:spcAft>
-              <a:buNone/>
-            </a:pPr>
-            <a:r>
-              <a:rPr lang="en-US" sz="4000" dirty="0">
-                <a:solidFill>
-                  <a:srgbClr val="111111"/>
-                </a:solidFill>
-                <a:latin typeface="Times New Roman" pitchFamily="34" charset="0"/>
-                <a:ea typeface="Times New Roman" pitchFamily="34" charset="-122"/>
-                <a:cs typeface="Times New Roman" pitchFamily="34" charset="-120"/>
-              </a:rPr>
-              <a:t>Every member has an equal chance of being chosen, by drawing names from a box or using random numbers; it is unbiased.</a:t>
-            </a:r>
-            <a:endParaRPr lang="en-US" sz="4000" dirty="0"/>
+              <a:t>Illustration: sampling methods</a:t>
+            </a:r>
+            <a:endParaRPr lang="en-US" sz="1600" dirty="0"/>
           </a:p>
         </p:txBody>
       </p:sp>
@@ -17023,109 +17253,9 @@
           </a:p>
         </p:txBody>
       </p:sp>
-      <p:sp>
-        <p:nvSpPr>
-          <p:cNvPr id="3" name="Text 1"/>
-          <p:cNvSpPr/>
-          <p:nvPr/>
-        </p:nvSpPr>
-        <p:spPr>
-          <a:xfrm>
-            <a:off x="365760" y="1005840"/>
-            <a:ext cx="11460175" cy="731520"/>
-          </a:xfrm>
-          <a:prstGeom prst="rect">
-            <a:avLst/>
-          </a:prstGeom>
-          <a:noFill/>
-          <a:ln/>
-        </p:spPr>
-        <p:txBody>
-          <a:bodyPr wrap="square" lIns="0" tIns="0" rIns="0" bIns="0" rtlCol="0" anchor="ctr">
-            <a:normAutofit/>
-          </a:bodyPr>
-          <a:lstStyle/>
-          <a:p>
-            <a:pPr algn="ctr" indent="0" marL="0">
-              <a:buNone/>
-            </a:pPr>
-            <a:r>
-              <a:rPr lang="en-US" sz="3600" b="1" dirty="0">
-                <a:solidFill>
-                  <a:srgbClr val="990011"/>
-                </a:solidFill>
-                <a:latin typeface="Times New Roman" pitchFamily="34" charset="0"/>
-                <a:ea typeface="Times New Roman" pitchFamily="34" charset="-122"/>
-                <a:cs typeface="Times New Roman" pitchFamily="34" charset="-120"/>
-              </a:rPr>
-              <a:t>2. Basic Sampling Procedures</a:t>
-            </a:r>
-            <a:endParaRPr lang="en-US" sz="3600" dirty="0"/>
-          </a:p>
-        </p:txBody>
-      </p:sp>
-      <p:sp>
-        <p:nvSpPr>
-          <p:cNvPr id="4" name="Text 2"/>
-          <p:cNvSpPr/>
-          <p:nvPr/>
-        </p:nvSpPr>
-        <p:spPr>
-          <a:xfrm>
-            <a:off x="365760" y="1783080"/>
-            <a:ext cx="4846320" cy="4617720"/>
-          </a:xfrm>
-          <a:prstGeom prst="rect">
-            <a:avLst/>
-          </a:prstGeom>
-          <a:noFill/>
-          <a:ln/>
-        </p:spPr>
-        <p:txBody>
-          <a:bodyPr wrap="square" lIns="0" tIns="0" rIns="0" bIns="0" rtlCol="0" anchor="t"/>
-          <a:lstStyle/>
-          <a:p>
-            <a:pPr algn="l" indent="0" marL="0">
-              <a:spcAft>
-                <a:spcPts val="800"/>
-              </a:spcAft>
-              <a:buNone/>
-            </a:pPr>
-            <a:r>
-              <a:rPr lang="en-US" sz="3400" b="1" dirty="0">
-                <a:solidFill>
-                  <a:srgbClr val="111111"/>
-                </a:solidFill>
-                <a:latin typeface="Times New Roman" pitchFamily="34" charset="0"/>
-                <a:ea typeface="Times New Roman" pitchFamily="34" charset="-122"/>
-                <a:cs typeface="Times New Roman" pitchFamily="34" charset="-120"/>
-              </a:rPr>
-              <a:t>Systematic sampling: </a:t>
-            </a:r>
-            <a:pPr algn="l" indent="0" marL="0">
-              <a:spcAft>
-                <a:spcPts val="800"/>
-              </a:spcAft>
-              <a:buNone/>
-            </a:pPr>
-            <a:r>
-              <a:rPr lang="en-US" sz="3400" dirty="0">
-                <a:solidFill>
-                  <a:srgbClr val="111111"/>
-                </a:solidFill>
-                <a:latin typeface="Times New Roman" pitchFamily="34" charset="0"/>
-                <a:ea typeface="Times New Roman" pitchFamily="34" charset="-122"/>
-                <a:cs typeface="Times New Roman" pitchFamily="34" charset="-120"/>
-              </a:rPr>
-              <a:t>Members are chosen at a regular interval k = population ÷ sample size, from a random start: for 20 out of 200, k = 10, so the 7th, 17th, 27th and so on.</a:t>
-            </a:r>
-            <a:endParaRPr lang="en-US" sz="3400" dirty="0"/>
-          </a:p>
-        </p:txBody>
-      </p:sp>
       <p:pic>
         <p:nvPicPr>
-          <p:cNvPr id="5" name="Image 0" descr="/home/claude/f4/img/v2/stat2_systematic.png">    </p:cNvPr>
+          <p:cNvPr id="3" name="Image 0" descr="/home/claude/f4/img/minesec_sheet.png">    </p:cNvPr>
           <p:cNvPicPr>
             <a:picLocks noChangeAspect="1"/>
           </p:cNvPicPr>
@@ -17139,8 +17269,8 @@
         </p:blipFill>
         <p:spPr>
           <a:xfrm>
-            <a:off x="5349240" y="2617506"/>
-            <a:ext cx="6659575" cy="2601397"/>
+            <a:off x="0" y="658368"/>
+            <a:ext cx="5120640" cy="5833872"/>
           </a:xfrm>
           <a:prstGeom prst="rect">
             <a:avLst/>
@@ -17149,14 +17279,14 @@
       </p:pic>
       <p:sp>
         <p:nvSpPr>
-          <p:cNvPr id="6" name="Text 3"/>
+          <p:cNvPr id="4" name="Text 1"/>
           <p:cNvSpPr/>
           <p:nvPr/>
         </p:nvSpPr>
         <p:spPr>
           <a:xfrm>
-            <a:off x="5349240" y="6089904"/>
-            <a:ext cx="6659575" cy="347472"/>
+            <a:off x="5349240" y="1005840"/>
+            <a:ext cx="6522415" cy="731520"/>
           </a:xfrm>
           <a:prstGeom prst="rect">
             <a:avLst/>
@@ -17165,24 +17295,85 @@
           <a:ln/>
         </p:spPr>
         <p:txBody>
-          <a:bodyPr wrap="square" lIns="0" tIns="0" rIns="0" bIns="0" rtlCol="0" anchor="ctr"/>
+          <a:bodyPr wrap="square" lIns="0" tIns="0" rIns="0" bIns="0" rtlCol="0" anchor="ctr">
+            <a:normAutofit/>
+          </a:bodyPr>
           <a:lstStyle/>
           <a:p>
             <a:pPr algn="ctr" indent="0" marL="0">
               <a:buNone/>
             </a:pPr>
             <a:r>
-              <a:rPr lang="en-US" sz="1600" i="1" dirty="0">
-                <a:solidFill>
-                  <a:srgbClr val="555555"/>
+              <a:rPr lang="en-US" sz="3600" b="1" dirty="0">
+                <a:solidFill>
+                  <a:srgbClr val="990011"/>
                 </a:solidFill>
                 <a:latin typeface="Times New Roman" pitchFamily="34" charset="0"/>
                 <a:ea typeface="Times New Roman" pitchFamily="34" charset="-122"/>
                 <a:cs typeface="Times New Roman" pitchFamily="34" charset="-120"/>
               </a:rPr>
-              <a:t>Illustration: systematic sampling</a:t>
-            </a:r>
-            <a:endParaRPr lang="en-US" sz="1600" dirty="0"/>
+              <a:t>2. Basic Sampling Procedures</a:t>
+            </a:r>
+            <a:endParaRPr lang="en-US" sz="3600" dirty="0"/>
+          </a:p>
+        </p:txBody>
+      </p:sp>
+      <p:sp>
+        <p:nvSpPr>
+          <p:cNvPr id="5" name="Text 2"/>
+          <p:cNvSpPr/>
+          <p:nvPr/>
+        </p:nvSpPr>
+        <p:spPr>
+          <a:xfrm>
+            <a:off x="5349240" y="1783080"/>
+            <a:ext cx="6522415" cy="4663440"/>
+          </a:xfrm>
+          <a:prstGeom prst="rect">
+            <a:avLst/>
+          </a:prstGeom>
+          <a:noFill/>
+          <a:ln/>
+        </p:spPr>
+        <p:txBody>
+          <a:bodyPr wrap="square" lIns="0" tIns="0" rIns="0" bIns="0" rtlCol="0" anchor="t"/>
+          <a:lstStyle/>
+          <a:p>
+            <a:pPr algn="l" indent="0" marL="0">
+              <a:spcAft>
+                <a:spcPts val="800"/>
+              </a:spcAft>
+              <a:buNone/>
+            </a:pPr>
+            <a:r>
+              <a:rPr lang="en-US" sz="4000" b="1" dirty="0">
+                <a:solidFill>
+                  <a:srgbClr val="111111"/>
+                </a:solidFill>
+                <a:latin typeface="Times New Roman" pitchFamily="34" charset="0"/>
+                <a:ea typeface="Times New Roman" pitchFamily="34" charset="-122"/>
+                <a:cs typeface="Times New Roman" pitchFamily="34" charset="-120"/>
+              </a:rPr>
+              <a:t>Random sampling: </a:t>
+            </a:r>
+            <a:pPr algn="l" indent="0" marL="0">
+              <a:spcAft>
+                <a:spcPts val="800"/>
+              </a:spcAft>
+              <a:buNone/>
+            </a:pPr>
+            <a:r>
+              <a:rPr lang="en-US" sz="4000" dirty="0">
+                <a:solidFill>
+                  <a:srgbClr val="111111"/>
+                </a:solidFill>
+                <a:latin typeface="Times New Roman" pitchFamily="34" charset="0"/>
+                <a:ea typeface="Times New Roman" pitchFamily="34" charset="-122"/>
+                <a:cs typeface="Times New Roman" pitchFamily="34" charset="-120"/>
+              </a:rPr>
+              <a:t>Every member has an equal chance of being chosen, for example by drawing names from a box or using random numbers. This method avoids bias.</a:t>
+            </a:r>
+            <a:endParaRPr lang="en-US" sz="4000" dirty="0"/>
           </a:p>
         </p:txBody>
       </p:sp>
@@ -17298,9 +17489,109 @@
           </a:p>
         </p:txBody>
       </p:sp>
+      <p:sp>
+        <p:nvSpPr>
+          <p:cNvPr id="3" name="Text 1"/>
+          <p:cNvSpPr/>
+          <p:nvPr/>
+        </p:nvSpPr>
+        <p:spPr>
+          <a:xfrm>
+            <a:off x="365760" y="1005840"/>
+            <a:ext cx="11460175" cy="731520"/>
+          </a:xfrm>
+          <a:prstGeom prst="rect">
+            <a:avLst/>
+          </a:prstGeom>
+          <a:noFill/>
+          <a:ln/>
+        </p:spPr>
+        <p:txBody>
+          <a:bodyPr wrap="square" lIns="0" tIns="0" rIns="0" bIns="0" rtlCol="0" anchor="ctr">
+            <a:normAutofit/>
+          </a:bodyPr>
+          <a:lstStyle/>
+          <a:p>
+            <a:pPr algn="ctr" indent="0" marL="0">
+              <a:buNone/>
+            </a:pPr>
+            <a:r>
+              <a:rPr lang="en-US" sz="3600" b="1" dirty="0">
+                <a:solidFill>
+                  <a:srgbClr val="990011"/>
+                </a:solidFill>
+                <a:latin typeface="Times New Roman" pitchFamily="34" charset="0"/>
+                <a:ea typeface="Times New Roman" pitchFamily="34" charset="-122"/>
+                <a:cs typeface="Times New Roman" pitchFamily="34" charset="-120"/>
+              </a:rPr>
+              <a:t>2. Basic Sampling Procedures</a:t>
+            </a:r>
+            <a:endParaRPr lang="en-US" sz="3600" dirty="0"/>
+          </a:p>
+        </p:txBody>
+      </p:sp>
+      <p:sp>
+        <p:nvSpPr>
+          <p:cNvPr id="4" name="Text 2"/>
+          <p:cNvSpPr/>
+          <p:nvPr/>
+        </p:nvSpPr>
+        <p:spPr>
+          <a:xfrm>
+            <a:off x="365760" y="1783080"/>
+            <a:ext cx="6035040" cy="4617720"/>
+          </a:xfrm>
+          <a:prstGeom prst="rect">
+            <a:avLst/>
+          </a:prstGeom>
+          <a:noFill/>
+          <a:ln/>
+        </p:spPr>
+        <p:txBody>
+          <a:bodyPr wrap="square" lIns="0" tIns="0" rIns="0" bIns="0" rtlCol="0" anchor="t"/>
+          <a:lstStyle/>
+          <a:p>
+            <a:pPr algn="l" indent="0" marL="0">
+              <a:spcAft>
+                <a:spcPts val="800"/>
+              </a:spcAft>
+              <a:buNone/>
+            </a:pPr>
+            <a:r>
+              <a:rPr lang="en-US" sz="3600" b="1" dirty="0">
+                <a:solidFill>
+                  <a:srgbClr val="111111"/>
+                </a:solidFill>
+                <a:latin typeface="Times New Roman" pitchFamily="34" charset="0"/>
+                <a:ea typeface="Times New Roman" pitchFamily="34" charset="-122"/>
+                <a:cs typeface="Times New Roman" pitchFamily="34" charset="-120"/>
+              </a:rPr>
+              <a:t>Systematic sampling: </a:t>
+            </a:r>
+            <a:pPr algn="l" indent="0" marL="0">
+              <a:spcAft>
+                <a:spcPts val="800"/>
+              </a:spcAft>
+              <a:buNone/>
+            </a:pPr>
+            <a:r>
+              <a:rPr lang="en-US" sz="3600" dirty="0">
+                <a:solidFill>
+                  <a:srgbClr val="111111"/>
+                </a:solidFill>
+                <a:latin typeface="Times New Roman" pitchFamily="34" charset="0"/>
+                <a:ea typeface="Times New Roman" pitchFamily="34" charset="-122"/>
+                <a:cs typeface="Times New Roman" pitchFamily="34" charset="-120"/>
+              </a:rPr>
+              <a:t>Members are chosen at a regular interval k = population ÷ sample size, starting from a random point. To choose 20 out of 200, k = 10, so the 7th, 17th, 27th and so on are chosen.</a:t>
+            </a:r>
+            <a:endParaRPr lang="en-US" sz="3600" dirty="0"/>
+          </a:p>
+        </p:txBody>
+      </p:sp>
       <p:pic>
         <p:nvPicPr>
-          <p:cNvPr id="3" name="Image 0" descr="/home/claude/f4/img/minesec_sheet.png">    </p:cNvPr>
+          <p:cNvPr id="5" name="Image 0" descr="/home/claude/f4/img/v2/stat2_systematic.png">    </p:cNvPr>
           <p:cNvPicPr>
             <a:picLocks noChangeAspect="1"/>
           </p:cNvPicPr>
@@ -17314,8 +17605,8 @@
         </p:blipFill>
         <p:spPr>
           <a:xfrm>
-            <a:off x="0" y="658368"/>
-            <a:ext cx="5120640" cy="5833872"/>
+            <a:off x="6537960" y="2849678"/>
+            <a:ext cx="5470855" cy="2137053"/>
           </a:xfrm>
           <a:prstGeom prst="rect">
             <a:avLst/>
@@ -17324,14 +17615,14 @@
       </p:pic>
       <p:sp>
         <p:nvSpPr>
-          <p:cNvPr id="4" name="Text 1"/>
+          <p:cNvPr id="6" name="Text 3"/>
           <p:cNvSpPr/>
           <p:nvPr/>
         </p:nvSpPr>
         <p:spPr>
           <a:xfrm>
-            <a:off x="5349240" y="1005840"/>
-            <a:ext cx="6522415" cy="731520"/>
+            <a:off x="6537960" y="6089904"/>
+            <a:ext cx="5470855" cy="347472"/>
           </a:xfrm>
           <a:prstGeom prst="rect">
             <a:avLst/>
@@ -17340,85 +17631,24 @@
           <a:ln/>
         </p:spPr>
         <p:txBody>
-          <a:bodyPr wrap="square" lIns="0" tIns="0" rIns="0" bIns="0" rtlCol="0" anchor="ctr">
-            <a:normAutofit/>
-          </a:bodyPr>
+          <a:bodyPr wrap="square" lIns="0" tIns="0" rIns="0" bIns="0" rtlCol="0" anchor="ctr"/>
           <a:lstStyle/>
           <a:p>
             <a:pPr algn="ctr" indent="0" marL="0">
               <a:buNone/>
             </a:pPr>
             <a:r>
-              <a:rPr lang="en-US" sz="3600" b="1" dirty="0">
-                <a:solidFill>
-                  <a:srgbClr val="990011"/>
+              <a:rPr lang="en-US" sz="1600" i="1" dirty="0">
+                <a:solidFill>
+                  <a:srgbClr val="555555"/>
                 </a:solidFill>
                 <a:latin typeface="Times New Roman" pitchFamily="34" charset="0"/>
                 <a:ea typeface="Times New Roman" pitchFamily="34" charset="-122"/>
                 <a:cs typeface="Times New Roman" pitchFamily="34" charset="-120"/>
               </a:rPr>
-              <a:t>2. Basic Sampling Procedures</a:t>
-            </a:r>
-            <a:endParaRPr lang="en-US" sz="3600" dirty="0"/>
-          </a:p>
-        </p:txBody>
-      </p:sp>
-      <p:sp>
-        <p:nvSpPr>
-          <p:cNvPr id="5" name="Text 2"/>
-          <p:cNvSpPr/>
-          <p:nvPr/>
-        </p:nvSpPr>
-        <p:spPr>
-          <a:xfrm>
-            <a:off x="5349240" y="1783080"/>
-            <a:ext cx="6522415" cy="4663440"/>
-          </a:xfrm>
-          <a:prstGeom prst="rect">
-            <a:avLst/>
-          </a:prstGeom>
-          <a:noFill/>
-          <a:ln/>
-        </p:spPr>
-        <p:txBody>
-          <a:bodyPr wrap="square" lIns="0" tIns="0" rIns="0" bIns="0" rtlCol="0" anchor="t"/>
-          <a:lstStyle/>
-          <a:p>
-            <a:pPr algn="l" indent="0" marL="0">
-              <a:spcAft>
-                <a:spcPts val="800"/>
-              </a:spcAft>
-              <a:buNone/>
-            </a:pPr>
-            <a:r>
-              <a:rPr lang="en-US" sz="4000" b="1" dirty="0">
-                <a:solidFill>
-                  <a:srgbClr val="111111"/>
-                </a:solidFill>
-                <a:latin typeface="Times New Roman" pitchFamily="34" charset="0"/>
-                <a:ea typeface="Times New Roman" pitchFamily="34" charset="-122"/>
-                <a:cs typeface="Times New Roman" pitchFamily="34" charset="-120"/>
-              </a:rPr>
-              <a:t>Stratified sampling: </a:t>
-            </a:r>
-            <a:pPr algn="l" indent="0" marL="0">
-              <a:spcAft>
-                <a:spcPts val="800"/>
-              </a:spcAft>
-              <a:buNone/>
-            </a:pPr>
-            <a:r>
-              <a:rPr lang="en-US" sz="4000" dirty="0">
-                <a:solidFill>
-                  <a:srgbClr val="111111"/>
-                </a:solidFill>
-                <a:latin typeface="Times New Roman" pitchFamily="34" charset="0"/>
-                <a:ea typeface="Times New Roman" pitchFamily="34" charset="-122"/>
-                <a:cs typeface="Times New Roman" pitchFamily="34" charset="-120"/>
-              </a:rPr>
-              <a:t>The population is divided into groups (strata), such as forms in a school, and each group is sampled in proportion to its size; it is very representative.</a:t>
-            </a:r>
-            <a:endParaRPr lang="en-US" sz="4000" dirty="0"/>
+              <a:t>Illustration: systematic sampling</a:t>
+            </a:r>
+            <a:endParaRPr lang="en-US" sz="1600" dirty="0"/>
           </a:p>
         </p:txBody>
       </p:sp>
@@ -17534,129 +17764,9 @@
           </a:p>
         </p:txBody>
       </p:sp>
-      <p:sp>
-        <p:nvSpPr>
-          <p:cNvPr id="3" name="Text 1"/>
-          <p:cNvSpPr/>
-          <p:nvPr/>
-        </p:nvSpPr>
-        <p:spPr>
-          <a:xfrm>
-            <a:off x="365760" y="1005840"/>
-            <a:ext cx="11460175" cy="731520"/>
-          </a:xfrm>
-          <a:prstGeom prst="rect">
-            <a:avLst/>
-          </a:prstGeom>
-          <a:noFill/>
-          <a:ln/>
-        </p:spPr>
-        <p:txBody>
-          <a:bodyPr wrap="square" lIns="0" tIns="0" rIns="0" bIns="0" rtlCol="0" anchor="ctr">
-            <a:normAutofit/>
-          </a:bodyPr>
-          <a:lstStyle/>
-          <a:p>
-            <a:pPr algn="ctr" indent="0" marL="0">
-              <a:buNone/>
-            </a:pPr>
-            <a:r>
-              <a:rPr lang="en-US" sz="3600" b="1" dirty="0">
-                <a:solidFill>
-                  <a:srgbClr val="990011"/>
-                </a:solidFill>
-                <a:latin typeface="Times New Roman" pitchFamily="34" charset="0"/>
-                <a:ea typeface="Times New Roman" pitchFamily="34" charset="-122"/>
-                <a:cs typeface="Times New Roman" pitchFamily="34" charset="-120"/>
-              </a:rPr>
-              <a:t>3. Primary Data Collection Techniques</a:t>
-            </a:r>
-            <a:endParaRPr lang="en-US" sz="3600" dirty="0"/>
-          </a:p>
-        </p:txBody>
-      </p:sp>
-      <p:sp>
-        <p:nvSpPr>
-          <p:cNvPr id="4" name="Text 2"/>
-          <p:cNvSpPr/>
-          <p:nvPr/>
-        </p:nvSpPr>
-        <p:spPr>
-          <a:xfrm>
-            <a:off x="365760" y="1783080"/>
-            <a:ext cx="4846320" cy="4617720"/>
-          </a:xfrm>
-          <a:prstGeom prst="rect">
-            <a:avLst/>
-          </a:prstGeom>
-          <a:noFill/>
-          <a:ln/>
-        </p:spPr>
-        <p:txBody>
-          <a:bodyPr wrap="square" lIns="0" tIns="0" rIns="0" bIns="0" rtlCol="0" anchor="t"/>
-          <a:lstStyle/>
-          <a:p>
-            <a:pPr algn="l" indent="0" marL="0">
-              <a:spcAft>
-                <a:spcPts val="800"/>
-              </a:spcAft>
-              <a:buNone/>
-            </a:pPr>
-            <a:r>
-              <a:rPr lang="en-US" sz="3200" i="1" dirty="0">
-                <a:solidFill>
-                  <a:srgbClr val="111111"/>
-                </a:solidFill>
-                <a:latin typeface="Times New Roman" pitchFamily="34" charset="0"/>
-                <a:ea typeface="Times New Roman" pitchFamily="34" charset="-122"/>
-                <a:cs typeface="Times New Roman" pitchFamily="34" charset="-120"/>
-              </a:rPr>
-              <a:t>The main techniques of primary data collection are the following:</a:t>
-            </a:r>
-            <a:endParaRPr lang="en-US" sz="3200" dirty="0"/>
-          </a:p>
-          <a:p>
-            <a:pPr algn="l" indent="0" marL="0">
-              <a:spcAft>
-                <a:spcPts val="800"/>
-              </a:spcAft>
-              <a:buNone/>
-            </a:pPr>
-            <a:r>
-              <a:rPr lang="en-US" sz="3200" b="1" dirty="0">
-                <a:solidFill>
-                  <a:srgbClr val="111111"/>
-                </a:solidFill>
-                <a:latin typeface="Times New Roman" pitchFamily="34" charset="0"/>
-                <a:ea typeface="Times New Roman" pitchFamily="34" charset="-122"/>
-                <a:cs typeface="Times New Roman" pitchFamily="34" charset="-120"/>
-              </a:rPr>
-              <a:t>Observation, counting and recording: </a:t>
-            </a:r>
-            <a:pPr algn="l" indent="0" marL="0">
-              <a:spcAft>
-                <a:spcPts val="800"/>
-              </a:spcAft>
-              <a:buNone/>
-            </a:pPr>
-            <a:r>
-              <a:rPr lang="en-US" sz="3200" dirty="0">
-                <a:solidFill>
-                  <a:srgbClr val="111111"/>
-                </a:solidFill>
-                <a:latin typeface="Times New Roman" pitchFamily="34" charset="0"/>
-                <a:ea typeface="Times New Roman" pitchFamily="34" charset="-122"/>
-                <a:cs typeface="Times New Roman" pitchFamily="34" charset="-120"/>
-              </a:rPr>
-              <a:t>Counting cars, motos and lorries on the Pont Neuf in one hour, or photographing house types in Yelwa.</a:t>
-            </a:r>
-            <a:endParaRPr lang="en-US" sz="3200" dirty="0"/>
-          </a:p>
-        </p:txBody>
-      </p:sp>
       <p:pic>
         <p:nvPicPr>
-          <p:cNvPr id="5" name="Image 0" descr="/home/claude/f4/img/v2/stat2_techniques.png">    </p:cNvPr>
+          <p:cNvPr id="3" name="Image 0" descr="/home/claude/f4/img/minesec_sheet.png">    </p:cNvPr>
           <p:cNvPicPr>
             <a:picLocks noChangeAspect="1"/>
           </p:cNvPicPr>
@@ -17670,8 +17780,8 @@
         </p:blipFill>
         <p:spPr>
           <a:xfrm>
-            <a:off x="5349240" y="2617506"/>
-            <a:ext cx="6659575" cy="2601397"/>
+            <a:off x="0" y="658368"/>
+            <a:ext cx="3840480" cy="5833872"/>
           </a:xfrm>
           <a:prstGeom prst="rect">
             <a:avLst/>
@@ -17680,14 +17790,14 @@
       </p:pic>
       <p:sp>
         <p:nvSpPr>
-          <p:cNvPr id="6" name="Text 3"/>
+          <p:cNvPr id="4" name="Text 1"/>
           <p:cNvSpPr/>
           <p:nvPr/>
         </p:nvSpPr>
         <p:spPr>
           <a:xfrm>
-            <a:off x="5349240" y="6089904"/>
-            <a:ext cx="6659575" cy="347472"/>
+            <a:off x="4069080" y="1005840"/>
+            <a:ext cx="7802575" cy="731520"/>
           </a:xfrm>
           <a:prstGeom prst="rect">
             <a:avLst/>
@@ -17696,24 +17806,85 @@
           <a:ln/>
         </p:spPr>
         <p:txBody>
-          <a:bodyPr wrap="square" lIns="0" tIns="0" rIns="0" bIns="0" rtlCol="0" anchor="ctr"/>
+          <a:bodyPr wrap="square" lIns="0" tIns="0" rIns="0" bIns="0" rtlCol="0" anchor="ctr">
+            <a:normAutofit/>
+          </a:bodyPr>
           <a:lstStyle/>
           <a:p>
             <a:pPr algn="ctr" indent="0" marL="0">
               <a:buNone/>
             </a:pPr>
             <a:r>
-              <a:rPr lang="en-US" sz="1600" i="1" dirty="0">
-                <a:solidFill>
-                  <a:srgbClr val="555555"/>
+              <a:rPr lang="en-US" sz="3600" b="1" dirty="0">
+                <a:solidFill>
+                  <a:srgbClr val="990011"/>
                 </a:solidFill>
                 <a:latin typeface="Times New Roman" pitchFamily="34" charset="0"/>
                 <a:ea typeface="Times New Roman" pitchFamily="34" charset="-122"/>
                 <a:cs typeface="Times New Roman" pitchFamily="34" charset="-120"/>
               </a:rPr>
-              <a:t>Illustration: collection techniques</a:t>
-            </a:r>
-            <a:endParaRPr lang="en-US" sz="1600" dirty="0"/>
+              <a:t>2. Basic Sampling Procedures</a:t>
+            </a:r>
+            <a:endParaRPr lang="en-US" sz="3600" dirty="0"/>
+          </a:p>
+        </p:txBody>
+      </p:sp>
+      <p:sp>
+        <p:nvSpPr>
+          <p:cNvPr id="5" name="Text 2"/>
+          <p:cNvSpPr/>
+          <p:nvPr/>
+        </p:nvSpPr>
+        <p:spPr>
+          <a:xfrm>
+            <a:off x="4069080" y="1783080"/>
+            <a:ext cx="7802575" cy="4663440"/>
+          </a:xfrm>
+          <a:prstGeom prst="rect">
+            <a:avLst/>
+          </a:prstGeom>
+          <a:noFill/>
+          <a:ln/>
+        </p:spPr>
+        <p:txBody>
+          <a:bodyPr wrap="square" lIns="0" tIns="0" rIns="0" bIns="0" rtlCol="0" anchor="t"/>
+          <a:lstStyle/>
+          <a:p>
+            <a:pPr algn="l" indent="0" marL="0">
+              <a:spcAft>
+                <a:spcPts val="800"/>
+              </a:spcAft>
+              <a:buNone/>
+            </a:pPr>
+            <a:r>
+              <a:rPr lang="en-US" sz="4000" b="1" dirty="0">
+                <a:solidFill>
+                  <a:srgbClr val="111111"/>
+                </a:solidFill>
+                <a:latin typeface="Times New Roman" pitchFamily="34" charset="0"/>
+                <a:ea typeface="Times New Roman" pitchFamily="34" charset="-122"/>
+                <a:cs typeface="Times New Roman" pitchFamily="34" charset="-120"/>
+              </a:rPr>
+              <a:t>Stratified sampling: </a:t>
+            </a:r>
+            <a:pPr algn="l" indent="0" marL="0">
+              <a:spcAft>
+                <a:spcPts val="800"/>
+              </a:spcAft>
+              <a:buNone/>
+            </a:pPr>
+            <a:r>
+              <a:rPr lang="en-US" sz="4000" dirty="0">
+                <a:solidFill>
+                  <a:srgbClr val="111111"/>
+                </a:solidFill>
+                <a:latin typeface="Times New Roman" pitchFamily="34" charset="0"/>
+                <a:ea typeface="Times New Roman" pitchFamily="34" charset="-122"/>
+                <a:cs typeface="Times New Roman" pitchFamily="34" charset="-120"/>
+              </a:rPr>
+              <a:t>The population is divided into groups (strata), such as the forms of a school, and each group is sampled in proportion to its size. This makes the sample very representative.</a:t>
+            </a:r>
+            <a:endParaRPr lang="en-US" sz="4000" dirty="0"/>
           </a:p>
         </p:txBody>
       </p:sp>
@@ -17829,9 +18000,170 @@
           </a:p>
         </p:txBody>
       </p:sp>
+      <p:sp>
+        <p:nvSpPr>
+          <p:cNvPr id="3" name="Text 1"/>
+          <p:cNvSpPr/>
+          <p:nvPr/>
+        </p:nvSpPr>
+        <p:spPr>
+          <a:xfrm>
+            <a:off x="365760" y="1005840"/>
+            <a:ext cx="11460175" cy="731520"/>
+          </a:xfrm>
+          <a:prstGeom prst="rect">
+            <a:avLst/>
+          </a:prstGeom>
+          <a:noFill/>
+          <a:ln/>
+        </p:spPr>
+        <p:txBody>
+          <a:bodyPr wrap="square" lIns="0" tIns="0" rIns="0" bIns="0" rtlCol="0" anchor="ctr">
+            <a:normAutofit/>
+          </a:bodyPr>
+          <a:lstStyle/>
+          <a:p>
+            <a:pPr algn="ctr" indent="0" marL="0">
+              <a:buNone/>
+            </a:pPr>
+            <a:r>
+              <a:rPr lang="en-US" sz="3600" b="1" dirty="0">
+                <a:solidFill>
+                  <a:srgbClr val="990011"/>
+                </a:solidFill>
+                <a:latin typeface="Times New Roman" pitchFamily="34" charset="0"/>
+                <a:ea typeface="Times New Roman" pitchFamily="34" charset="-122"/>
+                <a:cs typeface="Times New Roman" pitchFamily="34" charset="-120"/>
+              </a:rPr>
+              <a:t>3. Primary Data Collection Techniques</a:t>
+            </a:r>
+            <a:endParaRPr lang="en-US" sz="3600" dirty="0"/>
+          </a:p>
+        </p:txBody>
+      </p:sp>
+      <p:sp>
+        <p:nvSpPr>
+          <p:cNvPr id="4" name="Text 2"/>
+          <p:cNvSpPr/>
+          <p:nvPr/>
+        </p:nvSpPr>
+        <p:spPr>
+          <a:xfrm>
+            <a:off x="365760" y="1737360"/>
+            <a:ext cx="6035040" cy="457200"/>
+          </a:xfrm>
+          <a:prstGeom prst="rect">
+            <a:avLst/>
+          </a:prstGeom>
+          <a:noFill/>
+          <a:ln/>
+        </p:spPr>
+        <p:txBody>
+          <a:bodyPr wrap="square" lIns="0" tIns="0" rIns="0" bIns="0" rtlCol="0" anchor="ctr">
+            <a:normAutofit/>
+          </a:bodyPr>
+          <a:lstStyle/>
+          <a:p>
+            <a:pPr algn="l" indent="0" marL="0">
+              <a:buNone/>
+            </a:pPr>
+            <a:r>
+              <a:rPr lang="en-US" sz="3000" b="1" dirty="0">
+                <a:solidFill>
+                  <a:srgbClr val="990011"/>
+                </a:solidFill>
+                <a:latin typeface="Times New Roman" pitchFamily="34" charset="0"/>
+                <a:ea typeface="Times New Roman" pitchFamily="34" charset="-122"/>
+                <a:cs typeface="Times New Roman" pitchFamily="34" charset="-120"/>
+              </a:rPr>
+              <a:t>A) Observation, Recording and Measurement</a:t>
+            </a:r>
+            <a:endParaRPr lang="en-US" sz="3000" dirty="0"/>
+          </a:p>
+        </p:txBody>
+      </p:sp>
+      <p:sp>
+        <p:nvSpPr>
+          <p:cNvPr id="5" name="Text 3"/>
+          <p:cNvSpPr/>
+          <p:nvPr/>
+        </p:nvSpPr>
+        <p:spPr>
+          <a:xfrm>
+            <a:off x="365760" y="2240280"/>
+            <a:ext cx="6035040" cy="4160520"/>
+          </a:xfrm>
+          <a:prstGeom prst="rect">
+            <a:avLst/>
+          </a:prstGeom>
+          <a:noFill/>
+          <a:ln/>
+        </p:spPr>
+        <p:txBody>
+          <a:bodyPr wrap="square" lIns="0" tIns="0" rIns="0" bIns="0" rtlCol="0" anchor="t"/>
+          <a:lstStyle/>
+          <a:p>
+            <a:pPr algn="l" indent="0" marL="0">
+              <a:spcAft>
+                <a:spcPts val="800"/>
+              </a:spcAft>
+              <a:buNone/>
+            </a:pPr>
+            <a:r>
+              <a:rPr lang="en-US" sz="2800" i="1" dirty="0">
+                <a:solidFill>
+                  <a:srgbClr val="111111"/>
+                </a:solidFill>
+                <a:latin typeface="Times New Roman" pitchFamily="34" charset="0"/>
+                <a:ea typeface="Times New Roman" pitchFamily="34" charset="-122"/>
+                <a:cs typeface="Times New Roman" pitchFamily="34" charset="-120"/>
+              </a:rPr>
+              <a:t>Data are collected in the field with the following techniques:</a:t>
+            </a:r>
+            <a:endParaRPr lang="en-US" sz="2800" dirty="0"/>
+          </a:p>
+          <a:p>
+            <a:pPr algn="l" indent="0" marL="0">
+              <a:spcAft>
+                <a:spcPts val="800"/>
+              </a:spcAft>
+              <a:buNone/>
+            </a:pPr>
+            <a:r>
+              <a:rPr lang="en-US" sz="2800" b="1" dirty="0">
+                <a:solidFill>
+                  <a:srgbClr val="111111"/>
+                </a:solidFill>
+                <a:latin typeface="Times New Roman" pitchFamily="34" charset="0"/>
+                <a:ea typeface="Times New Roman" pitchFamily="34" charset="-122"/>
+                <a:cs typeface="Times New Roman" pitchFamily="34" charset="-120"/>
+              </a:rPr>
+              <a:t>Observation, counting and recording of frequencies: </a:t>
+            </a:r>
+            <a:pPr algn="l" indent="0" marL="0">
+              <a:spcAft>
+                <a:spcPts val="800"/>
+              </a:spcAft>
+              <a:buNone/>
+            </a:pPr>
+            <a:r>
+              <a:rPr lang="en-US" sz="2800" dirty="0">
+                <a:solidFill>
+                  <a:srgbClr val="111111"/>
+                </a:solidFill>
+                <a:latin typeface="Times New Roman" pitchFamily="34" charset="0"/>
+                <a:ea typeface="Times New Roman" pitchFamily="34" charset="-122"/>
+                <a:cs typeface="Times New Roman" pitchFamily="34" charset="-120"/>
+              </a:rPr>
+              <a:t>The researcher watches and counts events and records them on a tally sheet. For example, he counts the cars, motorbikes and lorries crossing the Pont Neuf in Garoua in one hour.</a:t>
+            </a:r>
+            <a:endParaRPr lang="en-US" sz="2800" dirty="0"/>
+          </a:p>
+        </p:txBody>
+      </p:sp>
       <p:pic>
         <p:nvPicPr>
-          <p:cNvPr id="3" name="Image 0" descr="/home/claude/f4/img/minesec_sheet.png">    </p:cNvPr>
+          <p:cNvPr id="6" name="Image 0" descr="/home/claude/f4/img/v2/stat2_techniques.png">    </p:cNvPr>
           <p:cNvPicPr>
             <a:picLocks noChangeAspect="1"/>
           </p:cNvPicPr>
@@ -17845,8 +18177,8 @@
         </p:blipFill>
         <p:spPr>
           <a:xfrm>
-            <a:off x="0" y="658368"/>
-            <a:ext cx="5120640" cy="5833872"/>
+            <a:off x="6537960" y="2849678"/>
+            <a:ext cx="5470855" cy="2137053"/>
           </a:xfrm>
           <a:prstGeom prst="rect">
             <a:avLst/>
@@ -17855,14 +18187,14 @@
       </p:pic>
       <p:sp>
         <p:nvSpPr>
-          <p:cNvPr id="4" name="Text 1"/>
+          <p:cNvPr id="7" name="Text 4"/>
           <p:cNvSpPr/>
           <p:nvPr/>
         </p:nvSpPr>
         <p:spPr>
           <a:xfrm>
-            <a:off x="5349240" y="1005840"/>
-            <a:ext cx="6522415" cy="731520"/>
+            <a:off x="6537960" y="6089904"/>
+            <a:ext cx="5470855" cy="347472"/>
           </a:xfrm>
           <a:prstGeom prst="rect">
             <a:avLst/>
@@ -17871,85 +18203,24 @@
           <a:ln/>
         </p:spPr>
         <p:txBody>
-          <a:bodyPr wrap="square" lIns="0" tIns="0" rIns="0" bIns="0" rtlCol="0" anchor="ctr">
-            <a:normAutofit/>
-          </a:bodyPr>
+          <a:bodyPr wrap="square" lIns="0" tIns="0" rIns="0" bIns="0" rtlCol="0" anchor="ctr"/>
           <a:lstStyle/>
           <a:p>
             <a:pPr algn="ctr" indent="0" marL="0">
               <a:buNone/>
             </a:pPr>
             <a:r>
-              <a:rPr lang="en-US" sz="3600" b="1" dirty="0">
-                <a:solidFill>
-                  <a:srgbClr val="990011"/>
+              <a:rPr lang="en-US" sz="1600" i="1" dirty="0">
+                <a:solidFill>
+                  <a:srgbClr val="555555"/>
                 </a:solidFill>
                 <a:latin typeface="Times New Roman" pitchFamily="34" charset="0"/>
                 <a:ea typeface="Times New Roman" pitchFamily="34" charset="-122"/>
                 <a:cs typeface="Times New Roman" pitchFamily="34" charset="-120"/>
               </a:rPr>
-              <a:t>3. Primary Data Collection Techniques</a:t>
-            </a:r>
-            <a:endParaRPr lang="en-US" sz="3600" dirty="0"/>
-          </a:p>
-        </p:txBody>
-      </p:sp>
-      <p:sp>
-        <p:nvSpPr>
-          <p:cNvPr id="5" name="Text 2"/>
-          <p:cNvSpPr/>
-          <p:nvPr/>
-        </p:nvSpPr>
-        <p:spPr>
-          <a:xfrm>
-            <a:off x="5349240" y="1783080"/>
-            <a:ext cx="6522415" cy="4663440"/>
-          </a:xfrm>
-          <a:prstGeom prst="rect">
-            <a:avLst/>
-          </a:prstGeom>
-          <a:noFill/>
-          <a:ln/>
-        </p:spPr>
-        <p:txBody>
-          <a:bodyPr wrap="square" lIns="0" tIns="0" rIns="0" bIns="0" rtlCol="0" anchor="t"/>
-          <a:lstStyle/>
-          <a:p>
-            <a:pPr algn="l" indent="0" marL="0">
-              <a:spcAft>
-                <a:spcPts val="800"/>
-              </a:spcAft>
-              <a:buNone/>
-            </a:pPr>
-            <a:r>
-              <a:rPr lang="en-US" sz="4000" b="1" dirty="0">
-                <a:solidFill>
-                  <a:srgbClr val="111111"/>
-                </a:solidFill>
-                <a:latin typeface="Times New Roman" pitchFamily="34" charset="0"/>
-                <a:ea typeface="Times New Roman" pitchFamily="34" charset="-122"/>
-                <a:cs typeface="Times New Roman" pitchFamily="34" charset="-120"/>
-              </a:rPr>
-              <a:t>Measurement: </a:t>
-            </a:r>
-            <a:pPr algn="l" indent="0" marL="0">
-              <a:spcAft>
-                <a:spcPts val="800"/>
-              </a:spcAft>
-              <a:buNone/>
-            </a:pPr>
-            <a:r>
-              <a:rPr lang="en-US" sz="4000" dirty="0">
-                <a:solidFill>
-                  <a:srgbClr val="111111"/>
-                </a:solidFill>
-                <a:latin typeface="Times New Roman" pitchFamily="34" charset="0"/>
-                <a:ea typeface="Times New Roman" pitchFamily="34" charset="-122"/>
-                <a:cs typeface="Times New Roman" pitchFamily="34" charset="-120"/>
-              </a:rPr>
-              <a:t>Instruments give precise figures: thermometer, rain gauge, measuring tape (river width), clinometer (slope angle).</a:t>
-            </a:r>
-            <a:endParaRPr lang="en-US" sz="4000" dirty="0"/>
+              <a:t>Illustration: data collection techniques</a:t>
+            </a:r>
+            <a:endParaRPr lang="en-US" sz="1600" dirty="0"/>
           </a:p>
         </p:txBody>
       </p:sp>
@@ -18065,109 +18336,9 @@
           </a:p>
         </p:txBody>
       </p:sp>
-      <p:sp>
-        <p:nvSpPr>
-          <p:cNvPr id="3" name="Text 1"/>
-          <p:cNvSpPr/>
-          <p:nvPr/>
-        </p:nvSpPr>
-        <p:spPr>
-          <a:xfrm>
-            <a:off x="365760" y="1005840"/>
-            <a:ext cx="11460175" cy="731520"/>
-          </a:xfrm>
-          <a:prstGeom prst="rect">
-            <a:avLst/>
-          </a:prstGeom>
-          <a:noFill/>
-          <a:ln/>
-        </p:spPr>
-        <p:txBody>
-          <a:bodyPr wrap="square" lIns="0" tIns="0" rIns="0" bIns="0" rtlCol="0" anchor="ctr">
-            <a:normAutofit/>
-          </a:bodyPr>
-          <a:lstStyle/>
-          <a:p>
-            <a:pPr algn="ctr" indent="0" marL="0">
-              <a:buNone/>
-            </a:pPr>
-            <a:r>
-              <a:rPr lang="en-US" sz="3600" b="1" dirty="0">
-                <a:solidFill>
-                  <a:srgbClr val="990011"/>
-                </a:solidFill>
-                <a:latin typeface="Times New Roman" pitchFamily="34" charset="0"/>
-                <a:ea typeface="Times New Roman" pitchFamily="34" charset="-122"/>
-                <a:cs typeface="Times New Roman" pitchFamily="34" charset="-120"/>
-              </a:rPr>
-              <a:t>3. Primary Data Collection Techniques</a:t>
-            </a:r>
-            <a:endParaRPr lang="en-US" sz="3600" dirty="0"/>
-          </a:p>
-        </p:txBody>
-      </p:sp>
-      <p:sp>
-        <p:nvSpPr>
-          <p:cNvPr id="4" name="Text 2"/>
-          <p:cNvSpPr/>
-          <p:nvPr/>
-        </p:nvSpPr>
-        <p:spPr>
-          <a:xfrm>
-            <a:off x="365760" y="1783080"/>
-            <a:ext cx="4846320" cy="4617720"/>
-          </a:xfrm>
-          <a:prstGeom prst="rect">
-            <a:avLst/>
-          </a:prstGeom>
-          <a:noFill/>
-          <a:ln/>
-        </p:spPr>
-        <p:txBody>
-          <a:bodyPr wrap="square" lIns="0" tIns="0" rIns="0" bIns="0" rtlCol="0" anchor="t"/>
-          <a:lstStyle/>
-          <a:p>
-            <a:pPr algn="l" indent="0" marL="0">
-              <a:spcAft>
-                <a:spcPts val="800"/>
-              </a:spcAft>
-              <a:buNone/>
-            </a:pPr>
-            <a:r>
-              <a:rPr lang="en-US" sz="3600" b="1" dirty="0">
-                <a:solidFill>
-                  <a:srgbClr val="111111"/>
-                </a:solidFill>
-                <a:latin typeface="Times New Roman" pitchFamily="34" charset="0"/>
-                <a:ea typeface="Times New Roman" pitchFamily="34" charset="-122"/>
-                <a:cs typeface="Times New Roman" pitchFamily="34" charset="-120"/>
-              </a:rPr>
-              <a:t>Questionnaires: </a:t>
-            </a:r>
-            <a:pPr algn="l" indent="0" marL="0">
-              <a:spcAft>
-                <a:spcPts val="800"/>
-              </a:spcAft>
-              <a:buNone/>
-            </a:pPr>
-            <a:r>
-              <a:rPr lang="en-US" sz="3600" dirty="0">
-                <a:solidFill>
-                  <a:srgbClr val="111111"/>
-                </a:solidFill>
-                <a:latin typeface="Times New Roman" pitchFamily="34" charset="0"/>
-                <a:ea typeface="Times New Roman" pitchFamily="34" charset="-122"/>
-                <a:cs typeface="Times New Roman" pitchFamily="34" charset="-120"/>
-              </a:rPr>
-              <a:t>Written questions answered by respondents, with closed (yes/no, choices) or open questions.</a:t>
-            </a:r>
-            <a:endParaRPr lang="en-US" sz="3600" dirty="0"/>
-          </a:p>
-        </p:txBody>
-      </p:sp>
       <p:pic>
         <p:nvPicPr>
-          <p:cNvPr id="5" name="Image 0" descr="/home/claude/f4/img/v2/questionnaire_big.png">    </p:cNvPr>
+          <p:cNvPr id="3" name="Image 0" descr="/home/claude/f4/img/minesec_sheet.png">    </p:cNvPr>
           <p:cNvPicPr>
             <a:picLocks noChangeAspect="1"/>
           </p:cNvPicPr>
@@ -18181,8 +18352,8 @@
         </p:blipFill>
         <p:spPr>
           <a:xfrm>
-            <a:off x="5349240" y="2617506"/>
-            <a:ext cx="6659575" cy="2601397"/>
+            <a:off x="0" y="658368"/>
+            <a:ext cx="2468880" cy="5833872"/>
           </a:xfrm>
           <a:prstGeom prst="rect">
             <a:avLst/>
@@ -18191,14 +18362,14 @@
       </p:pic>
       <p:sp>
         <p:nvSpPr>
-          <p:cNvPr id="6" name="Text 3"/>
+          <p:cNvPr id="4" name="Text 1"/>
           <p:cNvSpPr/>
           <p:nvPr/>
         </p:nvSpPr>
         <p:spPr>
           <a:xfrm>
-            <a:off x="5349240" y="6089904"/>
-            <a:ext cx="6659575" cy="347472"/>
+            <a:off x="2697480" y="1005840"/>
+            <a:ext cx="9174175" cy="731520"/>
           </a:xfrm>
           <a:prstGeom prst="rect">
             <a:avLst/>
@@ -18207,24 +18378,124 @@
           <a:ln/>
         </p:spPr>
         <p:txBody>
-          <a:bodyPr wrap="square" lIns="0" tIns="0" rIns="0" bIns="0" rtlCol="0" anchor="ctr"/>
+          <a:bodyPr wrap="square" lIns="0" tIns="0" rIns="0" bIns="0" rtlCol="0" anchor="ctr">
+            <a:normAutofit/>
+          </a:bodyPr>
           <a:lstStyle/>
           <a:p>
             <a:pPr algn="ctr" indent="0" marL="0">
               <a:buNone/>
             </a:pPr>
             <a:r>
-              <a:rPr lang="en-US" sz="1600" i="1" dirty="0">
-                <a:solidFill>
-                  <a:srgbClr val="555555"/>
+              <a:rPr lang="en-US" sz="3600" b="1" dirty="0">
+                <a:solidFill>
+                  <a:srgbClr val="990011"/>
                 </a:solidFill>
                 <a:latin typeface="Times New Roman" pitchFamily="34" charset="0"/>
                 <a:ea typeface="Times New Roman" pitchFamily="34" charset="-122"/>
                 <a:cs typeface="Times New Roman" pitchFamily="34" charset="-120"/>
               </a:rPr>
-              <a:t>Illustration: good and bad questions</a:t>
-            </a:r>
-            <a:endParaRPr lang="en-US" sz="1600" dirty="0"/>
+              <a:t>3. Primary Data Collection Techniques</a:t>
+            </a:r>
+            <a:endParaRPr lang="en-US" sz="3600" dirty="0"/>
+          </a:p>
+        </p:txBody>
+      </p:sp>
+      <p:sp>
+        <p:nvSpPr>
+          <p:cNvPr id="5" name="Text 2"/>
+          <p:cNvSpPr/>
+          <p:nvPr/>
+        </p:nvSpPr>
+        <p:spPr>
+          <a:xfrm>
+            <a:off x="2697480" y="1737360"/>
+            <a:ext cx="9174175" cy="457200"/>
+          </a:xfrm>
+          <a:prstGeom prst="rect">
+            <a:avLst/>
+          </a:prstGeom>
+          <a:noFill/>
+          <a:ln/>
+        </p:spPr>
+        <p:txBody>
+          <a:bodyPr wrap="square" lIns="0" tIns="0" rIns="0" bIns="0" rtlCol="0" anchor="ctr"/>
+          <a:lstStyle/>
+          <a:p>
+            <a:pPr algn="l" indent="0" marL="0">
+              <a:buNone/>
+            </a:pPr>
+            <a:r>
+              <a:rPr lang="en-US" sz="3200" b="1" dirty="0">
+                <a:solidFill>
+                  <a:srgbClr val="990011"/>
+                </a:solidFill>
+                <a:latin typeface="Times New Roman" pitchFamily="34" charset="0"/>
+                <a:ea typeface="Times New Roman" pitchFamily="34" charset="-122"/>
+                <a:cs typeface="Times New Roman" pitchFamily="34" charset="-120"/>
+              </a:rPr>
+              <a:t>A) Observation, Recording and Measurement</a:t>
+            </a:r>
+            <a:endParaRPr lang="en-US" sz="3200" dirty="0"/>
+          </a:p>
+        </p:txBody>
+      </p:sp>
+      <p:sp>
+        <p:nvSpPr>
+          <p:cNvPr id="6" name="Text 3"/>
+          <p:cNvSpPr/>
+          <p:nvPr/>
+        </p:nvSpPr>
+        <p:spPr>
+          <a:xfrm>
+            <a:off x="2697480" y="2240280"/>
+            <a:ext cx="9174175" cy="4206240"/>
+          </a:xfrm>
+          <a:prstGeom prst="rect">
+            <a:avLst/>
+          </a:prstGeom>
+          <a:noFill/>
+          <a:ln/>
+        </p:spPr>
+        <p:txBody>
+          <a:bodyPr wrap="square" lIns="0" tIns="0" rIns="0" bIns="0" rtlCol="0" anchor="t"/>
+          <a:lstStyle/>
+          <a:p>
+            <a:pPr algn="l" indent="0" marL="0">
+              <a:spcAft>
+                <a:spcPts val="800"/>
+              </a:spcAft>
+              <a:buNone/>
+            </a:pPr>
+            <a:r>
+              <a:rPr lang="en-US" sz="4000" b="1" dirty="0">
+                <a:solidFill>
+                  <a:srgbClr val="111111"/>
+                </a:solidFill>
+                <a:latin typeface="Times New Roman" pitchFamily="34" charset="0"/>
+                <a:ea typeface="Times New Roman" pitchFamily="34" charset="-122"/>
+                <a:cs typeface="Times New Roman" pitchFamily="34" charset="-120"/>
+              </a:rPr>
+              <a:t>Pictures, filming and video recording: </a:t>
+            </a:r>
+            <a:pPr algn="l" indent="0" marL="0">
+              <a:spcAft>
+                <a:spcPts val="800"/>
+              </a:spcAft>
+              <a:buNone/>
+            </a:pPr>
+            <a:r>
+              <a:rPr lang="en-US" sz="4000" dirty="0">
+                <a:solidFill>
+                  <a:srgbClr val="111111"/>
+                </a:solidFill>
+                <a:latin typeface="Times New Roman" pitchFamily="34" charset="0"/>
+                <a:ea typeface="Times New Roman" pitchFamily="34" charset="-122"/>
+                <a:cs typeface="Times New Roman" pitchFamily="34" charset="-120"/>
+              </a:rPr>
+              <a:t>Photographs and videos record landscapes, house types or activities as evidence. For example, a student photographs the types of houses in the Yelwa quarter.</a:t>
+            </a:r>
+            <a:endParaRPr lang="en-US" sz="4000" dirty="0"/>
           </a:p>
         </p:txBody>
       </p:sp>
@@ -18413,8 +18684,47 @@
         </p:nvSpPr>
         <p:spPr>
           <a:xfrm>
-            <a:off x="2697480" y="1783080"/>
-            <a:ext cx="9174175" cy="4663440"/>
+            <a:off x="2697480" y="1737360"/>
+            <a:ext cx="9174175" cy="457200"/>
+          </a:xfrm>
+          <a:prstGeom prst="rect">
+            <a:avLst/>
+          </a:prstGeom>
+          <a:noFill/>
+          <a:ln/>
+        </p:spPr>
+        <p:txBody>
+          <a:bodyPr wrap="square" lIns="0" tIns="0" rIns="0" bIns="0" rtlCol="0" anchor="ctr"/>
+          <a:lstStyle/>
+          <a:p>
+            <a:pPr algn="l" indent="0" marL="0">
+              <a:buNone/>
+            </a:pPr>
+            <a:r>
+              <a:rPr lang="en-US" sz="3200" b="1" dirty="0">
+                <a:solidFill>
+                  <a:srgbClr val="990011"/>
+                </a:solidFill>
+                <a:latin typeface="Times New Roman" pitchFamily="34" charset="0"/>
+                <a:ea typeface="Times New Roman" pitchFamily="34" charset="-122"/>
+                <a:cs typeface="Times New Roman" pitchFamily="34" charset="-120"/>
+              </a:rPr>
+              <a:t>A) Observation, Recording and Measurement</a:t>
+            </a:r>
+            <a:endParaRPr lang="en-US" sz="3200" dirty="0"/>
+          </a:p>
+        </p:txBody>
+      </p:sp>
+      <p:sp>
+        <p:nvSpPr>
+          <p:cNvPr id="6" name="Text 3"/>
+          <p:cNvSpPr/>
+          <p:nvPr/>
+        </p:nvSpPr>
+        <p:spPr>
+          <a:xfrm>
+            <a:off x="2697480" y="2240280"/>
+            <a:ext cx="9174175" cy="4206240"/>
           </a:xfrm>
           <a:prstGeom prst="rect">
             <a:avLst/>
@@ -18441,7 +18751,7 @@
                 <a:ea typeface="Times New Roman" pitchFamily="34" charset="-122"/>
                 <a:cs typeface="Times New Roman" pitchFamily="34" charset="-120"/>
               </a:rPr>
-              <a:t>Interviews: </a:t>
+              <a:t>Measurement: </a:t>
             </a:r>
             <a:pPr algn="l" indent="0" marL="0">
               <a:spcAft>
@@ -18458,44 +18768,7 @@
                 <a:ea typeface="Times New Roman" pitchFamily="34" charset="-122"/>
                 <a:cs typeface="Times New Roman" pitchFamily="34" charset="-120"/>
               </a:rPr>
-              <a:t>Face-to-face or telephone conversations, structured (fixed questions) or unstructured.</a:t>
-            </a:r>
-            <a:endParaRPr lang="en-US" sz="4000" dirty="0"/>
-          </a:p>
-          <a:p>
-            <a:pPr algn="l" indent="0" marL="0">
-              <a:spcAft>
-                <a:spcPts val="800"/>
-              </a:spcAft>
-              <a:buNone/>
-            </a:pPr>
-            <a:r>
-              <a:rPr lang="en-US" sz="4000" b="1" dirty="0">
-                <a:solidFill>
-                  <a:srgbClr val="111111"/>
-                </a:solidFill>
-                <a:latin typeface="Times New Roman" pitchFamily="34" charset="0"/>
-                <a:ea typeface="Times New Roman" pitchFamily="34" charset="-122"/>
-                <a:cs typeface="Times New Roman" pitchFamily="34" charset="-120"/>
-              </a:rPr>
-              <a:t>Focus group discussions: </a:t>
-            </a:r>
-            <a:pPr algn="l" indent="0" marL="0">
-              <a:spcAft>
-                <a:spcPts val="800"/>
-              </a:spcAft>
-              <a:buNone/>
-            </a:pPr>
-            <a:r>
-              <a:rPr lang="en-US" sz="4000" dirty="0">
-                <a:solidFill>
-                  <a:srgbClr val="111111"/>
-                </a:solidFill>
-                <a:latin typeface="Times New Roman" pitchFamily="34" charset="0"/>
-                <a:ea typeface="Times New Roman" pitchFamily="34" charset="-122"/>
-                <a:cs typeface="Times New Roman" pitchFamily="34" charset="-120"/>
-              </a:rPr>
-              <a:t>A guided discussion with 6–10 people sharing a characteristic, such as cotton farmers near Garoua discussing climate change.</a:t>
+              <a:t>Instruments give precise figures, such as a thermometer for temperature, a rain gauge for rainfall and a measuring tape for the width of a river. A clinometer measures the angle of slopes.</a:t>
             </a:r>
             <a:endParaRPr lang="en-US" sz="4000" dirty="0"/>
           </a:p>
@@ -18826,15 +19099,176 @@
                 <a:ea typeface="Calibri" pitchFamily="34" charset="-122"/>
                 <a:cs typeface="Calibri" pitchFamily="34" charset="-120"/>
               </a:rPr>
-              <a:t>FORMATIVE EVALUATION</a:t>
+              <a:t>BOARD SUMMARY</a:t>
             </a:r>
             <a:endParaRPr lang="en-US" sz="1400" dirty="0"/>
+          </a:p>
+        </p:txBody>
+      </p:sp>
+      <p:sp>
+        <p:nvSpPr>
+          <p:cNvPr id="3" name="Text 1"/>
+          <p:cNvSpPr/>
+          <p:nvPr/>
+        </p:nvSpPr>
+        <p:spPr>
+          <a:xfrm>
+            <a:off x="365760" y="1005840"/>
+            <a:ext cx="11460175" cy="731520"/>
+          </a:xfrm>
+          <a:prstGeom prst="rect">
+            <a:avLst/>
+          </a:prstGeom>
+          <a:noFill/>
+          <a:ln/>
+        </p:spPr>
+        <p:txBody>
+          <a:bodyPr wrap="square" lIns="0" tIns="0" rIns="0" bIns="0" rtlCol="0" anchor="ctr">
+            <a:normAutofit/>
+          </a:bodyPr>
+          <a:lstStyle/>
+          <a:p>
+            <a:pPr algn="ctr" indent="0" marL="0">
+              <a:buNone/>
+            </a:pPr>
+            <a:r>
+              <a:rPr lang="en-US" sz="3600" b="1" dirty="0">
+                <a:solidFill>
+                  <a:srgbClr val="990011"/>
+                </a:solidFill>
+                <a:latin typeface="Times New Roman" pitchFamily="34" charset="0"/>
+                <a:ea typeface="Times New Roman" pitchFamily="34" charset="-122"/>
+                <a:cs typeface="Times New Roman" pitchFamily="34" charset="-120"/>
+              </a:rPr>
+              <a:t>3. Primary Data Collection Techniques</a:t>
+            </a:r>
+            <a:endParaRPr lang="en-US" sz="3600" dirty="0"/>
+          </a:p>
+        </p:txBody>
+      </p:sp>
+      <p:sp>
+        <p:nvSpPr>
+          <p:cNvPr id="4" name="Text 2"/>
+          <p:cNvSpPr/>
+          <p:nvPr/>
+        </p:nvSpPr>
+        <p:spPr>
+          <a:xfrm>
+            <a:off x="365760" y="1737360"/>
+            <a:ext cx="6035040" cy="457200"/>
+          </a:xfrm>
+          <a:prstGeom prst="rect">
+            <a:avLst/>
+          </a:prstGeom>
+          <a:noFill/>
+          <a:ln/>
+        </p:spPr>
+        <p:txBody>
+          <a:bodyPr wrap="square" lIns="0" tIns="0" rIns="0" bIns="0" rtlCol="0" anchor="ctr">
+            <a:normAutofit/>
+          </a:bodyPr>
+          <a:lstStyle/>
+          <a:p>
+            <a:pPr algn="l" indent="0" marL="0">
+              <a:buNone/>
+            </a:pPr>
+            <a:r>
+              <a:rPr lang="en-US" sz="3000" b="1" dirty="0">
+                <a:solidFill>
+                  <a:srgbClr val="990011"/>
+                </a:solidFill>
+                <a:latin typeface="Times New Roman" pitchFamily="34" charset="0"/>
+                <a:ea typeface="Times New Roman" pitchFamily="34" charset="-122"/>
+                <a:cs typeface="Times New Roman" pitchFamily="34" charset="-120"/>
+              </a:rPr>
+              <a:t>B) Questionnaires, Interviews and Focus Groups</a:t>
+            </a:r>
+            <a:endParaRPr lang="en-US" sz="3000" dirty="0"/>
+          </a:p>
+        </p:txBody>
+      </p:sp>
+      <p:sp>
+        <p:nvSpPr>
+          <p:cNvPr id="5" name="Text 3"/>
+          <p:cNvSpPr/>
+          <p:nvPr/>
+        </p:nvSpPr>
+        <p:spPr>
+          <a:xfrm>
+            <a:off x="365760" y="2240280"/>
+            <a:ext cx="6035040" cy="4160520"/>
+          </a:xfrm>
+          <a:prstGeom prst="rect">
+            <a:avLst/>
+          </a:prstGeom>
+          <a:noFill/>
+          <a:ln/>
+        </p:spPr>
+        <p:txBody>
+          <a:bodyPr wrap="square" lIns="0" tIns="0" rIns="0" bIns="0" rtlCol="0" anchor="t"/>
+          <a:lstStyle/>
+          <a:p>
+            <a:pPr algn="l" indent="0" marL="0">
+              <a:spcAft>
+                <a:spcPts val="800"/>
+              </a:spcAft>
+              <a:buNone/>
+            </a:pPr>
+            <a:r>
+              <a:rPr lang="en-US" sz="2800" i="1" dirty="0">
+                <a:solidFill>
+                  <a:srgbClr val="111111"/>
+                </a:solidFill>
+                <a:latin typeface="Times New Roman" pitchFamily="34" charset="0"/>
+                <a:ea typeface="Times New Roman" pitchFamily="34" charset="-122"/>
+                <a:cs typeface="Times New Roman" pitchFamily="34" charset="-120"/>
+              </a:rPr>
+              <a:t>Data are collected from people with the following techniques:</a:t>
+            </a:r>
+            <a:endParaRPr lang="en-US" sz="2800" dirty="0"/>
+          </a:p>
+          <a:p>
+            <a:pPr algn="l" indent="0" marL="0">
+              <a:spcAft>
+                <a:spcPts val="800"/>
+              </a:spcAft>
+              <a:buNone/>
+            </a:pPr>
+            <a:r>
+              <a:rPr lang="en-US" sz="2800" b="1" dirty="0">
+                <a:solidFill>
+                  <a:srgbClr val="111111"/>
+                </a:solidFill>
+                <a:latin typeface="Times New Roman" pitchFamily="34" charset="0"/>
+                <a:ea typeface="Times New Roman" pitchFamily="34" charset="-122"/>
+                <a:cs typeface="Times New Roman" pitchFamily="34" charset="-120"/>
+              </a:rPr>
+              <a:t>Questionnaires: </a:t>
+            </a:r>
+            <a:pPr algn="l" indent="0" marL="0">
+              <a:spcAft>
+                <a:spcPts val="800"/>
+              </a:spcAft>
+              <a:buNone/>
+            </a:pPr>
+            <a:r>
+              <a:rPr lang="en-US" sz="2800" dirty="0">
+                <a:solidFill>
+                  <a:srgbClr val="111111"/>
+                </a:solidFill>
+                <a:latin typeface="Times New Roman" pitchFamily="34" charset="0"/>
+                <a:ea typeface="Times New Roman" pitchFamily="34" charset="-122"/>
+                <a:cs typeface="Times New Roman" pitchFamily="34" charset="-120"/>
+              </a:rPr>
+              <a:t>They are written questions answered by respondents, with closed questions (yes or no, or choices) or open questions. Closed questions are easy to count, while open questions give more detail.</a:t>
+            </a:r>
+            <a:endParaRPr lang="en-US" sz="2800" dirty="0"/>
           </a:p>
         </p:txBody>
       </p:sp>
       <p:pic>
         <p:nvPicPr>
-          <p:cNvPr id="3" name="Image 0" descr="/home/claude/f4/img/minesec_sheet.png">    </p:cNvPr>
+          <p:cNvPr id="6" name="Image 0" descr="/home/claude/f4/img/v2/questionnaire_big.png">    </p:cNvPr>
           <p:cNvPicPr>
             <a:picLocks noChangeAspect="1"/>
           </p:cNvPicPr>
@@ -18848,8 +19282,8 @@
         </p:blipFill>
         <p:spPr>
           <a:xfrm>
-            <a:off x="0" y="658368"/>
-            <a:ext cx="5120640" cy="5833872"/>
+            <a:off x="6537960" y="2849678"/>
+            <a:ext cx="5470855" cy="2137053"/>
           </a:xfrm>
           <a:prstGeom prst="rect">
             <a:avLst/>
@@ -18858,14 +19292,14 @@
       </p:pic>
       <p:sp>
         <p:nvSpPr>
-          <p:cNvPr id="4" name="Text 1"/>
+          <p:cNvPr id="7" name="Text 4"/>
           <p:cNvSpPr/>
           <p:nvPr/>
         </p:nvSpPr>
         <p:spPr>
           <a:xfrm>
-            <a:off x="5349240" y="1005840"/>
-            <a:ext cx="6522415" cy="731520"/>
+            <a:off x="6537960" y="6089904"/>
+            <a:ext cx="5470855" cy="347472"/>
           </a:xfrm>
           <a:prstGeom prst="rect">
             <a:avLst/>
@@ -18874,68 +19308,24 @@
           <a:ln/>
         </p:spPr>
         <p:txBody>
-          <a:bodyPr wrap="square" lIns="0" tIns="0" rIns="0" bIns="0" rtlCol="0" anchor="ctr">
-            <a:normAutofit/>
-          </a:bodyPr>
+          <a:bodyPr wrap="square" lIns="0" tIns="0" rIns="0" bIns="0" rtlCol="0" anchor="ctr"/>
           <a:lstStyle/>
           <a:p>
             <a:pPr algn="ctr" indent="0" marL="0">
               <a:buNone/>
             </a:pPr>
             <a:r>
-              <a:rPr lang="en-US" sz="3600" b="1" dirty="0">
-                <a:solidFill>
-                  <a:srgbClr val="990011"/>
+              <a:rPr lang="en-US" sz="1600" i="1" dirty="0">
+                <a:solidFill>
+                  <a:srgbClr val="555555"/>
                 </a:solidFill>
                 <a:latin typeface="Times New Roman" pitchFamily="34" charset="0"/>
                 <a:ea typeface="Times New Roman" pitchFamily="34" charset="-122"/>
                 <a:cs typeface="Times New Roman" pitchFamily="34" charset="-120"/>
               </a:rPr>
-              <a:t>Evaluation 1</a:t>
-            </a:r>
-            <a:endParaRPr lang="en-US" sz="3600" dirty="0"/>
-          </a:p>
-        </p:txBody>
-      </p:sp>
-      <p:sp>
-        <p:nvSpPr>
-          <p:cNvPr id="5" name="Text 2"/>
-          <p:cNvSpPr/>
-          <p:nvPr/>
-        </p:nvSpPr>
-        <p:spPr>
-          <a:xfrm>
-            <a:off x="5349240" y="1783080"/>
-            <a:ext cx="6522415" cy="4663440"/>
-          </a:xfrm>
-          <a:prstGeom prst="rect">
-            <a:avLst/>
-          </a:prstGeom>
-          <a:noFill/>
-          <a:ln/>
-        </p:spPr>
-        <p:txBody>
-          <a:bodyPr wrap="square" lIns="0" tIns="0" rIns="0" bIns="0" rtlCol="0" anchor="t"/>
-          <a:lstStyle/>
-          <a:p>
-            <a:pPr algn="l" indent="0" marL="0">
-              <a:spcAft>
-                <a:spcPts val="800"/>
-              </a:spcAft>
-              <a:buNone/>
-            </a:pPr>
-            <a:r>
-              <a:rPr lang="en-US" sz="4000" dirty="0">
-                <a:solidFill>
-                  <a:srgbClr val="111111"/>
-                </a:solidFill>
-                <a:latin typeface="Times New Roman" pitchFamily="34" charset="0"/>
-                <a:ea typeface="Times New Roman" pitchFamily="34" charset="-122"/>
-                <a:cs typeface="Times New Roman" pitchFamily="34" charset="-120"/>
-              </a:rPr>
-              <a:t>Distinguish primary data from secondary data, with one example from Garoua for each.</a:t>
-            </a:r>
-            <a:endParaRPr lang="en-US" sz="4000" dirty="0"/>
+              <a:t>Illustration: a questionnaire</a:t>
+            </a:r>
+            <a:endParaRPr lang="en-US" sz="1600" dirty="0"/>
           </a:p>
         </p:txBody>
       </p:sp>
@@ -19045,7 +19435,7 @@
                 <a:ea typeface="Calibri" pitchFamily="34" charset="-122"/>
                 <a:cs typeface="Calibri" pitchFamily="34" charset="-120"/>
               </a:rPr>
-              <a:t>FORMATIVE EVALUATION</a:t>
+              <a:t>BOARD SUMMARY</a:t>
             </a:r>
             <a:endParaRPr lang="en-US" sz="1400" dirty="0"/>
           </a:p>
@@ -19068,7 +19458,7 @@
         <p:spPr>
           <a:xfrm>
             <a:off x="0" y="658368"/>
-            <a:ext cx="5120640" cy="5833872"/>
+            <a:ext cx="3840480" cy="5833872"/>
           </a:xfrm>
           <a:prstGeom prst="rect">
             <a:avLst/>
@@ -19083,8 +19473,8 @@
         </p:nvSpPr>
         <p:spPr>
           <a:xfrm>
-            <a:off x="5349240" y="1005840"/>
-            <a:ext cx="6522415" cy="731520"/>
+            <a:off x="4069080" y="1005840"/>
+            <a:ext cx="7802575" cy="731520"/>
           </a:xfrm>
           <a:prstGeom prst="rect">
             <a:avLst/>
@@ -19110,7 +19500,7 @@
                 <a:ea typeface="Times New Roman" pitchFamily="34" charset="-122"/>
                 <a:cs typeface="Times New Roman" pitchFamily="34" charset="-120"/>
               </a:rPr>
-              <a:t>Expected Answer</a:t>
+              <a:t>3. Primary Data Collection Techniques</a:t>
             </a:r>
             <a:endParaRPr lang="en-US" sz="3600" dirty="0"/>
           </a:p>
@@ -19124,8 +19514,47 @@
         </p:nvSpPr>
         <p:spPr>
           <a:xfrm>
-            <a:off x="5349240" y="1783080"/>
-            <a:ext cx="6522415" cy="4663440"/>
+            <a:off x="4069080" y="1737360"/>
+            <a:ext cx="7802575" cy="457200"/>
+          </a:xfrm>
+          <a:prstGeom prst="rect">
+            <a:avLst/>
+          </a:prstGeom>
+          <a:noFill/>
+          <a:ln/>
+        </p:spPr>
+        <p:txBody>
+          <a:bodyPr wrap="square" lIns="0" tIns="0" rIns="0" bIns="0" rtlCol="0" anchor="ctr"/>
+          <a:lstStyle/>
+          <a:p>
+            <a:pPr algn="l" indent="0" marL="0">
+              <a:buNone/>
+            </a:pPr>
+            <a:r>
+              <a:rPr lang="en-US" sz="2600" b="1" dirty="0">
+                <a:solidFill>
+                  <a:srgbClr val="990011"/>
+                </a:solidFill>
+                <a:latin typeface="Times New Roman" pitchFamily="34" charset="0"/>
+                <a:ea typeface="Times New Roman" pitchFamily="34" charset="-122"/>
+                <a:cs typeface="Times New Roman" pitchFamily="34" charset="-120"/>
+              </a:rPr>
+              <a:t>B) Questionnaires, Interviews and Focus Groups</a:t>
+            </a:r>
+            <a:endParaRPr lang="en-US" sz="2600" dirty="0"/>
+          </a:p>
+        </p:txBody>
+      </p:sp>
+      <p:sp>
+        <p:nvSpPr>
+          <p:cNvPr id="6" name="Text 3"/>
+          <p:cNvSpPr/>
+          <p:nvPr/>
+        </p:nvSpPr>
+        <p:spPr>
+          <a:xfrm>
+            <a:off x="4069080" y="2240280"/>
+            <a:ext cx="7802575" cy="4206240"/>
           </a:xfrm>
           <a:prstGeom prst="rect">
             <a:avLst/>
@@ -19144,7 +19573,7 @@
               <a:buNone/>
             </a:pPr>
             <a:r>
-              <a:rPr lang="en-US" sz="4000" dirty="0">
+              <a:rPr lang="en-US" sz="4000" b="1" dirty="0">
                 <a:solidFill>
                   <a:srgbClr val="111111"/>
                 </a:solidFill>
@@ -19152,7 +19581,24 @@
                 <a:ea typeface="Times New Roman" pitchFamily="34" charset="-122"/>
                 <a:cs typeface="Times New Roman" pitchFamily="34" charset="-120"/>
               </a:rPr>
-              <a:t>Primary: collected by the researcher (counting motos at a crossroads); secondary: already published (BUCREP census figures).</a:t>
+              <a:t>Interviews: </a:t>
+            </a:r>
+            <a:pPr algn="l" indent="0" marL="0">
+              <a:spcAft>
+                <a:spcPts val="800"/>
+              </a:spcAft>
+              <a:buNone/>
+            </a:pPr>
+            <a:r>
+              <a:rPr lang="en-US" sz="4000" dirty="0">
+                <a:solidFill>
+                  <a:srgbClr val="111111"/>
+                </a:solidFill>
+                <a:latin typeface="Times New Roman" pitchFamily="34" charset="0"/>
+                <a:ea typeface="Times New Roman" pitchFamily="34" charset="-122"/>
+                <a:cs typeface="Times New Roman" pitchFamily="34" charset="-120"/>
+              </a:rPr>
+              <a:t>They are face-to-face or telephone conversations with respondents. They can be structured, with fixed questions, or unstructured, like a free conversation.</a:t>
             </a:r>
             <a:endParaRPr lang="en-US" sz="4000" dirty="0"/>
           </a:p>
@@ -19264,7 +19710,7 @@
                 <a:ea typeface="Calibri" pitchFamily="34" charset="-122"/>
                 <a:cs typeface="Calibri" pitchFamily="34" charset="-120"/>
               </a:rPr>
-              <a:t>FORMATIVE EVALUATION</a:t>
+              <a:t>BOARD SUMMARY</a:t>
             </a:r>
             <a:endParaRPr lang="en-US" sz="1400" dirty="0"/>
           </a:p>
@@ -19287,7 +19733,7 @@
         <p:spPr>
           <a:xfrm>
             <a:off x="0" y="658368"/>
-            <a:ext cx="5120640" cy="5833872"/>
+            <a:ext cx="2468880" cy="5833872"/>
           </a:xfrm>
           <a:prstGeom prst="rect">
             <a:avLst/>
@@ -19302,8 +19748,8 @@
         </p:nvSpPr>
         <p:spPr>
           <a:xfrm>
-            <a:off x="5349240" y="1005840"/>
-            <a:ext cx="6522415" cy="731520"/>
+            <a:off x="2697480" y="1005840"/>
+            <a:ext cx="9174175" cy="731520"/>
           </a:xfrm>
           <a:prstGeom prst="rect">
             <a:avLst/>
@@ -19329,7 +19775,7 @@
                 <a:ea typeface="Times New Roman" pitchFamily="34" charset="-122"/>
                 <a:cs typeface="Times New Roman" pitchFamily="34" charset="-120"/>
               </a:rPr>
-              <a:t>Evaluation 2</a:t>
+              <a:t>3. Primary Data Collection Techniques</a:t>
             </a:r>
             <a:endParaRPr lang="en-US" sz="3600" dirty="0"/>
           </a:p>
@@ -19343,8 +19789,47 @@
         </p:nvSpPr>
         <p:spPr>
           <a:xfrm>
-            <a:off x="5349240" y="1783080"/>
-            <a:ext cx="6522415" cy="4663440"/>
+            <a:off x="2697480" y="1737360"/>
+            <a:ext cx="9174175" cy="457200"/>
+          </a:xfrm>
+          <a:prstGeom prst="rect">
+            <a:avLst/>
+          </a:prstGeom>
+          <a:noFill/>
+          <a:ln/>
+        </p:spPr>
+        <p:txBody>
+          <a:bodyPr wrap="square" lIns="0" tIns="0" rIns="0" bIns="0" rtlCol="0" anchor="ctr"/>
+          <a:lstStyle/>
+          <a:p>
+            <a:pPr algn="l" indent="0" marL="0">
+              <a:buNone/>
+            </a:pPr>
+            <a:r>
+              <a:rPr lang="en-US" sz="3100" b="1" dirty="0">
+                <a:solidFill>
+                  <a:srgbClr val="990011"/>
+                </a:solidFill>
+                <a:latin typeface="Times New Roman" pitchFamily="34" charset="0"/>
+                <a:ea typeface="Times New Roman" pitchFamily="34" charset="-122"/>
+                <a:cs typeface="Times New Roman" pitchFamily="34" charset="-120"/>
+              </a:rPr>
+              <a:t>B) Questionnaires, Interviews and Focus Groups</a:t>
+            </a:r>
+            <a:endParaRPr lang="en-US" sz="3100" dirty="0"/>
+          </a:p>
+        </p:txBody>
+      </p:sp>
+      <p:sp>
+        <p:nvSpPr>
+          <p:cNvPr id="6" name="Text 3"/>
+          <p:cNvSpPr/>
+          <p:nvPr/>
+        </p:nvSpPr>
+        <p:spPr>
+          <a:xfrm>
+            <a:off x="2697480" y="2240280"/>
+            <a:ext cx="9174175" cy="4206240"/>
           </a:xfrm>
           <a:prstGeom prst="rect">
             <a:avLst/>
@@ -19363,7 +19848,7 @@
               <a:buNone/>
             </a:pPr>
             <a:r>
-              <a:rPr lang="en-US" sz="4000" dirty="0">
+              <a:rPr lang="en-US" sz="4000" b="1" dirty="0">
                 <a:solidFill>
                   <a:srgbClr val="111111"/>
                 </a:solidFill>
@@ -19371,7 +19856,24 @@
                 <a:ea typeface="Times New Roman" pitchFamily="34" charset="-122"/>
                 <a:cs typeface="Times New Roman" pitchFamily="34" charset="-120"/>
               </a:rPr>
-              <a:t>Explain how to select 30 people from a list of 600 by systematic sampling.</a:t>
+              <a:t>Focus group discussions: </a:t>
+            </a:r>
+            <a:pPr algn="l" indent="0" marL="0">
+              <a:spcAft>
+                <a:spcPts val="800"/>
+              </a:spcAft>
+              <a:buNone/>
+            </a:pPr>
+            <a:r>
+              <a:rPr lang="en-US" sz="4000" dirty="0">
+                <a:solidFill>
+                  <a:srgbClr val="111111"/>
+                </a:solidFill>
+                <a:latin typeface="Times New Roman" pitchFamily="34" charset="0"/>
+                <a:ea typeface="Times New Roman" pitchFamily="34" charset="-122"/>
+                <a:cs typeface="Times New Roman" pitchFamily="34" charset="-120"/>
+              </a:rPr>
+              <a:t>A small group of 6 to 10 people who share a characteristic discusses a topic guided by the researcher. For example, cotton farmers near Garoua discuss the effects of climate change on their harvests.</a:t>
             </a:r>
             <a:endParaRPr lang="en-US" sz="4000" dirty="0"/>
           </a:p>
@@ -19548,7 +20050,7 @@
                 <a:ea typeface="Times New Roman" pitchFamily="34" charset="-122"/>
                 <a:cs typeface="Times New Roman" pitchFamily="34" charset="-120"/>
               </a:rPr>
-              <a:t>Expected Answer</a:t>
+              <a:t>Evaluation 1</a:t>
             </a:r>
             <a:endParaRPr lang="en-US" sz="3600" dirty="0"/>
           </a:p>
@@ -19590,7 +20092,7 @@
                 <a:ea typeface="Times New Roman" pitchFamily="34" charset="-122"/>
                 <a:cs typeface="Times New Roman" pitchFamily="34" charset="-120"/>
               </a:rPr>
-              <a:t>k = 600 ÷ 30 = 20; choose a random start between 1 and 20, then every 20th person.</a:t>
+              <a:t>Distinguish primary data from secondary data, with one example from Garoua for each.</a:t>
             </a:r>
             <a:endParaRPr lang="en-US" sz="4000" dirty="0"/>
           </a:p>
@@ -19702,7 +20204,7 @@
                 <a:ea typeface="Calibri" pitchFamily="34" charset="-122"/>
                 <a:cs typeface="Calibri" pitchFamily="34" charset="-120"/>
               </a:rPr>
-              <a:t>REMEDIATION</a:t>
+              <a:t>FORMATIVE EVALUATION</a:t>
             </a:r>
             <a:endParaRPr lang="en-US" sz="1400" dirty="0"/>
           </a:p>
@@ -19767,7 +20269,7 @@
                 <a:ea typeface="Times New Roman" pitchFamily="34" charset="-122"/>
                 <a:cs typeface="Times New Roman" pitchFamily="34" charset="-120"/>
               </a:rPr>
-              <a:t>Remediation</a:t>
+              <a:t>Expected Answer</a:t>
             </a:r>
             <a:endParaRPr lang="en-US" sz="3600" dirty="0"/>
           </a:p>
@@ -19801,7 +20303,7 @@
               <a:buNone/>
             </a:pPr>
             <a:r>
-              <a:rPr lang="en-US" sz="4000" b="1" dirty="0">
+              <a:rPr lang="en-US" sz="4000" dirty="0">
                 <a:solidFill>
                   <a:srgbClr val="111111"/>
                 </a:solidFill>
@@ -19809,51 +20311,7 @@
                 <a:ea typeface="Times New Roman" pitchFamily="34" charset="-122"/>
                 <a:cs typeface="Times New Roman" pitchFamily="34" charset="-120"/>
               </a:rPr>
-              <a:t>Fill in the blanks:</a:t>
-            </a:r>
-            <a:endParaRPr lang="en-US" sz="4000" dirty="0"/>
-          </a:p>
-          <a:p>
-            <a:pPr algn="l" marL="342900" indent="-342900">
-              <a:spcAft>
-                <a:spcPts val="800"/>
-              </a:spcAft>
-              <a:buSzPct val="100000"/>
-              <a:buFont typeface="+mj-lt"/>
-              <a:buAutoNum type="arabicPeriod" startAt="1"/>
-            </a:pPr>
-            <a:r>
-              <a:rPr lang="en-US" sz="4000" dirty="0">
-                <a:solidFill>
-                  <a:srgbClr val="111111"/>
-                </a:solidFill>
-                <a:latin typeface="Times New Roman" pitchFamily="34" charset="0"/>
-                <a:ea typeface="Times New Roman" pitchFamily="34" charset="-122"/>
-                <a:cs typeface="Times New Roman" pitchFamily="34" charset="-120"/>
-              </a:rPr>
-              <a:t>Data collected by the researcher are ______ data.</a:t>
-            </a:r>
-            <a:endParaRPr lang="en-US" sz="4000" dirty="0"/>
-          </a:p>
-          <a:p>
-            <a:pPr algn="l" marL="342900" indent="-342900">
-              <a:spcAft>
-                <a:spcPts val="800"/>
-              </a:spcAft>
-              <a:buSzPct val="100000"/>
-              <a:buFont typeface="+mj-lt"/>
-              <a:buAutoNum type="arabicPeriod" startAt="1"/>
-            </a:pPr>
-            <a:r>
-              <a:rPr lang="en-US" sz="4000" dirty="0">
-                <a:solidFill>
-                  <a:srgbClr val="111111"/>
-                </a:solidFill>
-                <a:latin typeface="Times New Roman" pitchFamily="34" charset="0"/>
-                <a:ea typeface="Times New Roman" pitchFamily="34" charset="-122"/>
-                <a:cs typeface="Times New Roman" pitchFamily="34" charset="-120"/>
-              </a:rPr>
-              <a:t>Choosing every 10th house is ______ sampling.</a:t>
+              <a:t>Primary: collected by the researcher (counting motos at a crossroads); secondary: already published (BUCREP census figures).</a:t>
             </a:r>
             <a:endParaRPr lang="en-US" sz="4000" dirty="0"/>
           </a:p>
@@ -19965,7 +20423,7 @@
                 <a:ea typeface="Calibri" pitchFamily="34" charset="-122"/>
                 <a:cs typeface="Calibri" pitchFamily="34" charset="-120"/>
               </a:rPr>
-              <a:t>REMEDIATION</a:t>
+              <a:t>FORMATIVE EVALUATION</a:t>
             </a:r>
             <a:endParaRPr lang="en-US" sz="1400" dirty="0"/>
           </a:p>
@@ -20030,7 +20488,7 @@
                 <a:ea typeface="Times New Roman" pitchFamily="34" charset="-122"/>
                 <a:cs typeface="Times New Roman" pitchFamily="34" charset="-120"/>
               </a:rPr>
-              <a:t>Remediation (continued)</a:t>
+              <a:t>Evaluation 2</a:t>
             </a:r>
             <a:endParaRPr lang="en-US" sz="3600" dirty="0"/>
           </a:p>
@@ -20057,13 +20515,11 @@
           <a:bodyPr wrap="square" lIns="0" tIns="0" rIns="0" bIns="0" rtlCol="0" anchor="t"/>
           <a:lstStyle/>
           <a:p>
-            <a:pPr algn="l" marL="342900" indent="-342900">
+            <a:pPr algn="l" indent="0" marL="0">
               <a:spcAft>
                 <a:spcPts val="800"/>
               </a:spcAft>
-              <a:buSzPct val="100000"/>
-              <a:buFont typeface="+mj-lt"/>
-              <a:buAutoNum type="arabicPeriod" startAt="1"/>
+              <a:buNone/>
             </a:pPr>
             <a:r>
               <a:rPr lang="en-US" sz="4000" dirty="0">
@@ -20074,7 +20530,7 @@
                 <a:ea typeface="Times New Roman" pitchFamily="34" charset="-122"/>
                 <a:cs typeface="Times New Roman" pitchFamily="34" charset="-120"/>
               </a:rPr>
-              <a:t>Dividing the population into groups first is ______ sampling.</a:t>
+              <a:t>Explain how to select 30 people from a list of 600 by systematic sampling.</a:t>
             </a:r>
             <a:endParaRPr lang="en-US" sz="4000" dirty="0"/>
           </a:p>
@@ -20186,7 +20642,7 @@
                 <a:ea typeface="Calibri" pitchFamily="34" charset="-122"/>
                 <a:cs typeface="Calibri" pitchFamily="34" charset="-120"/>
               </a:rPr>
-              <a:t>HOMEWORK</a:t>
+              <a:t>FORMATIVE EVALUATION</a:t>
             </a:r>
             <a:endParaRPr lang="en-US" sz="1400" dirty="0"/>
           </a:p>
@@ -20251,7 +20707,7 @@
                 <a:ea typeface="Times New Roman" pitchFamily="34" charset="-122"/>
                 <a:cs typeface="Times New Roman" pitchFamily="34" charset="-120"/>
               </a:rPr>
-              <a:t>Homework</a:t>
+              <a:t>Expected Answer</a:t>
             </a:r>
             <a:endParaRPr lang="en-US" sz="3600" dirty="0"/>
           </a:p>
@@ -20293,7 +20749,7 @@
                 <a:ea typeface="Times New Roman" pitchFamily="34" charset="-122"/>
                 <a:cs typeface="Times New Roman" pitchFamily="34" charset="-120"/>
               </a:rPr>
-              <a:t>Define the arithmetic mean.</a:t>
+              <a:t>k = 600 ÷ 30 = 20; choose a random start between 1 and 20, then every 20th person.</a:t>
             </a:r>
             <a:endParaRPr lang="en-US" sz="4000" dirty="0"/>
           </a:p>
@@ -20405,7 +20861,7 @@
                 <a:ea typeface="Calibri" pitchFamily="34" charset="-122"/>
                 <a:cs typeface="Calibri" pitchFamily="34" charset="-120"/>
               </a:rPr>
-              <a:t>NEXT LESSON</a:t>
+              <a:t>REMEDIATION</a:t>
             </a:r>
             <a:endParaRPr lang="en-US" sz="1400" dirty="0"/>
           </a:p>
@@ -20470,7 +20926,7 @@
                 <a:ea typeface="Times New Roman" pitchFamily="34" charset="-122"/>
                 <a:cs typeface="Times New Roman" pitchFamily="34" charset="-120"/>
               </a:rPr>
-              <a:t>Next Lesson</a:t>
+              <a:t>Remediation</a:t>
             </a:r>
             <a:endParaRPr lang="en-US" sz="3600" dirty="0"/>
           </a:p>
@@ -20494,10 +20950,10 @@
           <a:ln/>
         </p:spPr>
         <p:txBody>
-          <a:bodyPr wrap="square" lIns="0" tIns="0" rIns="0" bIns="0" rtlCol="0" anchor="ctr"/>
-          <a:lstStyle/>
-          <a:p>
-            <a:pPr algn="ctr" indent="0" marL="0">
+          <a:bodyPr wrap="square" lIns="0" tIns="0" rIns="0" bIns="0" rtlCol="0" anchor="t"/>
+          <a:lstStyle/>
+          <a:p>
+            <a:pPr algn="l" indent="0" marL="0">
               <a:spcAft>
                 <a:spcPts val="800"/>
               </a:spcAft>
@@ -20512,27 +20968,51 @@
                 <a:ea typeface="Times New Roman" pitchFamily="34" charset="-122"/>
                 <a:cs typeface="Times New Roman" pitchFamily="34" charset="-120"/>
               </a:rPr>
-              <a:t>Our next lesson will be on:</a:t>
+              <a:t>Fill in the blanks:</a:t>
             </a:r>
             <a:endParaRPr lang="en-US" sz="4000" dirty="0"/>
           </a:p>
           <a:p>
-            <a:pPr algn="ctr" indent="0" marL="0">
+            <a:pPr algn="l" marL="342900" indent="-342900">
               <a:spcAft>
                 <a:spcPts val="800"/>
               </a:spcAft>
-              <a:buNone/>
+              <a:buSzPct val="100000"/>
+              <a:buFont typeface="+mj-lt"/>
+              <a:buAutoNum type="arabicPeriod" startAt="1"/>
             </a:pPr>
             <a:r>
-              <a:rPr lang="en-US" sz="4000" b="1" dirty="0">
-                <a:solidFill>
-                  <a:srgbClr val="990011"/>
+              <a:rPr lang="en-US" sz="4000" dirty="0">
+                <a:solidFill>
+                  <a:srgbClr val="111111"/>
                 </a:solidFill>
                 <a:latin typeface="Times New Roman" pitchFamily="34" charset="0"/>
                 <a:ea typeface="Times New Roman" pitchFamily="34" charset="-122"/>
                 <a:cs typeface="Times New Roman" pitchFamily="34" charset="-120"/>
               </a:rPr>
-              <a:t>Quantitative Techniques 3 (Part 1): Measures of Central Tendency, Range and Quartiles</a:t>
+              <a:t>Data collected by the researcher are ______ data.</a:t>
+            </a:r>
+            <a:endParaRPr lang="en-US" sz="4000" dirty="0"/>
+          </a:p>
+          <a:p>
+            <a:pPr algn="l" marL="342900" indent="-342900">
+              <a:spcAft>
+                <a:spcPts val="800"/>
+              </a:spcAft>
+              <a:buSzPct val="100000"/>
+              <a:buFont typeface="+mj-lt"/>
+              <a:buAutoNum type="arabicPeriod" startAt="1"/>
+            </a:pPr>
+            <a:r>
+              <a:rPr lang="en-US" sz="4000" dirty="0">
+                <a:solidFill>
+                  <a:srgbClr val="111111"/>
+                </a:solidFill>
+                <a:latin typeface="Times New Roman" pitchFamily="34" charset="0"/>
+                <a:ea typeface="Times New Roman" pitchFamily="34" charset="-122"/>
+                <a:cs typeface="Times New Roman" pitchFamily="34" charset="-120"/>
+              </a:rPr>
+              <a:t>Choosing every 10th house is ______ sampling.</a:t>
             </a:r>
             <a:endParaRPr lang="en-US" sz="4000" dirty="0"/>
           </a:p>
@@ -20644,6 +21124,1016 @@
                 <a:ea typeface="Calibri" pitchFamily="34" charset="-122"/>
                 <a:cs typeface="Calibri" pitchFamily="34" charset="-120"/>
               </a:rPr>
+              <a:t>REMEDIATION</a:t>
+            </a:r>
+            <a:endParaRPr lang="en-US" sz="1400" dirty="0"/>
+          </a:p>
+        </p:txBody>
+      </p:sp>
+      <p:pic>
+        <p:nvPicPr>
+          <p:cNvPr id="3" name="Image 0" descr="/home/claude/f4/img/minesec_sheet.png">    </p:cNvPr>
+          <p:cNvPicPr>
+            <a:picLocks noChangeAspect="1"/>
+          </p:cNvPicPr>
+          <p:nvPr/>
+        </p:nvPicPr>
+        <p:blipFill>
+          <a:blip r:embed="rId1"/>
+          <a:stretch>
+            <a:fillRect/>
+          </a:stretch>
+        </p:blipFill>
+        <p:spPr>
+          <a:xfrm>
+            <a:off x="0" y="658368"/>
+            <a:ext cx="5120640" cy="5833872"/>
+          </a:xfrm>
+          <a:prstGeom prst="rect">
+            <a:avLst/>
+          </a:prstGeom>
+        </p:spPr>
+      </p:pic>
+      <p:sp>
+        <p:nvSpPr>
+          <p:cNvPr id="4" name="Text 1"/>
+          <p:cNvSpPr/>
+          <p:nvPr/>
+        </p:nvSpPr>
+        <p:spPr>
+          <a:xfrm>
+            <a:off x="5349240" y="1005840"/>
+            <a:ext cx="6522415" cy="731520"/>
+          </a:xfrm>
+          <a:prstGeom prst="rect">
+            <a:avLst/>
+          </a:prstGeom>
+          <a:noFill/>
+          <a:ln/>
+        </p:spPr>
+        <p:txBody>
+          <a:bodyPr wrap="square" lIns="0" tIns="0" rIns="0" bIns="0" rtlCol="0" anchor="ctr">
+            <a:normAutofit/>
+          </a:bodyPr>
+          <a:lstStyle/>
+          <a:p>
+            <a:pPr algn="ctr" indent="0" marL="0">
+              <a:buNone/>
+            </a:pPr>
+            <a:r>
+              <a:rPr lang="en-US" sz="3600" b="1" dirty="0">
+                <a:solidFill>
+                  <a:srgbClr val="990011"/>
+                </a:solidFill>
+                <a:latin typeface="Times New Roman" pitchFamily="34" charset="0"/>
+                <a:ea typeface="Times New Roman" pitchFamily="34" charset="-122"/>
+                <a:cs typeface="Times New Roman" pitchFamily="34" charset="-120"/>
+              </a:rPr>
+              <a:t>Remediation (continued)</a:t>
+            </a:r>
+            <a:endParaRPr lang="en-US" sz="3600" dirty="0"/>
+          </a:p>
+        </p:txBody>
+      </p:sp>
+      <p:sp>
+        <p:nvSpPr>
+          <p:cNvPr id="5" name="Text 2"/>
+          <p:cNvSpPr/>
+          <p:nvPr/>
+        </p:nvSpPr>
+        <p:spPr>
+          <a:xfrm>
+            <a:off x="5349240" y="1783080"/>
+            <a:ext cx="6522415" cy="4663440"/>
+          </a:xfrm>
+          <a:prstGeom prst="rect">
+            <a:avLst/>
+          </a:prstGeom>
+          <a:noFill/>
+          <a:ln/>
+        </p:spPr>
+        <p:txBody>
+          <a:bodyPr wrap="square" lIns="0" tIns="0" rIns="0" bIns="0" rtlCol="0" anchor="t"/>
+          <a:lstStyle/>
+          <a:p>
+            <a:pPr algn="l" marL="342900" indent="-342900">
+              <a:spcAft>
+                <a:spcPts val="800"/>
+              </a:spcAft>
+              <a:buSzPct val="100000"/>
+              <a:buFont typeface="+mj-lt"/>
+              <a:buAutoNum type="arabicPeriod" startAt="1"/>
+            </a:pPr>
+            <a:r>
+              <a:rPr lang="en-US" sz="4000" dirty="0">
+                <a:solidFill>
+                  <a:srgbClr val="111111"/>
+                </a:solidFill>
+                <a:latin typeface="Times New Roman" pitchFamily="34" charset="0"/>
+                <a:ea typeface="Times New Roman" pitchFamily="34" charset="-122"/>
+                <a:cs typeface="Times New Roman" pitchFamily="34" charset="-120"/>
+              </a:rPr>
+              <a:t>Dividing the population into groups first is ______ sampling.</a:t>
+            </a:r>
+            <a:endParaRPr lang="en-US" sz="4000" dirty="0"/>
+          </a:p>
+        </p:txBody>
+      </p:sp>
+      <p:sp>
+        <p:nvSpPr>
+          <p:cNvPr id="25" name="Slide Number Placeholder 0"/>
+          <p:cNvSpPr>
+            <a:spLocks noGrp="1"/>
+          </p:cNvSpPr>
+          <p:nvPr>
+            <p:ph type="sldNum" sz="quarter" idx="4294967295"/>
+          </p:nvPr>
+        </p:nvSpPr>
+        <p:spPr>
+          <a:xfrm>
+            <a:off x="27432" y="91440"/>
+            <a:ext cx="585216" cy="475488"/>
+          </a:xfrm>
+          <a:prstGeom prst="rect">
+            <a:avLst/>
+          </a:prstGeom>
+          <a:extLst>
+            <a:ext uri="{C572A759-6A51-4108-AA02-DFA0A04FC94B}">
+              <ma14:wrappingTextBoxFlag xmlns:ma14="http://schemas.microsoft.com/office/mac/drawingml/2011/main" val="0"/>
+            </a:ext>
+          </a:extLst>
+        </p:spPr>
+        <p:txBody>
+          <a:bodyPr/>
+          <a:lstStyle>
+            <a:lvl1pPr>
+              <a:defRPr sz="2000">
+                <a:solidFill>
+                  <a:srgbClr val="FFFFFF"/>
+                </a:solidFill>
+                <a:latin typeface="Calibri"/>
+                <a:ea typeface="Calibri"/>
+                <a:cs typeface="Calibri"/>
+              </a:defRPr>
+            </a:lvl1pPr>
+          </a:lstStyle>
+          <a:p>
+            <a:pPr algn="ctr"/>
+            <a:fld id="{F7021451-1387-4CA6-816F-3879F97B5CBC}" type="slidenum">
+              <a:rPr b="1" lang="en-US"/>
+              <a:t>58</a:t>
+            </a:fld>
+            <a:endParaRPr lang="en-US"/>
+          </a:p>
+        </p:txBody>
+      </p:sp>
+    </p:spTree>
+  </p:cSld>
+  <p:clrMapOvr>
+    <a:masterClrMapping/>
+  </p:clrMapOvr>
+</p:sld>
+</file>
+
+<file path=ppt/slides/slide59.xml><?xml version="1.0" encoding="utf-8"?>
+<p:sld xmlns:a="http://schemas.openxmlformats.org/drawingml/2006/main" xmlns:r="http://schemas.openxmlformats.org/officeDocument/2006/relationships" xmlns:p="http://schemas.openxmlformats.org/presentationml/2006/main">
+  <p:cSld name="Slide 59">
+    <p:spTree>
+      <p:nvGrpSpPr>
+        <p:cNvPr id="1" name=""/>
+        <p:cNvGrpSpPr/>
+        <p:nvPr/>
+      </p:nvGrpSpPr>
+      <p:grpSpPr>
+        <a:xfrm>
+          <a:off x="0" y="0"/>
+          <a:ext cx="0" cy="0"/>
+          <a:chOff x="0" y="0"/>
+          <a:chExt cx="0" cy="0"/>
+        </a:xfrm>
+      </p:grpSpPr>
+      <p:sp>
+        <p:nvSpPr>
+          <p:cNvPr id="2" name="Text 0"/>
+          <p:cNvSpPr/>
+          <p:nvPr/>
+        </p:nvSpPr>
+        <p:spPr>
+          <a:xfrm>
+            <a:off x="457200" y="713232"/>
+            <a:ext cx="11368735" cy="274320"/>
+          </a:xfrm>
+          <a:prstGeom prst="rect">
+            <a:avLst/>
+          </a:prstGeom>
+          <a:noFill/>
+          <a:ln/>
+        </p:spPr>
+        <p:txBody>
+          <a:bodyPr wrap="square" lIns="0" tIns="0" rIns="0" bIns="0" rtlCol="0" anchor="ctr"/>
+          <a:lstStyle/>
+          <a:p>
+            <a:pPr algn="r" indent="0" marL="0">
+              <a:buNone/>
+            </a:pPr>
+            <a:r>
+              <a:rPr lang="en-US" sz="1400" b="1" dirty="0">
+                <a:solidFill>
+                  <a:srgbClr val="1C3F6E"/>
+                </a:solidFill>
+                <a:latin typeface="Calibri" pitchFamily="34" charset="0"/>
+                <a:ea typeface="Calibri" pitchFamily="34" charset="-122"/>
+                <a:cs typeface="Calibri" pitchFamily="34" charset="-120"/>
+              </a:rPr>
+              <a:t>HOMEWORK</a:t>
+            </a:r>
+            <a:endParaRPr lang="en-US" sz="1400" dirty="0"/>
+          </a:p>
+        </p:txBody>
+      </p:sp>
+      <p:pic>
+        <p:nvPicPr>
+          <p:cNvPr id="3" name="Image 0" descr="/home/claude/f4/img/minesec_sheet.png">    </p:cNvPr>
+          <p:cNvPicPr>
+            <a:picLocks noChangeAspect="1"/>
+          </p:cNvPicPr>
+          <p:nvPr/>
+        </p:nvPicPr>
+        <p:blipFill>
+          <a:blip r:embed="rId1"/>
+          <a:stretch>
+            <a:fillRect/>
+          </a:stretch>
+        </p:blipFill>
+        <p:spPr>
+          <a:xfrm>
+            <a:off x="0" y="658368"/>
+            <a:ext cx="5120640" cy="5833872"/>
+          </a:xfrm>
+          <a:prstGeom prst="rect">
+            <a:avLst/>
+          </a:prstGeom>
+        </p:spPr>
+      </p:pic>
+      <p:sp>
+        <p:nvSpPr>
+          <p:cNvPr id="4" name="Text 1"/>
+          <p:cNvSpPr/>
+          <p:nvPr/>
+        </p:nvSpPr>
+        <p:spPr>
+          <a:xfrm>
+            <a:off x="5349240" y="1005840"/>
+            <a:ext cx="6522415" cy="731520"/>
+          </a:xfrm>
+          <a:prstGeom prst="rect">
+            <a:avLst/>
+          </a:prstGeom>
+          <a:noFill/>
+          <a:ln/>
+        </p:spPr>
+        <p:txBody>
+          <a:bodyPr wrap="square" lIns="0" tIns="0" rIns="0" bIns="0" rtlCol="0" anchor="ctr">
+            <a:normAutofit/>
+          </a:bodyPr>
+          <a:lstStyle/>
+          <a:p>
+            <a:pPr algn="ctr" indent="0" marL="0">
+              <a:buNone/>
+            </a:pPr>
+            <a:r>
+              <a:rPr lang="en-US" sz="3600" b="1" dirty="0">
+                <a:solidFill>
+                  <a:srgbClr val="990011"/>
+                </a:solidFill>
+                <a:latin typeface="Times New Roman" pitchFamily="34" charset="0"/>
+                <a:ea typeface="Times New Roman" pitchFamily="34" charset="-122"/>
+                <a:cs typeface="Times New Roman" pitchFamily="34" charset="-120"/>
+              </a:rPr>
+              <a:t>Homework</a:t>
+            </a:r>
+            <a:endParaRPr lang="en-US" sz="3600" dirty="0"/>
+          </a:p>
+        </p:txBody>
+      </p:sp>
+      <p:sp>
+        <p:nvSpPr>
+          <p:cNvPr id="5" name="Text 2"/>
+          <p:cNvSpPr/>
+          <p:nvPr/>
+        </p:nvSpPr>
+        <p:spPr>
+          <a:xfrm>
+            <a:off x="5349240" y="1783080"/>
+            <a:ext cx="6522415" cy="4663440"/>
+          </a:xfrm>
+          <a:prstGeom prst="rect">
+            <a:avLst/>
+          </a:prstGeom>
+          <a:noFill/>
+          <a:ln/>
+        </p:spPr>
+        <p:txBody>
+          <a:bodyPr wrap="square" lIns="0" tIns="0" rIns="0" bIns="0" rtlCol="0" anchor="t"/>
+          <a:lstStyle/>
+          <a:p>
+            <a:pPr algn="l" indent="0" marL="0">
+              <a:spcAft>
+                <a:spcPts val="800"/>
+              </a:spcAft>
+              <a:buNone/>
+            </a:pPr>
+            <a:r>
+              <a:rPr lang="en-US" sz="4000" dirty="0">
+                <a:solidFill>
+                  <a:srgbClr val="111111"/>
+                </a:solidFill>
+                <a:latin typeface="Times New Roman" pitchFamily="34" charset="0"/>
+                <a:ea typeface="Times New Roman" pitchFamily="34" charset="-122"/>
+                <a:cs typeface="Times New Roman" pitchFamily="34" charset="-120"/>
+              </a:rPr>
+              <a:t>Define the arithmetic mean.</a:t>
+            </a:r>
+            <a:endParaRPr lang="en-US" sz="4000" dirty="0"/>
+          </a:p>
+        </p:txBody>
+      </p:sp>
+      <p:sp>
+        <p:nvSpPr>
+          <p:cNvPr id="25" name="Slide Number Placeholder 0"/>
+          <p:cNvSpPr>
+            <a:spLocks noGrp="1"/>
+          </p:cNvSpPr>
+          <p:nvPr>
+            <p:ph type="sldNum" sz="quarter" idx="4294967295"/>
+          </p:nvPr>
+        </p:nvSpPr>
+        <p:spPr>
+          <a:xfrm>
+            <a:off x="27432" y="91440"/>
+            <a:ext cx="585216" cy="475488"/>
+          </a:xfrm>
+          <a:prstGeom prst="rect">
+            <a:avLst/>
+          </a:prstGeom>
+          <a:extLst>
+            <a:ext uri="{C572A759-6A51-4108-AA02-DFA0A04FC94B}">
+              <ma14:wrappingTextBoxFlag xmlns:ma14="http://schemas.microsoft.com/office/mac/drawingml/2011/main" val="0"/>
+            </a:ext>
+          </a:extLst>
+        </p:spPr>
+        <p:txBody>
+          <a:bodyPr/>
+          <a:lstStyle>
+            <a:lvl1pPr>
+              <a:defRPr sz="2000">
+                <a:solidFill>
+                  <a:srgbClr val="FFFFFF"/>
+                </a:solidFill>
+                <a:latin typeface="Calibri"/>
+                <a:ea typeface="Calibri"/>
+                <a:cs typeface="Calibri"/>
+              </a:defRPr>
+            </a:lvl1pPr>
+          </a:lstStyle>
+          <a:p>
+            <a:pPr algn="ctr"/>
+            <a:fld id="{F7021451-1387-4CA6-816F-3879F97B5CBC}" type="slidenum">
+              <a:rPr b="1" lang="en-US"/>
+              <a:t>59</a:t>
+            </a:fld>
+            <a:endParaRPr lang="en-US"/>
+          </a:p>
+        </p:txBody>
+      </p:sp>
+    </p:spTree>
+  </p:cSld>
+  <p:clrMapOvr>
+    <a:masterClrMapping/>
+  </p:clrMapOvr>
+</p:sld>
+</file>
+
+<file path=ppt/slides/slide6.xml><?xml version="1.0" encoding="utf-8"?>
+<p:sld xmlns:a="http://schemas.openxmlformats.org/drawingml/2006/main" xmlns:r="http://schemas.openxmlformats.org/officeDocument/2006/relationships" xmlns:p="http://schemas.openxmlformats.org/presentationml/2006/main">
+  <p:cSld name="Slide 6">
+    <p:spTree>
+      <p:nvGrpSpPr>
+        <p:cNvPr id="1" name=""/>
+        <p:cNvGrpSpPr/>
+        <p:nvPr/>
+      </p:nvGrpSpPr>
+      <p:grpSpPr>
+        <a:xfrm>
+          <a:off x="0" y="0"/>
+          <a:ext cx="0" cy="0"/>
+          <a:chOff x="0" y="0"/>
+          <a:chExt cx="0" cy="0"/>
+        </a:xfrm>
+      </p:grpSpPr>
+      <p:sp>
+        <p:nvSpPr>
+          <p:cNvPr id="2" name="Text 0"/>
+          <p:cNvSpPr/>
+          <p:nvPr/>
+        </p:nvSpPr>
+        <p:spPr>
+          <a:xfrm>
+            <a:off x="457200" y="713232"/>
+            <a:ext cx="11368735" cy="274320"/>
+          </a:xfrm>
+          <a:prstGeom prst="rect">
+            <a:avLst/>
+          </a:prstGeom>
+          <a:noFill/>
+          <a:ln/>
+        </p:spPr>
+        <p:txBody>
+          <a:bodyPr wrap="square" lIns="0" tIns="0" rIns="0" bIns="0" rtlCol="0" anchor="ctr"/>
+          <a:lstStyle/>
+          <a:p>
+            <a:pPr algn="r" indent="0" marL="0">
+              <a:buNone/>
+            </a:pPr>
+            <a:r>
+              <a:rPr lang="en-US" sz="1400" b="1" dirty="0">
+                <a:solidFill>
+                  <a:srgbClr val="1C3F6E"/>
+                </a:solidFill>
+                <a:latin typeface="Calibri" pitchFamily="34" charset="0"/>
+                <a:ea typeface="Calibri" pitchFamily="34" charset="-122"/>
+                <a:cs typeface="Calibri" pitchFamily="34" charset="-120"/>
+              </a:rPr>
+              <a:t>LESSON PLAN</a:t>
+            </a:r>
+            <a:endParaRPr lang="en-US" sz="1400" dirty="0"/>
+          </a:p>
+        </p:txBody>
+      </p:sp>
+      <p:pic>
+        <p:nvPicPr>
+          <p:cNvPr id="3" name="Image 0" descr="/home/claude/f4/img/minesec_sheet.png">    </p:cNvPr>
+          <p:cNvPicPr>
+            <a:picLocks noChangeAspect="1"/>
+          </p:cNvPicPr>
+          <p:nvPr/>
+        </p:nvPicPr>
+        <p:blipFill>
+          <a:blip r:embed="rId1"/>
+          <a:stretch>
+            <a:fillRect/>
+          </a:stretch>
+        </p:blipFill>
+        <p:spPr>
+          <a:xfrm>
+            <a:off x="0" y="658368"/>
+            <a:ext cx="2468880" cy="5833872"/>
+          </a:xfrm>
+          <a:prstGeom prst="rect">
+            <a:avLst/>
+          </a:prstGeom>
+        </p:spPr>
+      </p:pic>
+      <p:sp>
+        <p:nvSpPr>
+          <p:cNvPr id="4" name="Text 1"/>
+          <p:cNvSpPr/>
+          <p:nvPr/>
+        </p:nvSpPr>
+        <p:spPr>
+          <a:xfrm>
+            <a:off x="2697480" y="1005840"/>
+            <a:ext cx="9174175" cy="731520"/>
+          </a:xfrm>
+          <a:prstGeom prst="rect">
+            <a:avLst/>
+          </a:prstGeom>
+          <a:noFill/>
+          <a:ln/>
+        </p:spPr>
+        <p:txBody>
+          <a:bodyPr wrap="square" lIns="0" tIns="0" rIns="0" bIns="0" rtlCol="0" anchor="ctr">
+            <a:normAutofit/>
+          </a:bodyPr>
+          <a:lstStyle/>
+          <a:p>
+            <a:pPr algn="ctr" indent="0" marL="0">
+              <a:buNone/>
+            </a:pPr>
+            <a:r>
+              <a:rPr lang="en-US" sz="3600" b="1" dirty="0">
+                <a:solidFill>
+                  <a:srgbClr val="990011"/>
+                </a:solidFill>
+                <a:latin typeface="Times New Roman" pitchFamily="34" charset="0"/>
+                <a:ea typeface="Times New Roman" pitchFamily="34" charset="-122"/>
+                <a:cs typeface="Times New Roman" pitchFamily="34" charset="-120"/>
+              </a:rPr>
+              <a:t>Lesson Plan</a:t>
+            </a:r>
+            <a:endParaRPr lang="en-US" sz="3600" dirty="0"/>
+          </a:p>
+        </p:txBody>
+      </p:sp>
+      <p:sp>
+        <p:nvSpPr>
+          <p:cNvPr id="5" name="Text 2"/>
+          <p:cNvSpPr/>
+          <p:nvPr/>
+        </p:nvSpPr>
+        <p:spPr>
+          <a:xfrm>
+            <a:off x="2697480" y="1783080"/>
+            <a:ext cx="9174175" cy="4663440"/>
+          </a:xfrm>
+          <a:prstGeom prst="rect">
+            <a:avLst/>
+          </a:prstGeom>
+          <a:noFill/>
+          <a:ln/>
+        </p:spPr>
+        <p:txBody>
+          <a:bodyPr wrap="square" lIns="0" tIns="0" rIns="0" bIns="0" rtlCol="0" anchor="t"/>
+          <a:lstStyle/>
+          <a:p>
+            <a:pPr algn="l" marL="342900" indent="-342900">
+              <a:spcAft>
+                <a:spcPts val="800"/>
+              </a:spcAft>
+              <a:buSzPct val="100000"/>
+              <a:buFont typeface="+mj-lt"/>
+              <a:buAutoNum type="arabicPeriod" startAt="1"/>
+            </a:pPr>
+            <a:r>
+              <a:rPr lang="en-US" sz="4000" dirty="0">
+                <a:solidFill>
+                  <a:srgbClr val="111111"/>
+                </a:solidFill>
+                <a:latin typeface="Times New Roman" pitchFamily="34" charset="0"/>
+                <a:ea typeface="Times New Roman" pitchFamily="34" charset="-122"/>
+                <a:cs typeface="Times New Roman" pitchFamily="34" charset="-120"/>
+              </a:rPr>
+              <a:t>Correction of the homework</a:t>
+            </a:r>
+            <a:endParaRPr lang="en-US" sz="4000" dirty="0"/>
+          </a:p>
+          <a:p>
+            <a:pPr algn="l" marL="342900" indent="-342900">
+              <a:spcAft>
+                <a:spcPts val="800"/>
+              </a:spcAft>
+              <a:buSzPct val="100000"/>
+              <a:buFont typeface="+mj-lt"/>
+              <a:buAutoNum type="arabicPeriod" startAt="1"/>
+            </a:pPr>
+            <a:r>
+              <a:rPr lang="en-US" sz="4000" dirty="0">
+                <a:solidFill>
+                  <a:srgbClr val="111111"/>
+                </a:solidFill>
+                <a:latin typeface="Times New Roman" pitchFamily="34" charset="0"/>
+                <a:ea typeface="Times New Roman" pitchFamily="34" charset="-122"/>
+                <a:cs typeface="Times New Roman" pitchFamily="34" charset="-120"/>
+              </a:rPr>
+              <a:t>Objectives and recall</a:t>
+            </a:r>
+            <a:endParaRPr lang="en-US" sz="4000" dirty="0"/>
+          </a:p>
+          <a:p>
+            <a:pPr algn="l" marL="342900" indent="-342900">
+              <a:spcAft>
+                <a:spcPts val="800"/>
+              </a:spcAft>
+              <a:buSzPct val="100000"/>
+              <a:buFont typeface="+mj-lt"/>
+              <a:buAutoNum type="arabicPeriod" startAt="1"/>
+            </a:pPr>
+            <a:r>
+              <a:rPr lang="en-US" sz="4000" dirty="0">
+                <a:solidFill>
+                  <a:srgbClr val="111111"/>
+                </a:solidFill>
+                <a:latin typeface="Times New Roman" pitchFamily="34" charset="0"/>
+                <a:ea typeface="Times New Roman" pitchFamily="34" charset="-122"/>
+                <a:cs typeface="Times New Roman" pitchFamily="34" charset="-120"/>
+              </a:rPr>
+              <a:t>Real-life situation and action to take</a:t>
+            </a:r>
+            <a:endParaRPr lang="en-US" sz="4000" dirty="0"/>
+          </a:p>
+          <a:p>
+            <a:pPr algn="l" marL="342900" indent="-342900">
+              <a:spcAft>
+                <a:spcPts val="800"/>
+              </a:spcAft>
+              <a:buSzPct val="100000"/>
+              <a:buFont typeface="+mj-lt"/>
+              <a:buAutoNum type="arabicPeriod" startAt="1"/>
+            </a:pPr>
+            <a:r>
+              <a:rPr lang="en-US" sz="4000" dirty="0">
+                <a:solidFill>
+                  <a:srgbClr val="111111"/>
+                </a:solidFill>
+                <a:latin typeface="Times New Roman" pitchFamily="34" charset="0"/>
+                <a:ea typeface="Times New Roman" pitchFamily="34" charset="-122"/>
+                <a:cs typeface="Times New Roman" pitchFamily="34" charset="-120"/>
+              </a:rPr>
+              <a:t>Learning activities</a:t>
+            </a:r>
+            <a:endParaRPr lang="en-US" sz="4000" dirty="0"/>
+          </a:p>
+          <a:p>
+            <a:pPr algn="l" marL="342900" indent="-342900">
+              <a:spcAft>
+                <a:spcPts val="800"/>
+              </a:spcAft>
+              <a:buSzPct val="100000"/>
+              <a:buFont typeface="+mj-lt"/>
+              <a:buAutoNum type="arabicPeriod" startAt="1"/>
+            </a:pPr>
+            <a:r>
+              <a:rPr lang="en-US" sz="4000" dirty="0">
+                <a:solidFill>
+                  <a:srgbClr val="111111"/>
+                </a:solidFill>
+                <a:latin typeface="Times New Roman" pitchFamily="34" charset="0"/>
+                <a:ea typeface="Times New Roman" pitchFamily="34" charset="-122"/>
+                <a:cs typeface="Times New Roman" pitchFamily="34" charset="-120"/>
+              </a:rPr>
+              <a:t>Board summary</a:t>
+            </a:r>
+            <a:endParaRPr lang="en-US" sz="4000" dirty="0"/>
+          </a:p>
+          <a:p>
+            <a:pPr algn="l" marL="342900" indent="-342900">
+              <a:spcAft>
+                <a:spcPts val="800"/>
+              </a:spcAft>
+              <a:buSzPct val="100000"/>
+              <a:buFont typeface="+mj-lt"/>
+              <a:buAutoNum type="arabicPeriod" startAt="1"/>
+            </a:pPr>
+            <a:r>
+              <a:rPr lang="en-US" sz="4000" dirty="0">
+                <a:solidFill>
+                  <a:srgbClr val="111111"/>
+                </a:solidFill>
+                <a:latin typeface="Times New Roman" pitchFamily="34" charset="0"/>
+                <a:ea typeface="Times New Roman" pitchFamily="34" charset="-122"/>
+                <a:cs typeface="Times New Roman" pitchFamily="34" charset="-120"/>
+              </a:rPr>
+              <a:t>Evaluation, remediation and homework</a:t>
+            </a:r>
+            <a:endParaRPr lang="en-US" sz="4000" dirty="0"/>
+          </a:p>
+        </p:txBody>
+      </p:sp>
+      <p:sp>
+        <p:nvSpPr>
+          <p:cNvPr id="25" name="Slide Number Placeholder 0"/>
+          <p:cNvSpPr>
+            <a:spLocks noGrp="1"/>
+          </p:cNvSpPr>
+          <p:nvPr>
+            <p:ph type="sldNum" sz="quarter" idx="4294967295"/>
+          </p:nvPr>
+        </p:nvSpPr>
+        <p:spPr>
+          <a:xfrm>
+            <a:off x="27432" y="91440"/>
+            <a:ext cx="585216" cy="475488"/>
+          </a:xfrm>
+          <a:prstGeom prst="rect">
+            <a:avLst/>
+          </a:prstGeom>
+          <a:extLst>
+            <a:ext uri="{C572A759-6A51-4108-AA02-DFA0A04FC94B}">
+              <ma14:wrappingTextBoxFlag xmlns:ma14="http://schemas.microsoft.com/office/mac/drawingml/2011/main" val="0"/>
+            </a:ext>
+          </a:extLst>
+        </p:spPr>
+        <p:txBody>
+          <a:bodyPr/>
+          <a:lstStyle>
+            <a:lvl1pPr>
+              <a:defRPr sz="2000">
+                <a:solidFill>
+                  <a:srgbClr val="FFFFFF"/>
+                </a:solidFill>
+                <a:latin typeface="Calibri"/>
+                <a:ea typeface="Calibri"/>
+                <a:cs typeface="Calibri"/>
+              </a:defRPr>
+            </a:lvl1pPr>
+          </a:lstStyle>
+          <a:p>
+            <a:pPr algn="ctr"/>
+            <a:fld id="{F7021451-1387-4CA6-816F-3879F97B5CBC}" type="slidenum">
+              <a:rPr b="1" lang="en-US"/>
+              <a:t>6</a:t>
+            </a:fld>
+            <a:endParaRPr lang="en-US"/>
+          </a:p>
+        </p:txBody>
+      </p:sp>
+    </p:spTree>
+  </p:cSld>
+  <p:clrMapOvr>
+    <a:masterClrMapping/>
+  </p:clrMapOvr>
+</p:sld>
+</file>
+
+<file path=ppt/slides/slide60.xml><?xml version="1.0" encoding="utf-8"?>
+<p:sld xmlns:a="http://schemas.openxmlformats.org/drawingml/2006/main" xmlns:r="http://schemas.openxmlformats.org/officeDocument/2006/relationships" xmlns:p="http://schemas.openxmlformats.org/presentationml/2006/main">
+  <p:cSld name="Slide 60">
+    <p:spTree>
+      <p:nvGrpSpPr>
+        <p:cNvPr id="1" name=""/>
+        <p:cNvGrpSpPr/>
+        <p:nvPr/>
+      </p:nvGrpSpPr>
+      <p:grpSpPr>
+        <a:xfrm>
+          <a:off x="0" y="0"/>
+          <a:ext cx="0" cy="0"/>
+          <a:chOff x="0" y="0"/>
+          <a:chExt cx="0" cy="0"/>
+        </a:xfrm>
+      </p:grpSpPr>
+      <p:sp>
+        <p:nvSpPr>
+          <p:cNvPr id="2" name="Text 0"/>
+          <p:cNvSpPr/>
+          <p:nvPr/>
+        </p:nvSpPr>
+        <p:spPr>
+          <a:xfrm>
+            <a:off x="457200" y="713232"/>
+            <a:ext cx="11368735" cy="274320"/>
+          </a:xfrm>
+          <a:prstGeom prst="rect">
+            <a:avLst/>
+          </a:prstGeom>
+          <a:noFill/>
+          <a:ln/>
+        </p:spPr>
+        <p:txBody>
+          <a:bodyPr wrap="square" lIns="0" tIns="0" rIns="0" bIns="0" rtlCol="0" anchor="ctr"/>
+          <a:lstStyle/>
+          <a:p>
+            <a:pPr algn="r" indent="0" marL="0">
+              <a:buNone/>
+            </a:pPr>
+            <a:r>
+              <a:rPr lang="en-US" sz="1400" b="1" dirty="0">
+                <a:solidFill>
+                  <a:srgbClr val="1C3F6E"/>
+                </a:solidFill>
+                <a:latin typeface="Calibri" pitchFamily="34" charset="0"/>
+                <a:ea typeface="Calibri" pitchFamily="34" charset="-122"/>
+                <a:cs typeface="Calibri" pitchFamily="34" charset="-120"/>
+              </a:rPr>
+              <a:t>NEXT LESSON</a:t>
+            </a:r>
+            <a:endParaRPr lang="en-US" sz="1400" dirty="0"/>
+          </a:p>
+        </p:txBody>
+      </p:sp>
+      <p:pic>
+        <p:nvPicPr>
+          <p:cNvPr id="3" name="Image 0" descr="/home/claude/f4/img/minesec_sheet.png">    </p:cNvPr>
+          <p:cNvPicPr>
+            <a:picLocks noChangeAspect="1"/>
+          </p:cNvPicPr>
+          <p:nvPr/>
+        </p:nvPicPr>
+        <p:blipFill>
+          <a:blip r:embed="rId1"/>
+          <a:stretch>
+            <a:fillRect/>
+          </a:stretch>
+        </p:blipFill>
+        <p:spPr>
+          <a:xfrm>
+            <a:off x="0" y="658368"/>
+            <a:ext cx="5120640" cy="5833872"/>
+          </a:xfrm>
+          <a:prstGeom prst="rect">
+            <a:avLst/>
+          </a:prstGeom>
+        </p:spPr>
+      </p:pic>
+      <p:sp>
+        <p:nvSpPr>
+          <p:cNvPr id="4" name="Text 1"/>
+          <p:cNvSpPr/>
+          <p:nvPr/>
+        </p:nvSpPr>
+        <p:spPr>
+          <a:xfrm>
+            <a:off x="5349240" y="1005840"/>
+            <a:ext cx="6522415" cy="731520"/>
+          </a:xfrm>
+          <a:prstGeom prst="rect">
+            <a:avLst/>
+          </a:prstGeom>
+          <a:noFill/>
+          <a:ln/>
+        </p:spPr>
+        <p:txBody>
+          <a:bodyPr wrap="square" lIns="0" tIns="0" rIns="0" bIns="0" rtlCol="0" anchor="ctr">
+            <a:normAutofit/>
+          </a:bodyPr>
+          <a:lstStyle/>
+          <a:p>
+            <a:pPr algn="ctr" indent="0" marL="0">
+              <a:buNone/>
+            </a:pPr>
+            <a:r>
+              <a:rPr lang="en-US" sz="3600" b="1" dirty="0">
+                <a:solidFill>
+                  <a:srgbClr val="990011"/>
+                </a:solidFill>
+                <a:latin typeface="Times New Roman" pitchFamily="34" charset="0"/>
+                <a:ea typeface="Times New Roman" pitchFamily="34" charset="-122"/>
+                <a:cs typeface="Times New Roman" pitchFamily="34" charset="-120"/>
+              </a:rPr>
+              <a:t>Next Lesson</a:t>
+            </a:r>
+            <a:endParaRPr lang="en-US" sz="3600" dirty="0"/>
+          </a:p>
+        </p:txBody>
+      </p:sp>
+      <p:sp>
+        <p:nvSpPr>
+          <p:cNvPr id="5" name="Text 2"/>
+          <p:cNvSpPr/>
+          <p:nvPr/>
+        </p:nvSpPr>
+        <p:spPr>
+          <a:xfrm>
+            <a:off x="5349240" y="1783080"/>
+            <a:ext cx="6522415" cy="4663440"/>
+          </a:xfrm>
+          <a:prstGeom prst="rect">
+            <a:avLst/>
+          </a:prstGeom>
+          <a:noFill/>
+          <a:ln/>
+        </p:spPr>
+        <p:txBody>
+          <a:bodyPr wrap="square" lIns="0" tIns="0" rIns="0" bIns="0" rtlCol="0" anchor="ctr"/>
+          <a:lstStyle/>
+          <a:p>
+            <a:pPr algn="ctr" indent="0" marL="0">
+              <a:spcAft>
+                <a:spcPts val="800"/>
+              </a:spcAft>
+              <a:buNone/>
+            </a:pPr>
+            <a:r>
+              <a:rPr lang="en-US" sz="4000" b="1" dirty="0">
+                <a:solidFill>
+                  <a:srgbClr val="111111"/>
+                </a:solidFill>
+                <a:latin typeface="Times New Roman" pitchFamily="34" charset="0"/>
+                <a:ea typeface="Times New Roman" pitchFamily="34" charset="-122"/>
+                <a:cs typeface="Times New Roman" pitchFamily="34" charset="-120"/>
+              </a:rPr>
+              <a:t>Our next lesson will be on:</a:t>
+            </a:r>
+            <a:endParaRPr lang="en-US" sz="4000" dirty="0"/>
+          </a:p>
+          <a:p>
+            <a:pPr algn="ctr" indent="0" marL="0">
+              <a:spcAft>
+                <a:spcPts val="800"/>
+              </a:spcAft>
+              <a:buNone/>
+            </a:pPr>
+            <a:r>
+              <a:rPr lang="en-US" sz="4000" b="1" dirty="0">
+                <a:solidFill>
+                  <a:srgbClr val="990011"/>
+                </a:solidFill>
+                <a:latin typeface="Times New Roman" pitchFamily="34" charset="0"/>
+                <a:ea typeface="Times New Roman" pitchFamily="34" charset="-122"/>
+                <a:cs typeface="Times New Roman" pitchFamily="34" charset="-120"/>
+              </a:rPr>
+              <a:t>Quantitative Techniques 3 (Part 1): Measures of Central Tendency, Range and Quartiles</a:t>
+            </a:r>
+            <a:endParaRPr lang="en-US" sz="4000" dirty="0"/>
+          </a:p>
+        </p:txBody>
+      </p:sp>
+      <p:sp>
+        <p:nvSpPr>
+          <p:cNvPr id="25" name="Slide Number Placeholder 0"/>
+          <p:cNvSpPr>
+            <a:spLocks noGrp="1"/>
+          </p:cNvSpPr>
+          <p:nvPr>
+            <p:ph type="sldNum" sz="quarter" idx="4294967295"/>
+          </p:nvPr>
+        </p:nvSpPr>
+        <p:spPr>
+          <a:xfrm>
+            <a:off x="27432" y="91440"/>
+            <a:ext cx="585216" cy="475488"/>
+          </a:xfrm>
+          <a:prstGeom prst="rect">
+            <a:avLst/>
+          </a:prstGeom>
+          <a:extLst>
+            <a:ext uri="{C572A759-6A51-4108-AA02-DFA0A04FC94B}">
+              <ma14:wrappingTextBoxFlag xmlns:ma14="http://schemas.microsoft.com/office/mac/drawingml/2011/main" val="0"/>
+            </a:ext>
+          </a:extLst>
+        </p:spPr>
+        <p:txBody>
+          <a:bodyPr/>
+          <a:lstStyle>
+            <a:lvl1pPr>
+              <a:defRPr sz="2000">
+                <a:solidFill>
+                  <a:srgbClr val="FFFFFF"/>
+                </a:solidFill>
+                <a:latin typeface="Calibri"/>
+                <a:ea typeface="Calibri"/>
+                <a:cs typeface="Calibri"/>
+              </a:defRPr>
+            </a:lvl1pPr>
+          </a:lstStyle>
+          <a:p>
+            <a:pPr algn="ctr"/>
+            <a:fld id="{F7021451-1387-4CA6-816F-3879F97B5CBC}" type="slidenum">
+              <a:rPr b="1" lang="en-US"/>
+              <a:t>60</a:t>
+            </a:fld>
+            <a:endParaRPr lang="en-US"/>
+          </a:p>
+        </p:txBody>
+      </p:sp>
+    </p:spTree>
+  </p:cSld>
+  <p:clrMapOvr>
+    <a:masterClrMapping/>
+  </p:clrMapOvr>
+</p:sld>
+</file>
+
+<file path=ppt/slides/slide61.xml><?xml version="1.0" encoding="utf-8"?>
+<p:sld xmlns:a="http://schemas.openxmlformats.org/drawingml/2006/main" xmlns:r="http://schemas.openxmlformats.org/officeDocument/2006/relationships" xmlns:p="http://schemas.openxmlformats.org/presentationml/2006/main">
+  <p:cSld name="Slide 61">
+    <p:spTree>
+      <p:nvGrpSpPr>
+        <p:cNvPr id="1" name=""/>
+        <p:cNvGrpSpPr/>
+        <p:nvPr/>
+      </p:nvGrpSpPr>
+      <p:grpSpPr>
+        <a:xfrm>
+          <a:off x="0" y="0"/>
+          <a:ext cx="0" cy="0"/>
+          <a:chOff x="0" y="0"/>
+          <a:chExt cx="0" cy="0"/>
+        </a:xfrm>
+      </p:grpSpPr>
+      <p:sp>
+        <p:nvSpPr>
+          <p:cNvPr id="2" name="Text 0"/>
+          <p:cNvSpPr/>
+          <p:nvPr/>
+        </p:nvSpPr>
+        <p:spPr>
+          <a:xfrm>
+            <a:off x="457200" y="713232"/>
+            <a:ext cx="11368735" cy="274320"/>
+          </a:xfrm>
+          <a:prstGeom prst="rect">
+            <a:avLst/>
+          </a:prstGeom>
+          <a:noFill/>
+          <a:ln/>
+        </p:spPr>
+        <p:txBody>
+          <a:bodyPr wrap="square" lIns="0" tIns="0" rIns="0" bIns="0" rtlCol="0" anchor="ctr"/>
+          <a:lstStyle/>
+          <a:p>
+            <a:pPr algn="r" indent="0" marL="0">
+              <a:buNone/>
+            </a:pPr>
+            <a:r>
+              <a:rPr lang="en-US" sz="1400" b="1" dirty="0">
+                <a:solidFill>
+                  <a:srgbClr val="1C3F6E"/>
+                </a:solidFill>
+                <a:latin typeface="Calibri" pitchFamily="34" charset="0"/>
+                <a:ea typeface="Calibri" pitchFamily="34" charset="-122"/>
+                <a:cs typeface="Calibri" pitchFamily="34" charset="-120"/>
+              </a:rPr>
               <a:t>BILINGUAL GAME</a:t>
             </a:r>
             <a:endParaRPr lang="en-US" sz="1400" dirty="0"/>
@@ -20691,7 +22181,7 @@
       </p:sp>
       <p:graphicFrame>
         <p:nvGraphicFramePr>
-          <p:cNvPr id="59" name="Table 0"/>
+          <p:cNvPr id="62" name="Table 0"/>
           <p:cNvGraphicFramePr>
             <a:graphicFrameLocks noGrp="1"/>
           </p:cNvGraphicFramePr>
@@ -21727,7 +23217,7 @@
             <a:pPr algn="ctr"/>
             <a:fld id="{F7021451-1387-4CA6-816F-3879F97B5CBC}" type="slidenum">
               <a:rPr b="1" lang="en-US"/>
-              <a:t>58</a:t>
+              <a:t>61</a:t>
             </a:fld>
             <a:endParaRPr lang="en-US"/>
           </a:p>
@@ -21741,9 +23231,9 @@
 </p:sld>
 </file>
 
-<file path=ppt/slides/slide59.xml><?xml version="1.0" encoding="utf-8"?>
+<file path=ppt/slides/slide62.xml><?xml version="1.0" encoding="utf-8"?>
 <p:sld xmlns:a="http://schemas.openxmlformats.org/drawingml/2006/main" xmlns:r="http://schemas.openxmlformats.org/officeDocument/2006/relationships" xmlns:p="http://schemas.openxmlformats.org/presentationml/2006/main">
-  <p:cSld name="Slide 59">
+  <p:cSld name="Slide 62">
     <p:spTree>
       <p:nvGrpSpPr>
         <p:cNvPr id="1" name=""/>
@@ -21838,7 +23328,7 @@
       </p:sp>
       <p:graphicFrame>
         <p:nvGraphicFramePr>
-          <p:cNvPr id="60" name="Table 0"/>
+          <p:cNvPr id="63" name="Table 0"/>
           <p:cNvGraphicFramePr>
             <a:graphicFrameLocks noGrp="1"/>
           </p:cNvGraphicFramePr>
@@ -22460,7 +23950,7 @@
             <a:pPr algn="ctr"/>
             <a:fld id="{F7021451-1387-4CA6-816F-3879F97B5CBC}" type="slidenum">
               <a:rPr b="1" lang="en-US"/>
-              <a:t>59</a:t>
+              <a:t>62</a:t>
             </a:fld>
             <a:endParaRPr lang="en-US"/>
           </a:p>
@@ -22474,9 +23964,9 @@
 </p:sld>
 </file>
 
-<file path=ppt/slides/slide6.xml><?xml version="1.0" encoding="utf-8"?>
+<file path=ppt/slides/slide63.xml><?xml version="1.0" encoding="utf-8"?>
 <p:sld xmlns:a="http://schemas.openxmlformats.org/drawingml/2006/main" xmlns:r="http://schemas.openxmlformats.org/officeDocument/2006/relationships" xmlns:p="http://schemas.openxmlformats.org/presentationml/2006/main">
-  <p:cSld name="Slide 6">
+  <p:cSld name="Slide 63">
     <p:spTree>
       <p:nvGrpSpPr>
         <p:cNvPr id="1" name=""/>
@@ -22524,337 +24014,6 @@
                 <a:ea typeface="Calibri" pitchFamily="34" charset="-122"/>
                 <a:cs typeface="Calibri" pitchFamily="34" charset="-120"/>
               </a:rPr>
-              <a:t>LESSON PLAN</a:t>
-            </a:r>
-            <a:endParaRPr lang="en-US" sz="1400" dirty="0"/>
-          </a:p>
-        </p:txBody>
-      </p:sp>
-      <p:pic>
-        <p:nvPicPr>
-          <p:cNvPr id="3" name="Image 0" descr="/home/claude/f4/img/minesec_sheet.png">    </p:cNvPr>
-          <p:cNvPicPr>
-            <a:picLocks noChangeAspect="1"/>
-          </p:cNvPicPr>
-          <p:nvPr/>
-        </p:nvPicPr>
-        <p:blipFill>
-          <a:blip r:embed="rId1"/>
-          <a:stretch>
-            <a:fillRect/>
-          </a:stretch>
-        </p:blipFill>
-        <p:spPr>
-          <a:xfrm>
-            <a:off x="0" y="658368"/>
-            <a:ext cx="2468880" cy="5833872"/>
-          </a:xfrm>
-          <a:prstGeom prst="rect">
-            <a:avLst/>
-          </a:prstGeom>
-        </p:spPr>
-      </p:pic>
-      <p:sp>
-        <p:nvSpPr>
-          <p:cNvPr id="4" name="Text 1"/>
-          <p:cNvSpPr/>
-          <p:nvPr/>
-        </p:nvSpPr>
-        <p:spPr>
-          <a:xfrm>
-            <a:off x="2697480" y="1005840"/>
-            <a:ext cx="9174175" cy="731520"/>
-          </a:xfrm>
-          <a:prstGeom prst="rect">
-            <a:avLst/>
-          </a:prstGeom>
-          <a:noFill/>
-          <a:ln/>
-        </p:spPr>
-        <p:txBody>
-          <a:bodyPr wrap="square" lIns="0" tIns="0" rIns="0" bIns="0" rtlCol="0" anchor="ctr">
-            <a:normAutofit/>
-          </a:bodyPr>
-          <a:lstStyle/>
-          <a:p>
-            <a:pPr algn="ctr" indent="0" marL="0">
-              <a:buNone/>
-            </a:pPr>
-            <a:r>
-              <a:rPr lang="en-US" sz="3600" b="1" dirty="0">
-                <a:solidFill>
-                  <a:srgbClr val="990011"/>
-                </a:solidFill>
-                <a:latin typeface="Times New Roman" pitchFamily="34" charset="0"/>
-                <a:ea typeface="Times New Roman" pitchFamily="34" charset="-122"/>
-                <a:cs typeface="Times New Roman" pitchFamily="34" charset="-120"/>
-              </a:rPr>
-              <a:t>Lesson Plan</a:t>
-            </a:r>
-            <a:endParaRPr lang="en-US" sz="3600" dirty="0"/>
-          </a:p>
-        </p:txBody>
-      </p:sp>
-      <p:sp>
-        <p:nvSpPr>
-          <p:cNvPr id="5" name="Text 2"/>
-          <p:cNvSpPr/>
-          <p:nvPr/>
-        </p:nvSpPr>
-        <p:spPr>
-          <a:xfrm>
-            <a:off x="2697480" y="1783080"/>
-            <a:ext cx="9174175" cy="4663440"/>
-          </a:xfrm>
-          <a:prstGeom prst="rect">
-            <a:avLst/>
-          </a:prstGeom>
-          <a:noFill/>
-          <a:ln/>
-        </p:spPr>
-        <p:txBody>
-          <a:bodyPr wrap="square" lIns="0" tIns="0" rIns="0" bIns="0" rtlCol="0" anchor="t"/>
-          <a:lstStyle/>
-          <a:p>
-            <a:pPr algn="l" marL="342900" indent="-342900">
-              <a:spcAft>
-                <a:spcPts val="800"/>
-              </a:spcAft>
-              <a:buSzPct val="100000"/>
-              <a:buFont typeface="+mj-lt"/>
-              <a:buAutoNum type="arabicPeriod" startAt="1"/>
-            </a:pPr>
-            <a:r>
-              <a:rPr lang="en-US" sz="4000" dirty="0">
-                <a:solidFill>
-                  <a:srgbClr val="111111"/>
-                </a:solidFill>
-                <a:latin typeface="Times New Roman" pitchFamily="34" charset="0"/>
-                <a:ea typeface="Times New Roman" pitchFamily="34" charset="-122"/>
-                <a:cs typeface="Times New Roman" pitchFamily="34" charset="-120"/>
-              </a:rPr>
-              <a:t>Correction of the homework</a:t>
-            </a:r>
-            <a:endParaRPr lang="en-US" sz="4000" dirty="0"/>
-          </a:p>
-          <a:p>
-            <a:pPr algn="l" marL="342900" indent="-342900">
-              <a:spcAft>
-                <a:spcPts val="800"/>
-              </a:spcAft>
-              <a:buSzPct val="100000"/>
-              <a:buFont typeface="+mj-lt"/>
-              <a:buAutoNum type="arabicPeriod" startAt="1"/>
-            </a:pPr>
-            <a:r>
-              <a:rPr lang="en-US" sz="4000" dirty="0">
-                <a:solidFill>
-                  <a:srgbClr val="111111"/>
-                </a:solidFill>
-                <a:latin typeface="Times New Roman" pitchFamily="34" charset="0"/>
-                <a:ea typeface="Times New Roman" pitchFamily="34" charset="-122"/>
-                <a:cs typeface="Times New Roman" pitchFamily="34" charset="-120"/>
-              </a:rPr>
-              <a:t>Objectives and recall</a:t>
-            </a:r>
-            <a:endParaRPr lang="en-US" sz="4000" dirty="0"/>
-          </a:p>
-          <a:p>
-            <a:pPr algn="l" marL="342900" indent="-342900">
-              <a:spcAft>
-                <a:spcPts val="800"/>
-              </a:spcAft>
-              <a:buSzPct val="100000"/>
-              <a:buFont typeface="+mj-lt"/>
-              <a:buAutoNum type="arabicPeriod" startAt="1"/>
-            </a:pPr>
-            <a:r>
-              <a:rPr lang="en-US" sz="4000" dirty="0">
-                <a:solidFill>
-                  <a:srgbClr val="111111"/>
-                </a:solidFill>
-                <a:latin typeface="Times New Roman" pitchFamily="34" charset="0"/>
-                <a:ea typeface="Times New Roman" pitchFamily="34" charset="-122"/>
-                <a:cs typeface="Times New Roman" pitchFamily="34" charset="-120"/>
-              </a:rPr>
-              <a:t>Real-life situation and action to take</a:t>
-            </a:r>
-            <a:endParaRPr lang="en-US" sz="4000" dirty="0"/>
-          </a:p>
-          <a:p>
-            <a:pPr algn="l" marL="342900" indent="-342900">
-              <a:spcAft>
-                <a:spcPts val="800"/>
-              </a:spcAft>
-              <a:buSzPct val="100000"/>
-              <a:buFont typeface="+mj-lt"/>
-              <a:buAutoNum type="arabicPeriod" startAt="1"/>
-            </a:pPr>
-            <a:r>
-              <a:rPr lang="en-US" sz="4000" dirty="0">
-                <a:solidFill>
-                  <a:srgbClr val="111111"/>
-                </a:solidFill>
-                <a:latin typeface="Times New Roman" pitchFamily="34" charset="0"/>
-                <a:ea typeface="Times New Roman" pitchFamily="34" charset="-122"/>
-                <a:cs typeface="Times New Roman" pitchFamily="34" charset="-120"/>
-              </a:rPr>
-              <a:t>Learning activities</a:t>
-            </a:r>
-            <a:endParaRPr lang="en-US" sz="4000" dirty="0"/>
-          </a:p>
-          <a:p>
-            <a:pPr algn="l" marL="342900" indent="-342900">
-              <a:spcAft>
-                <a:spcPts val="800"/>
-              </a:spcAft>
-              <a:buSzPct val="100000"/>
-              <a:buFont typeface="+mj-lt"/>
-              <a:buAutoNum type="arabicPeriod" startAt="1"/>
-            </a:pPr>
-            <a:r>
-              <a:rPr lang="en-US" sz="4000" dirty="0">
-                <a:solidFill>
-                  <a:srgbClr val="111111"/>
-                </a:solidFill>
-                <a:latin typeface="Times New Roman" pitchFamily="34" charset="0"/>
-                <a:ea typeface="Times New Roman" pitchFamily="34" charset="-122"/>
-                <a:cs typeface="Times New Roman" pitchFamily="34" charset="-120"/>
-              </a:rPr>
-              <a:t>Board summary</a:t>
-            </a:r>
-            <a:endParaRPr lang="en-US" sz="4000" dirty="0"/>
-          </a:p>
-          <a:p>
-            <a:pPr algn="l" marL="342900" indent="-342900">
-              <a:spcAft>
-                <a:spcPts val="800"/>
-              </a:spcAft>
-              <a:buSzPct val="100000"/>
-              <a:buFont typeface="+mj-lt"/>
-              <a:buAutoNum type="arabicPeriod" startAt="1"/>
-            </a:pPr>
-            <a:r>
-              <a:rPr lang="en-US" sz="4000" dirty="0">
-                <a:solidFill>
-                  <a:srgbClr val="111111"/>
-                </a:solidFill>
-                <a:latin typeface="Times New Roman" pitchFamily="34" charset="0"/>
-                <a:ea typeface="Times New Roman" pitchFamily="34" charset="-122"/>
-                <a:cs typeface="Times New Roman" pitchFamily="34" charset="-120"/>
-              </a:rPr>
-              <a:t>Evaluation, remediation and homework</a:t>
-            </a:r>
-            <a:endParaRPr lang="en-US" sz="4000" dirty="0"/>
-          </a:p>
-        </p:txBody>
-      </p:sp>
-      <p:sp>
-        <p:nvSpPr>
-          <p:cNvPr id="25" name="Slide Number Placeholder 0"/>
-          <p:cNvSpPr>
-            <a:spLocks noGrp="1"/>
-          </p:cNvSpPr>
-          <p:nvPr>
-            <p:ph type="sldNum" sz="quarter" idx="4294967295"/>
-          </p:nvPr>
-        </p:nvSpPr>
-        <p:spPr>
-          <a:xfrm>
-            <a:off x="27432" y="91440"/>
-            <a:ext cx="585216" cy="475488"/>
-          </a:xfrm>
-          <a:prstGeom prst="rect">
-            <a:avLst/>
-          </a:prstGeom>
-          <a:extLst>
-            <a:ext uri="{C572A759-6A51-4108-AA02-DFA0A04FC94B}">
-              <ma14:wrappingTextBoxFlag xmlns:ma14="http://schemas.microsoft.com/office/mac/drawingml/2011/main" val="0"/>
-            </a:ext>
-          </a:extLst>
-        </p:spPr>
-        <p:txBody>
-          <a:bodyPr/>
-          <a:lstStyle>
-            <a:lvl1pPr>
-              <a:defRPr sz="2000">
-                <a:solidFill>
-                  <a:srgbClr val="FFFFFF"/>
-                </a:solidFill>
-                <a:latin typeface="Calibri"/>
-                <a:ea typeface="Calibri"/>
-                <a:cs typeface="Calibri"/>
-              </a:defRPr>
-            </a:lvl1pPr>
-          </a:lstStyle>
-          <a:p>
-            <a:pPr algn="ctr"/>
-            <a:fld id="{F7021451-1387-4CA6-816F-3879F97B5CBC}" type="slidenum">
-              <a:rPr b="1" lang="en-US"/>
-              <a:t>6</a:t>
-            </a:fld>
-            <a:endParaRPr lang="en-US"/>
-          </a:p>
-        </p:txBody>
-      </p:sp>
-    </p:spTree>
-  </p:cSld>
-  <p:clrMapOvr>
-    <a:masterClrMapping/>
-  </p:clrMapOvr>
-</p:sld>
-</file>
-
-<file path=ppt/slides/slide60.xml><?xml version="1.0" encoding="utf-8"?>
-<p:sld xmlns:a="http://schemas.openxmlformats.org/drawingml/2006/main" xmlns:r="http://schemas.openxmlformats.org/officeDocument/2006/relationships" xmlns:p="http://schemas.openxmlformats.org/presentationml/2006/main">
-  <p:cSld name="Slide 60">
-    <p:spTree>
-      <p:nvGrpSpPr>
-        <p:cNvPr id="1" name=""/>
-        <p:cNvGrpSpPr/>
-        <p:nvPr/>
-      </p:nvGrpSpPr>
-      <p:grpSpPr>
-        <a:xfrm>
-          <a:off x="0" y="0"/>
-          <a:ext cx="0" cy="0"/>
-          <a:chOff x="0" y="0"/>
-          <a:chExt cx="0" cy="0"/>
-        </a:xfrm>
-      </p:grpSpPr>
-      <p:sp>
-        <p:nvSpPr>
-          <p:cNvPr id="2" name="Text 0"/>
-          <p:cNvSpPr/>
-          <p:nvPr/>
-        </p:nvSpPr>
-        <p:spPr>
-          <a:xfrm>
-            <a:off x="457200" y="713232"/>
-            <a:ext cx="11368735" cy="274320"/>
-          </a:xfrm>
-          <a:prstGeom prst="rect">
-            <a:avLst/>
-          </a:prstGeom>
-          <a:noFill/>
-          <a:ln/>
-        </p:spPr>
-        <p:txBody>
-          <a:bodyPr wrap="square" lIns="0" tIns="0" rIns="0" bIns="0" rtlCol="0" anchor="ctr"/>
-          <a:lstStyle/>
-          <a:p>
-            <a:pPr algn="r" indent="0" marL="0">
-              <a:buNone/>
-            </a:pPr>
-            <a:r>
-              <a:rPr lang="en-US" sz="1400" b="1" dirty="0">
-                <a:solidFill>
-                  <a:srgbClr val="1C3F6E"/>
-                </a:solidFill>
-                <a:latin typeface="Calibri" pitchFamily="34" charset="0"/>
-                <a:ea typeface="Calibri" pitchFamily="34" charset="-122"/>
-                <a:cs typeface="Calibri" pitchFamily="34" charset="-120"/>
-              </a:rPr>
               <a:t>LOGBOOK</a:t>
             </a:r>
             <a:endParaRPr lang="en-US" sz="1400" dirty="0"/>
@@ -22902,7 +24061,7 @@
       </p:sp>
       <p:graphicFrame>
         <p:nvGraphicFramePr>
-          <p:cNvPr id="61" name="Table 0"/>
+          <p:cNvPr id="64" name="Table 0"/>
           <p:cNvGraphicFramePr>
             <a:graphicFrameLocks noGrp="1"/>
           </p:cNvGraphicFramePr>
@@ -23012,7 +24171,7 @@
                           <a:ea typeface="Calibri" pitchFamily="34" charset="-122"/>
                           <a:cs typeface="Calibri" pitchFamily="34" charset="-120"/>
                         </a:rPr>
-                        <a:t>DEFINITIONS; Sources of Geographical Data; Basic Sampling Procedures; Primary Data Collection Techniques.</a:t>
+                        <a:t>DEFINITIONS; Sources of Geographical Data; Basic Sampling Procedures; Observation, Recording and Measurement; Questionnaires, Interviews and Focus Groups.</a:t>
                       </a:r>
                       <a:endParaRPr lang="en-US" sz="1600" dirty="0">
                         <a:latin typeface="Calibri" charset="0"/>
@@ -23662,7 +24821,7 @@
             <a:pPr algn="ctr"/>
             <a:fld id="{F7021451-1387-4CA6-816F-3879F97B5CBC}" type="slidenum">
               <a:rPr b="1" lang="en-US"/>
-              <a:t>60</a:t>
+              <a:t>63</a:t>
             </a:fld>
             <a:endParaRPr lang="en-US"/>
           </a:p>
@@ -23676,9 +24835,9 @@
 </p:sld>
 </file>
 
-<file path=ppt/slides/slide61.xml><?xml version="1.0" encoding="utf-8"?>
+<file path=ppt/slides/slide64.xml><?xml version="1.0" encoding="utf-8"?>
 <p:sld xmlns:a="http://schemas.openxmlformats.org/drawingml/2006/main" xmlns:r="http://schemas.openxmlformats.org/officeDocument/2006/relationships" xmlns:p="http://schemas.openxmlformats.org/presentationml/2006/main">
-  <p:cSld name="Slide 61">
+  <p:cSld name="Slide 64">
     <p:spTree>
       <p:nvGrpSpPr>
         <p:cNvPr id="1" name=""/>
@@ -23987,7 +25146,7 @@
             <a:pPr algn="ctr"/>
             <a:fld id="{F7021451-1387-4CA6-816F-3879F97B5CBC}" type="slidenum">
               <a:rPr b="1" lang="en-US"/>
-              <a:t>61</a:t>
+              <a:t>64</a:t>
             </a:fld>
             <a:endParaRPr lang="en-US"/>
           </a:p>
@@ -24001,9 +25160,9 @@
 </p:sld>
 </file>
 
-<file path=ppt/slides/slide62.xml><?xml version="1.0" encoding="utf-8"?>
+<file path=ppt/slides/slide65.xml><?xml version="1.0" encoding="utf-8"?>
 <p:sld xmlns:a="http://schemas.openxmlformats.org/drawingml/2006/main" xmlns:r="http://schemas.openxmlformats.org/officeDocument/2006/relationships" xmlns:p="http://schemas.openxmlformats.org/presentationml/2006/main">
-  <p:cSld name="Slide 62">
+  <p:cSld name="Slide 65">
     <p:spTree>
       <p:nvGrpSpPr>
         <p:cNvPr id="1" name=""/>
@@ -24249,7 +25408,7 @@
             <a:pPr algn="ctr"/>
             <a:fld id="{F7021451-1387-4CA6-816F-3879F97B5CBC}" type="slidenum">
               <a:rPr b="1" lang="en-US"/>
-              <a:t>62</a:t>
+              <a:t>65</a:t>
             </a:fld>
             <a:endParaRPr lang="en-US"/>
           </a:p>

</xml_diff>